<commit_message>
Enhance text contrast to pure crisp white and clean title slide
</commit_message>
<xml_diff>
--- a/Coal_GCV_Prediction_Presentation.pptx
+++ b/Coal_GCV_Prediction_Presentation.pptx
@@ -6,16 +6,16 @@
   </p:sldMasterIdLst>
   <p:sldIdLst>
     <p:sldId id="256" r:id="rId7"/>
-    <p:sldId id="257" r:id="rId9"/>
-    <p:sldId id="258" r:id="rId10"/>
-    <p:sldId id="259" r:id="rId11"/>
-    <p:sldId id="260" r:id="rId12"/>
-    <p:sldId id="261" r:id="rId13"/>
-    <p:sldId id="262" r:id="rId14"/>
-    <p:sldId id="263" r:id="rId15"/>
-    <p:sldId id="264" r:id="rId16"/>
-    <p:sldId id="265" r:id="rId17"/>
-    <p:sldId id="266" r:id="rId18"/>
+    <p:sldId id="257" r:id="rId8"/>
+    <p:sldId id="258" r:id="rId9"/>
+    <p:sldId id="259" r:id="rId10"/>
+    <p:sldId id="260" r:id="rId11"/>
+    <p:sldId id="261" r:id="rId12"/>
+    <p:sldId id="262" r:id="rId13"/>
+    <p:sldId id="263" r:id="rId14"/>
+    <p:sldId id="264" r:id="rId15"/>
+    <p:sldId id="265" r:id="rId16"/>
+    <p:sldId id="266" r:id="rId17"/>
   </p:sldIdLst>
   <p:sldSz cx="12191695" cy="6858000" type="screen4x3"/>
   <p:notesSz cx="6858000" cy="9144000"/>
@@ -115,1126 +115,6 @@
     </a:lvl9pPr>
   </p:defaultTextStyle>
 </p:presentation>
-</file>
-
-<file path=ppt/notesMasters/notesMaster1.xml><?xml version="1.0" encoding="utf-8"?>
-<p:notesMaster xmlns:a="http://schemas.openxmlformats.org/drawingml/2006/main" xmlns:p="http://schemas.openxmlformats.org/presentationml/2006/main" xmlns:r="http://schemas.openxmlformats.org/officeDocument/2006/relationships">
-  <p:cSld>
-    <p:bg>
-      <p:bgRef idx="1001">
-        <a:schemeClr val="bg1"/>
-      </p:bgRef>
-    </p:bg>
-    <p:spTree>
-      <p:nvGrpSpPr>
-        <p:cNvPr id="1" name=""/>
-        <p:cNvGrpSpPr/>
-        <p:nvPr/>
-      </p:nvGrpSpPr>
-      <p:grpSpPr>
-        <a:xfrm>
-          <a:off x="0" y="0"/>
-          <a:ext cx="0" cy="0"/>
-          <a:chOff x="0" y="0"/>
-          <a:chExt cx="0" cy="0"/>
-        </a:xfrm>
-      </p:grpSpPr>
-      <p:sp>
-        <p:nvSpPr>
-          <p:cNvPr id="2" name="Header Placeholder 1"/>
-          <p:cNvSpPr>
-            <a:spLocks noGrp="1"/>
-          </p:cNvSpPr>
-          <p:nvPr>
-            <p:ph type="hdr" sz="quarter"/>
-          </p:nvPr>
-        </p:nvSpPr>
-        <p:spPr>
-          <a:xfrm>
-            <a:off x="0" y="0"/>
-            <a:ext cx="2971800" cy="457200"/>
-          </a:xfrm>
-          <a:prstGeom prst="rect">
-            <a:avLst/>
-          </a:prstGeom>
-        </p:spPr>
-        <p:txBody>
-          <a:bodyPr vert="horz" lIns="91440" tIns="45720" rIns="91440" bIns="45720" rtlCol="0"/>
-          <a:lstStyle>
-            <a:lvl1pPr algn="l">
-              <a:defRPr sz="1200"/>
-            </a:lvl1pPr>
-          </a:lstStyle>
-          <a:p>
-            <a:endParaRPr lang="en-US"/>
-          </a:p>
-        </p:txBody>
-      </p:sp>
-      <p:sp>
-        <p:nvSpPr>
-          <p:cNvPr id="3" name="Date Placeholder 2"/>
-          <p:cNvSpPr>
-            <a:spLocks noGrp="1"/>
-          </p:cNvSpPr>
-          <p:nvPr>
-            <p:ph type="dt" idx="1"/>
-          </p:nvPr>
-        </p:nvSpPr>
-        <p:spPr>
-          <a:xfrm>
-            <a:off x="3884613" y="0"/>
-            <a:ext cx="2971800" cy="457200"/>
-          </a:xfrm>
-          <a:prstGeom prst="rect">
-            <a:avLst/>
-          </a:prstGeom>
-        </p:spPr>
-        <p:txBody>
-          <a:bodyPr vert="horz" lIns="91440" tIns="45720" rIns="91440" bIns="45720" rtlCol="0"/>
-          <a:lstStyle>
-            <a:lvl1pPr algn="r">
-              <a:defRPr sz="1200"/>
-            </a:lvl1pPr>
-          </a:lstStyle>
-          <a:p>
-            <a:fld id="{0F89C1C7-3DCD-1040-A9CF-14679D8B5DDD}" type="datetimeFigureOut">
-              <a:rPr lang="en-US" smtClean="0"/>
-              <a:t>10/17/16</a:t>
-            </a:fld>
-            <a:endParaRPr lang="en-US"/>
-          </a:p>
-        </p:txBody>
-      </p:sp>
-      <p:sp>
-        <p:nvSpPr>
-          <p:cNvPr id="4" name="Slide Image Placeholder 3"/>
-          <p:cNvSpPr>
-            <a:spLocks noGrp="1" noRot="1" noChangeAspect="1"/>
-          </p:cNvSpPr>
-          <p:nvPr>
-            <p:ph type="sldImg" idx="2"/>
-          </p:nvPr>
-        </p:nvSpPr>
-        <p:spPr>
-          <a:xfrm>
-            <a:off x="1143000" y="685800"/>
-            <a:ext cx="4572000" cy="3429000"/>
-          </a:xfrm>
-          <a:prstGeom prst="rect">
-            <a:avLst/>
-          </a:prstGeom>
-          <a:noFill/>
-          <a:ln w="12700">
-            <a:solidFill>
-              <a:prstClr val="black"/>
-            </a:solidFill>
-          </a:ln>
-        </p:spPr>
-        <p:txBody>
-          <a:bodyPr vert="horz" lIns="91440" tIns="45720" rIns="91440" bIns="45720" rtlCol="0" anchor="ctr"/>
-          <a:lstStyle/>
-          <a:p>
-            <a:endParaRPr lang="en-US"/>
-          </a:p>
-        </p:txBody>
-      </p:sp>
-      <p:sp>
-        <p:nvSpPr>
-          <p:cNvPr id="5" name="Notes Placeholder 4"/>
-          <p:cNvSpPr>
-            <a:spLocks noGrp="1"/>
-          </p:cNvSpPr>
-          <p:nvPr>
-            <p:ph type="body" sz="quarter" idx="3"/>
-          </p:nvPr>
-        </p:nvSpPr>
-        <p:spPr>
-          <a:xfrm>
-            <a:off x="685800" y="4343400"/>
-            <a:ext cx="5486400" cy="4114800"/>
-          </a:xfrm>
-          <a:prstGeom prst="rect">
-            <a:avLst/>
-          </a:prstGeom>
-        </p:spPr>
-        <p:txBody>
-          <a:bodyPr vert="horz" lIns="91440" tIns="45720" rIns="91440" bIns="45720" rtlCol="0"/>
-          <a:lstStyle/>
-          <a:p>
-            <a:pPr lvl="0"/>
-            <a:r>
-              <a:rPr lang="en-US" smtClean="0"/>
-              <a:t>Click to edit Master text styles</a:t>
-            </a:r>
-          </a:p>
-          <a:p>
-            <a:pPr lvl="1"/>
-            <a:r>
-              <a:rPr lang="en-US" smtClean="0"/>
-              <a:t>Second level</a:t>
-            </a:r>
-          </a:p>
-          <a:p>
-            <a:pPr lvl="2"/>
-            <a:r>
-              <a:rPr lang="en-US" smtClean="0"/>
-              <a:t>Third level</a:t>
-            </a:r>
-          </a:p>
-          <a:p>
-            <a:pPr lvl="3"/>
-            <a:r>
-              <a:rPr lang="en-US" smtClean="0"/>
-              <a:t>Fourth level</a:t>
-            </a:r>
-          </a:p>
-          <a:p>
-            <a:pPr lvl="4"/>
-            <a:r>
-              <a:rPr lang="en-US" smtClean="0"/>
-              <a:t>Fifth level</a:t>
-            </a:r>
-            <a:endParaRPr lang="en-US"/>
-          </a:p>
-        </p:txBody>
-      </p:sp>
-      <p:sp>
-        <p:nvSpPr>
-          <p:cNvPr id="6" name="Footer Placeholder 5"/>
-          <p:cNvSpPr>
-            <a:spLocks noGrp="1"/>
-          </p:cNvSpPr>
-          <p:nvPr>
-            <p:ph type="ftr" sz="quarter" idx="4"/>
-          </p:nvPr>
-        </p:nvSpPr>
-        <p:spPr>
-          <a:xfrm>
-            <a:off x="0" y="8685213"/>
-            <a:ext cx="2971800" cy="457200"/>
-          </a:xfrm>
-          <a:prstGeom prst="rect">
-            <a:avLst/>
-          </a:prstGeom>
-        </p:spPr>
-        <p:txBody>
-          <a:bodyPr vert="horz" lIns="91440" tIns="45720" rIns="91440" bIns="45720" rtlCol="0" anchor="b"/>
-          <a:lstStyle>
-            <a:lvl1pPr algn="l">
-              <a:defRPr sz="1200"/>
-            </a:lvl1pPr>
-          </a:lstStyle>
-          <a:p>
-            <a:endParaRPr lang="en-US"/>
-          </a:p>
-        </p:txBody>
-      </p:sp>
-      <p:sp>
-        <p:nvSpPr>
-          <p:cNvPr id="7" name="Slide Number Placeholder 6"/>
-          <p:cNvSpPr>
-            <a:spLocks noGrp="1"/>
-          </p:cNvSpPr>
-          <p:nvPr>
-            <p:ph type="sldNum" sz="quarter" idx="5"/>
-          </p:nvPr>
-        </p:nvSpPr>
-        <p:spPr>
-          <a:xfrm>
-            <a:off x="3884613" y="8685213"/>
-            <a:ext cx="2971800" cy="457200"/>
-          </a:xfrm>
-          <a:prstGeom prst="rect">
-            <a:avLst/>
-          </a:prstGeom>
-        </p:spPr>
-        <p:txBody>
-          <a:bodyPr vert="horz" lIns="91440" tIns="45720" rIns="91440" bIns="45720" rtlCol="0" anchor="b"/>
-          <a:lstStyle>
-            <a:lvl1pPr algn="r">
-              <a:defRPr sz="1200"/>
-            </a:lvl1pPr>
-          </a:lstStyle>
-          <a:p>
-            <a:fld id="{BB5E49A5-4136-284D-997B-48E1D791AD67}" type="slidenum">
-              <a:rPr lang="en-US" smtClean="0"/>
-              <a:t>‹#›</a:t>
-            </a:fld>
-            <a:endParaRPr lang="en-US"/>
-          </a:p>
-        </p:txBody>
-      </p:sp>
-    </p:spTree>
-    <p:extLst>
-      <p:ext uri="{BB962C8B-B14F-4D97-AF65-F5344CB8AC3E}">
-        <p14:creationId xmlns:p14="http://schemas.microsoft.com/office/powerpoint/2010/main" val="2623252185"/>
-      </p:ext>
-    </p:extLst>
-  </p:cSld>
-  <p:clrMap bg1="lt1" tx1="dk1" bg2="lt2" tx2="dk2" accent1="accent1" accent2="accent2" accent3="accent3" accent4="accent4" accent5="accent5" accent6="accent6" hlink="hlink" folHlink="folHlink"/>
-  <p:notesStyle>
-    <a:lvl1pPr marL="0" algn="l" defTabSz="457200" rtl="0" eaLnBrk="1" latinLnBrk="0" hangingPunct="1">
-      <a:defRPr sz="1200" kern="1200">
-        <a:solidFill>
-          <a:schemeClr val="tx1"/>
-        </a:solidFill>
-        <a:latin typeface="+mn-lt"/>
-        <a:ea typeface="+mn-ea"/>
-        <a:cs typeface="+mn-cs"/>
-      </a:defRPr>
-    </a:lvl1pPr>
-    <a:lvl2pPr marL="457200" algn="l" defTabSz="457200" rtl="0" eaLnBrk="1" latinLnBrk="0" hangingPunct="1">
-      <a:defRPr sz="1200" kern="1200">
-        <a:solidFill>
-          <a:schemeClr val="tx1"/>
-        </a:solidFill>
-        <a:latin typeface="+mn-lt"/>
-        <a:ea typeface="+mn-ea"/>
-        <a:cs typeface="+mn-cs"/>
-      </a:defRPr>
-    </a:lvl2pPr>
-    <a:lvl3pPr marL="914400" algn="l" defTabSz="457200" rtl="0" eaLnBrk="1" latinLnBrk="0" hangingPunct="1">
-      <a:defRPr sz="1200" kern="1200">
-        <a:solidFill>
-          <a:schemeClr val="tx1"/>
-        </a:solidFill>
-        <a:latin typeface="+mn-lt"/>
-        <a:ea typeface="+mn-ea"/>
-        <a:cs typeface="+mn-cs"/>
-      </a:defRPr>
-    </a:lvl3pPr>
-    <a:lvl4pPr marL="1371600" algn="l" defTabSz="457200" rtl="0" eaLnBrk="1" latinLnBrk="0" hangingPunct="1">
-      <a:defRPr sz="1200" kern="1200">
-        <a:solidFill>
-          <a:schemeClr val="tx1"/>
-        </a:solidFill>
-        <a:latin typeface="+mn-lt"/>
-        <a:ea typeface="+mn-ea"/>
-        <a:cs typeface="+mn-cs"/>
-      </a:defRPr>
-    </a:lvl4pPr>
-    <a:lvl5pPr marL="1828800" algn="l" defTabSz="457200" rtl="0" eaLnBrk="1" latinLnBrk="0" hangingPunct="1">
-      <a:defRPr sz="1200" kern="1200">
-        <a:solidFill>
-          <a:schemeClr val="tx1"/>
-        </a:solidFill>
-        <a:latin typeface="+mn-lt"/>
-        <a:ea typeface="+mn-ea"/>
-        <a:cs typeface="+mn-cs"/>
-      </a:defRPr>
-    </a:lvl5pPr>
-    <a:lvl6pPr marL="2286000" algn="l" defTabSz="457200" rtl="0" eaLnBrk="1" latinLnBrk="0" hangingPunct="1">
-      <a:defRPr sz="1200" kern="1200">
-        <a:solidFill>
-          <a:schemeClr val="tx1"/>
-        </a:solidFill>
-        <a:latin typeface="+mn-lt"/>
-        <a:ea typeface="+mn-ea"/>
-        <a:cs typeface="+mn-cs"/>
-      </a:defRPr>
-    </a:lvl6pPr>
-    <a:lvl7pPr marL="2743200" algn="l" defTabSz="457200" rtl="0" eaLnBrk="1" latinLnBrk="0" hangingPunct="1">
-      <a:defRPr sz="1200" kern="1200">
-        <a:solidFill>
-          <a:schemeClr val="tx1"/>
-        </a:solidFill>
-        <a:latin typeface="+mn-lt"/>
-        <a:ea typeface="+mn-ea"/>
-        <a:cs typeface="+mn-cs"/>
-      </a:defRPr>
-    </a:lvl7pPr>
-    <a:lvl8pPr marL="3200400" algn="l" defTabSz="457200" rtl="0" eaLnBrk="1" latinLnBrk="0" hangingPunct="1">
-      <a:defRPr sz="1200" kern="1200">
-        <a:solidFill>
-          <a:schemeClr val="tx1"/>
-        </a:solidFill>
-        <a:latin typeface="+mn-lt"/>
-        <a:ea typeface="+mn-ea"/>
-        <a:cs typeface="+mn-cs"/>
-      </a:defRPr>
-    </a:lvl8pPr>
-    <a:lvl9pPr marL="3657600" algn="l" defTabSz="457200" rtl="0" eaLnBrk="1" latinLnBrk="0" hangingPunct="1">
-      <a:defRPr sz="1200" kern="1200">
-        <a:solidFill>
-          <a:schemeClr val="tx1"/>
-        </a:solidFill>
-        <a:latin typeface="+mn-lt"/>
-        <a:ea typeface="+mn-ea"/>
-        <a:cs typeface="+mn-cs"/>
-      </a:defRPr>
-    </a:lvl9pPr>
-  </p:notesStyle>
-</p:notesMaster>
-</file>
-
-<file path=ppt/notesSlides/notesSlide1.xml><?xml version="1.0" encoding="utf-8"?>
-<p:notes xmlns:a="http://schemas.openxmlformats.org/drawingml/2006/main" xmlns:p="http://schemas.openxmlformats.org/presentationml/2006/main" xmlns:r="http://schemas.openxmlformats.org/officeDocument/2006/relationships">
-  <p:cSld>
-    <p:spTree>
-      <p:nvGrpSpPr>
-        <p:cNvPr id="1" name=""/>
-        <p:cNvGrpSpPr/>
-        <p:nvPr/>
-      </p:nvGrpSpPr>
-      <p:grpSpPr>
-        <a:xfrm>
-          <a:off x="0" y="0"/>
-          <a:ext cx="0" cy="0"/>
-          <a:chOff x="0" y="0"/>
-          <a:chExt cx="0" cy="0"/>
-        </a:xfrm>
-      </p:grpSpPr>
-      <p:sp>
-        <p:nvSpPr>
-          <p:cNvPr id="2" name="Slide Image Placeholder 1"/>
-          <p:cNvSpPr>
-            <a:spLocks noGrp="1"/>
-          </p:cNvSpPr>
-          <p:nvPr>
-            <p:ph type="sldImg" idx="2"/>
-          </p:nvPr>
-        </p:nvSpPr>
-        <p:spPr/>
-      </p:sp>
-      <p:sp>
-        <p:nvSpPr>
-          <p:cNvPr id="3" name="Notes Placeholder 2"/>
-          <p:cNvSpPr>
-            <a:spLocks noGrp="1"/>
-          </p:cNvSpPr>
-          <p:nvPr>
-            <p:ph type="body" idx="3" sz="quarter"/>
-          </p:nvPr>
-        </p:nvSpPr>
-        <p:spPr/>
-        <p:txBody>
-          <a:bodyPr/>
-          <a:lstStyle/>
-          <a:p>
-            <a:r>
-              <a:t>Good morning professor. Today I am presenting our end-to-end system for estimating coal Gross Calorific Value purely from proximate analysis. In industrial power plants and metallurgical facilities, bomb calorimetry tests are expensive, labor-intensive, and cause operational bottlenecks. Our objective was to develop an academically rigorous machine learning framework that delivers sub-2% error rates using only rapid, low-cost proximate lab tests.</a:t>
-            </a:r>
-          </a:p>
-        </p:txBody>
-      </p:sp>
-      <p:sp>
-        <p:nvSpPr>
-          <p:cNvPr id="4" name="Slide Number Placeholder 3"/>
-          <p:cNvSpPr>
-            <a:spLocks noGrp="1"/>
-          </p:cNvSpPr>
-          <p:nvPr>
-            <p:ph type="sldNum" idx="5" sz="quarter"/>
-          </p:nvPr>
-        </p:nvSpPr>
-        <p:spPr/>
-      </p:sp>
-    </p:spTree>
-  </p:cSld>
-  <p:clrMapOvr>
-    <a:masterClrMapping/>
-  </p:clrMapOvr>
-</p:notes>
-</file>
-
-<file path=ppt/notesSlides/notesSlide10.xml><?xml version="1.0" encoding="utf-8"?>
-<p:notes xmlns:a="http://schemas.openxmlformats.org/drawingml/2006/main" xmlns:p="http://schemas.openxmlformats.org/presentationml/2006/main" xmlns:r="http://schemas.openxmlformats.org/officeDocument/2006/relationships">
-  <p:cSld>
-    <p:spTree>
-      <p:nvGrpSpPr>
-        <p:cNvPr id="1" name=""/>
-        <p:cNvGrpSpPr/>
-        <p:nvPr/>
-      </p:nvGrpSpPr>
-      <p:grpSpPr>
-        <a:xfrm>
-          <a:off x="0" y="0"/>
-          <a:ext cx="0" cy="0"/>
-          <a:chOff x="0" y="0"/>
-          <a:chExt cx="0" cy="0"/>
-        </a:xfrm>
-      </p:grpSpPr>
-      <p:sp>
-        <p:nvSpPr>
-          <p:cNvPr id="2" name="Slide Image Placeholder 1"/>
-          <p:cNvSpPr>
-            <a:spLocks noGrp="1"/>
-          </p:cNvSpPr>
-          <p:nvPr>
-            <p:ph type="sldImg" idx="2"/>
-          </p:nvPr>
-        </p:nvSpPr>
-        <p:spPr/>
-      </p:sp>
-      <p:sp>
-        <p:nvSpPr>
-          <p:cNvPr id="3" name="Notes Placeholder 2"/>
-          <p:cNvSpPr>
-            <a:spLocks noGrp="1"/>
-          </p:cNvSpPr>
-          <p:nvPr>
-            <p:ph type="body" idx="3" sz="quarter"/>
-          </p:nvPr>
-        </p:nvSpPr>
-        <p:spPr/>
-        <p:txBody>
-          <a:bodyPr/>
-          <a:lstStyle/>
-          <a:p>
-            <a:r>
-              <a:t>We deployed this entire system as an interactive web dashboard in Streamlit. It includes built-in domain validation: if someone inputs numbers that violate the 100% mass balance or enters an ash percentage above 55%, the system immediately halts and warns the user. The dashboard has two tabs—one for universal coal and one for bituminous—giving instant predictions and interactive SHAP plots.</a:t>
-            </a:r>
-          </a:p>
-        </p:txBody>
-      </p:sp>
-      <p:sp>
-        <p:nvSpPr>
-          <p:cNvPr id="4" name="Slide Number Placeholder 3"/>
-          <p:cNvSpPr>
-            <a:spLocks noGrp="1"/>
-          </p:cNvSpPr>
-          <p:nvPr>
-            <p:ph type="sldNum" idx="5" sz="quarter"/>
-          </p:nvPr>
-        </p:nvSpPr>
-        <p:spPr/>
-      </p:sp>
-    </p:spTree>
-  </p:cSld>
-  <p:clrMapOvr>
-    <a:masterClrMapping/>
-  </p:clrMapOvr>
-</p:notes>
-</file>
-
-<file path=ppt/notesSlides/notesSlide11.xml><?xml version="1.0" encoding="utf-8"?>
-<p:notes xmlns:a="http://schemas.openxmlformats.org/drawingml/2006/main" xmlns:p="http://schemas.openxmlformats.org/presentationml/2006/main" xmlns:r="http://schemas.openxmlformats.org/officeDocument/2006/relationships">
-  <p:cSld>
-    <p:spTree>
-      <p:nvGrpSpPr>
-        <p:cNvPr id="1" name=""/>
-        <p:cNvGrpSpPr/>
-        <p:nvPr/>
-      </p:nvGrpSpPr>
-      <p:grpSpPr>
-        <a:xfrm>
-          <a:off x="0" y="0"/>
-          <a:ext cx="0" cy="0"/>
-          <a:chOff x="0" y="0"/>
-          <a:chExt cx="0" cy="0"/>
-        </a:xfrm>
-      </p:grpSpPr>
-      <p:sp>
-        <p:nvSpPr>
-          <p:cNvPr id="2" name="Slide Image Placeholder 1"/>
-          <p:cNvSpPr>
-            <a:spLocks noGrp="1"/>
-          </p:cNvSpPr>
-          <p:nvPr>
-            <p:ph type="sldImg" idx="2"/>
-          </p:nvPr>
-        </p:nvSpPr>
-        <p:spPr/>
-      </p:sp>
-      <p:sp>
-        <p:nvSpPr>
-          <p:cNvPr id="3" name="Notes Placeholder 2"/>
-          <p:cNvSpPr>
-            <a:spLocks noGrp="1"/>
-          </p:cNvSpPr>
-          <p:nvPr>
-            <p:ph type="body" idx="3" sz="quarter"/>
-          </p:nvPr>
-        </p:nvSpPr>
-        <p:spPr/>
-        <p:txBody>
-          <a:bodyPr/>
-          <a:lstStyle/>
-          <a:p>
-            <a:r>
-              <a:t>To summarize, our machine learning pipeline delivers sub-2% error margins, surpassing the 8% industrial threshold. For future work, we plan to incorporate ultimate analysis for even tighter accuracy, as well as quantile regression to give plant operators formal confidence intervals for risk-aware procurement. Thank you for your time, professor. I welcome any questions or discussion.</a:t>
-            </a:r>
-          </a:p>
-        </p:txBody>
-      </p:sp>
-      <p:sp>
-        <p:nvSpPr>
-          <p:cNvPr id="4" name="Slide Number Placeholder 3"/>
-          <p:cNvSpPr>
-            <a:spLocks noGrp="1"/>
-          </p:cNvSpPr>
-          <p:nvPr>
-            <p:ph type="sldNum" idx="5" sz="quarter"/>
-          </p:nvPr>
-        </p:nvSpPr>
-        <p:spPr/>
-      </p:sp>
-    </p:spTree>
-  </p:cSld>
-  <p:clrMapOvr>
-    <a:masterClrMapping/>
-  </p:clrMapOvr>
-</p:notes>
-</file>
-
-<file path=ppt/notesSlides/notesSlide2.xml><?xml version="1.0" encoding="utf-8"?>
-<p:notes xmlns:a="http://schemas.openxmlformats.org/drawingml/2006/main" xmlns:p="http://schemas.openxmlformats.org/presentationml/2006/main" xmlns:r="http://schemas.openxmlformats.org/officeDocument/2006/relationships">
-  <p:cSld>
-    <p:spTree>
-      <p:nvGrpSpPr>
-        <p:cNvPr id="1" name=""/>
-        <p:cNvGrpSpPr/>
-        <p:nvPr/>
-      </p:nvGrpSpPr>
-      <p:grpSpPr>
-        <a:xfrm>
-          <a:off x="0" y="0"/>
-          <a:ext cx="0" cy="0"/>
-          <a:chOff x="0" y="0"/>
-          <a:chExt cx="0" cy="0"/>
-        </a:xfrm>
-      </p:grpSpPr>
-      <p:sp>
-        <p:nvSpPr>
-          <p:cNvPr id="2" name="Slide Image Placeholder 1"/>
-          <p:cNvSpPr>
-            <a:spLocks noGrp="1"/>
-          </p:cNvSpPr>
-          <p:nvPr>
-            <p:ph type="sldImg" idx="2"/>
-          </p:nvPr>
-        </p:nvSpPr>
-        <p:spPr/>
-      </p:sp>
-      <p:sp>
-        <p:nvSpPr>
-          <p:cNvPr id="3" name="Notes Placeholder 2"/>
-          <p:cNvSpPr>
-            <a:spLocks noGrp="1"/>
-          </p:cNvSpPr>
-          <p:nvPr>
-            <p:ph type="body" idx="3" sz="quarter"/>
-          </p:nvPr>
-        </p:nvSpPr>
-        <p:spPr/>
-        <p:txBody>
-          <a:bodyPr/>
-          <a:lstStyle/>
-          <a:p>
-            <a:r>
-              <a:t>Professor, measuring calorific value experimentally in a bomb calorimeter is slow and costly. In contrast, proximate analysis takes minimal equipment. Thermal power plants need rapid GCV estimation to adjust boiler firing and coal blending. The accepted industry benchmark is an RMSE under 200 Kcal/kg and a coefficient of variation under 8%. As you will see, our pipeline comfortably beat both criteria.</a:t>
-            </a:r>
-          </a:p>
-        </p:txBody>
-      </p:sp>
-      <p:sp>
-        <p:nvSpPr>
-          <p:cNvPr id="4" name="Slide Number Placeholder 3"/>
-          <p:cNvSpPr>
-            <a:spLocks noGrp="1"/>
-          </p:cNvSpPr>
-          <p:nvPr>
-            <p:ph type="sldNum" idx="5" sz="quarter"/>
-          </p:nvPr>
-        </p:nvSpPr>
-        <p:spPr/>
-      </p:sp>
-    </p:spTree>
-  </p:cSld>
-  <p:clrMapOvr>
-    <a:masterClrMapping/>
-  </p:clrMapOvr>
-</p:notes>
-</file>
-
-<file path=ppt/notesSlides/notesSlide3.xml><?xml version="1.0" encoding="utf-8"?>
-<p:notes xmlns:a="http://schemas.openxmlformats.org/drawingml/2006/main" xmlns:p="http://schemas.openxmlformats.org/presentationml/2006/main" xmlns:r="http://schemas.openxmlformats.org/officeDocument/2006/relationships">
-  <p:cSld>
-    <p:spTree>
-      <p:nvGrpSpPr>
-        <p:cNvPr id="1" name=""/>
-        <p:cNvGrpSpPr/>
-        <p:nvPr/>
-      </p:nvGrpSpPr>
-      <p:grpSpPr>
-        <a:xfrm>
-          <a:off x="0" y="0"/>
-          <a:ext cx="0" cy="0"/>
-          <a:chOff x="0" y="0"/>
-          <a:chExt cx="0" cy="0"/>
-        </a:xfrm>
-      </p:grpSpPr>
-      <p:sp>
-        <p:nvSpPr>
-          <p:cNvPr id="2" name="Slide Image Placeholder 1"/>
-          <p:cNvSpPr>
-            <a:spLocks noGrp="1"/>
-          </p:cNvSpPr>
-          <p:nvPr>
-            <p:ph type="sldImg" idx="2"/>
-          </p:nvPr>
-        </p:nvSpPr>
-        <p:spPr/>
-      </p:sp>
-      <p:sp>
-        <p:nvSpPr>
-          <p:cNvPr id="3" name="Notes Placeholder 2"/>
-          <p:cNvSpPr>
-            <a:spLocks noGrp="1"/>
-          </p:cNvSpPr>
-          <p:nvPr>
-            <p:ph type="body" idx="3" sz="quarter"/>
-          </p:nvPr>
-        </p:nvSpPr>
-        <p:spPr/>
-        <p:txBody>
-          <a:bodyPr/>
-          <a:lstStyle/>
-          <a:p>
-            <a:r>
-              <a:t>A key scientific priority was ensuring zero data leakage. In many published papers, researchers fit imputers across the entire dataset including the target column, which artificially inflates validation scores. We ensured our KNN imputer operated strictly in feature space. We also converted Btu to Kcal/kg, filtered out unphysical entries, and enforced the fundamental proximate mass balance constraint.</a:t>
-            </a:r>
-          </a:p>
-        </p:txBody>
-      </p:sp>
-      <p:sp>
-        <p:nvSpPr>
-          <p:cNvPr id="4" name="Slide Number Placeholder 3"/>
-          <p:cNvSpPr>
-            <a:spLocks noGrp="1"/>
-          </p:cNvSpPr>
-          <p:nvPr>
-            <p:ph type="sldNum" idx="5" sz="quarter"/>
-          </p:nvPr>
-        </p:nvSpPr>
-        <p:spPr/>
-      </p:sp>
-    </p:spTree>
-  </p:cSld>
-  <p:clrMapOvr>
-    <a:masterClrMapping/>
-  </p:clrMapOvr>
-</p:notes>
-</file>
-
-<file path=ppt/notesSlides/notesSlide4.xml><?xml version="1.0" encoding="utf-8"?>
-<p:notes xmlns:a="http://schemas.openxmlformats.org/drawingml/2006/main" xmlns:p="http://schemas.openxmlformats.org/presentationml/2006/main" xmlns:r="http://schemas.openxmlformats.org/officeDocument/2006/relationships">
-  <p:cSld>
-    <p:spTree>
-      <p:nvGrpSpPr>
-        <p:cNvPr id="1" name=""/>
-        <p:cNvGrpSpPr/>
-        <p:nvPr/>
-      </p:nvGrpSpPr>
-      <p:grpSpPr>
-        <a:xfrm>
-          <a:off x="0" y="0"/>
-          <a:ext cx="0" cy="0"/>
-          <a:chOff x="0" y="0"/>
-          <a:chExt cx="0" cy="0"/>
-        </a:xfrm>
-      </p:grpSpPr>
-      <p:sp>
-        <p:nvSpPr>
-          <p:cNvPr id="2" name="Slide Image Placeholder 1"/>
-          <p:cNvSpPr>
-            <a:spLocks noGrp="1"/>
-          </p:cNvSpPr>
-          <p:nvPr>
-            <p:ph type="sldImg" idx="2"/>
-          </p:nvPr>
-        </p:nvSpPr>
-        <p:spPr/>
-      </p:sp>
-      <p:sp>
-        <p:nvSpPr>
-          <p:cNvPr id="3" name="Notes Placeholder 2"/>
-          <p:cNvSpPr>
-            <a:spLocks noGrp="1"/>
-          </p:cNvSpPr>
-          <p:nvPr>
-            <p:ph type="body" idx="3" sz="quarter"/>
-          </p:nvPr>
-        </p:nvSpPr>
-        <p:spPr/>
-        <p:txBody>
-          <a:bodyPr/>
-          <a:lstStyle/>
-          <a:p>
-            <a:r>
-              <a:t>Professor, you might wonder why we introduced the Fuel Ratio feature. Random Forest and XGBoost are powerful, but tree splits are orthogonal—they are fundamentally weak at division. In coal geology, fixed carbon divided by volatile matter is the classic Fuel Ratio that determines coal rank. Computing this explicitly allowed our trees to distinguish high-rank from low-rank coal immediately at early nodes, keeping the trees shallow and preventing overfitting.</a:t>
-            </a:r>
-          </a:p>
-        </p:txBody>
-      </p:sp>
-      <p:sp>
-        <p:nvSpPr>
-          <p:cNvPr id="4" name="Slide Number Placeholder 3"/>
-          <p:cNvSpPr>
-            <a:spLocks noGrp="1"/>
-          </p:cNvSpPr>
-          <p:nvPr>
-            <p:ph type="sldNum" idx="5" sz="quarter"/>
-          </p:nvPr>
-        </p:nvSpPr>
-        <p:spPr/>
-      </p:sp>
-    </p:spTree>
-  </p:cSld>
-  <p:clrMapOvr>
-    <a:masterClrMapping/>
-  </p:clrMapOvr>
-</p:notes>
-</file>
-
-<file path=ppt/notesSlides/notesSlide5.xml><?xml version="1.0" encoding="utf-8"?>
-<p:notes xmlns:a="http://schemas.openxmlformats.org/drawingml/2006/main" xmlns:p="http://schemas.openxmlformats.org/presentationml/2006/main" xmlns:r="http://schemas.openxmlformats.org/officeDocument/2006/relationships">
-  <p:cSld>
-    <p:spTree>
-      <p:nvGrpSpPr>
-        <p:cNvPr id="1" name=""/>
-        <p:cNvGrpSpPr/>
-        <p:nvPr/>
-      </p:nvGrpSpPr>
-      <p:grpSpPr>
-        <a:xfrm>
-          <a:off x="0" y="0"/>
-          <a:ext cx="0" cy="0"/>
-          <a:chOff x="0" y="0"/>
-          <a:chExt cx="0" cy="0"/>
-        </a:xfrm>
-      </p:grpSpPr>
-      <p:sp>
-        <p:nvSpPr>
-          <p:cNvPr id="2" name="Slide Image Placeholder 1"/>
-          <p:cNvSpPr>
-            <a:spLocks noGrp="1"/>
-          </p:cNvSpPr>
-          <p:nvPr>
-            <p:ph type="sldImg" idx="2"/>
-          </p:nvPr>
-        </p:nvSpPr>
-        <p:spPr/>
-      </p:sp>
-      <p:sp>
-        <p:nvSpPr>
-          <p:cNvPr id="3" name="Notes Placeholder 2"/>
-          <p:cNvSpPr>
-            <a:spLocks noGrp="1"/>
-          </p:cNvSpPr>
-          <p:nvPr>
-            <p:ph type="body" idx="3" sz="quarter"/>
-          </p:nvPr>
-        </p:nvSpPr>
-        <p:spPr/>
-        <p:txBody>
-          <a:bodyPr/>
-          <a:lstStyle/>
-          <a:p>
-            <a:r>
-              <a:t>Here is the direct empirical comparison. Standalone SVR struggled significantly because the wide variance of GCV destabilizes standard hyperplane optimization. A single Decision Tree suffered from high split variance with an RMSE of 217. While standalone Random Forest and XGBoost performed very well at around 152 to 154 RMSE, our Stacking Ensemble blended their distinct inductive biases, achieving the lowest RMSE of 150.28 Kcal/kg and highest R-squared of 0.9595.</a:t>
-            </a:r>
-          </a:p>
-        </p:txBody>
-      </p:sp>
-      <p:sp>
-        <p:nvSpPr>
-          <p:cNvPr id="4" name="Slide Number Placeholder 3"/>
-          <p:cNvSpPr>
-            <a:spLocks noGrp="1"/>
-          </p:cNvSpPr>
-          <p:nvPr>
-            <p:ph type="sldNum" idx="5" sz="quarter"/>
-          </p:nvPr>
-        </p:nvSpPr>
-        <p:spPr/>
-      </p:sp>
-    </p:spTree>
-  </p:cSld>
-  <p:clrMapOvr>
-    <a:masterClrMapping/>
-  </p:clrMapOvr>
-</p:notes>
-</file>
-
-<file path=ppt/notesSlides/notesSlide6.xml><?xml version="1.0" encoding="utf-8"?>
-<p:notes xmlns:a="http://schemas.openxmlformats.org/drawingml/2006/main" xmlns:p="http://schemas.openxmlformats.org/presentationml/2006/main" xmlns:r="http://schemas.openxmlformats.org/officeDocument/2006/relationships">
-  <p:cSld>
-    <p:spTree>
-      <p:nvGrpSpPr>
-        <p:cNvPr id="1" name=""/>
-        <p:cNvGrpSpPr/>
-        <p:nvPr/>
-      </p:nvGrpSpPr>
-      <p:grpSpPr>
-        <a:xfrm>
-          <a:off x="0" y="0"/>
-          <a:ext cx="0" cy="0"/>
-          <a:chOff x="0" y="0"/>
-          <a:chExt cx="0" cy="0"/>
-        </a:xfrm>
-      </p:grpSpPr>
-      <p:sp>
-        <p:nvSpPr>
-          <p:cNvPr id="2" name="Slide Image Placeholder 1"/>
-          <p:cNvSpPr>
-            <a:spLocks noGrp="1"/>
-          </p:cNvSpPr>
-          <p:nvPr>
-            <p:ph type="sldImg" idx="2"/>
-          </p:nvPr>
-        </p:nvSpPr>
-        <p:spPr/>
-      </p:sp>
-      <p:sp>
-        <p:nvSpPr>
-          <p:cNvPr id="3" name="Notes Placeholder 2"/>
-          <p:cNvSpPr>
-            <a:spLocks noGrp="1"/>
-          </p:cNvSpPr>
-          <p:nvPr>
-            <p:ph type="body" idx="3" sz="quarter"/>
-          </p:nvPr>
-        </p:nvSpPr>
-        <p:spPr/>
-        <p:txBody>
-          <a:bodyPr/>
-          <a:lstStyle/>
-          <a:p>
-            <a:r>
-              <a:t>This slide details our Stacking architecture. Notice our base models include both tree-based algorithms and a kernel-based SVR. SVR normally fails on raw GCV because the numbers are around 6,000 to 8,000. We solved this by using a TransformedTargetRegressor that scales both the features and the GCV target during cross-validation. The out-of-fold predictions from all three models are then fed to a Ridge meta-learner that assigns optimal blending weights.</a:t>
-            </a:r>
-          </a:p>
-        </p:txBody>
-      </p:sp>
-      <p:sp>
-        <p:nvSpPr>
-          <p:cNvPr id="4" name="Slide Number Placeholder 3"/>
-          <p:cNvSpPr>
-            <a:spLocks noGrp="1"/>
-          </p:cNvSpPr>
-          <p:nvPr>
-            <p:ph type="sldNum" idx="5" sz="quarter"/>
-          </p:nvPr>
-        </p:nvSpPr>
-        <p:spPr/>
-      </p:sp>
-    </p:spTree>
-  </p:cSld>
-  <p:clrMapOvr>
-    <a:masterClrMapping/>
-  </p:clrMapOvr>
-</p:notes>
-</file>
-
-<file path=ppt/notesSlides/notesSlide7.xml><?xml version="1.0" encoding="utf-8"?>
-<p:notes xmlns:a="http://schemas.openxmlformats.org/drawingml/2006/main" xmlns:p="http://schemas.openxmlformats.org/presentationml/2006/main" xmlns:r="http://schemas.openxmlformats.org/officeDocument/2006/relationships">
-  <p:cSld>
-    <p:spTree>
-      <p:nvGrpSpPr>
-        <p:cNvPr id="1" name=""/>
-        <p:cNvGrpSpPr/>
-        <p:nvPr/>
-      </p:nvGrpSpPr>
-      <p:grpSpPr>
-        <a:xfrm>
-          <a:off x="0" y="0"/>
-          <a:ext cx="0" cy="0"/>
-          <a:chOff x="0" y="0"/>
-          <a:chExt cx="0" cy="0"/>
-        </a:xfrm>
-      </p:grpSpPr>
-      <p:sp>
-        <p:nvSpPr>
-          <p:cNvPr id="2" name="Slide Image Placeholder 1"/>
-          <p:cNvSpPr>
-            <a:spLocks noGrp="1"/>
-          </p:cNvSpPr>
-          <p:nvPr>
-            <p:ph type="sldImg" idx="2"/>
-          </p:nvPr>
-        </p:nvSpPr>
-        <p:spPr/>
-      </p:sp>
-      <p:sp>
-        <p:nvSpPr>
-          <p:cNvPr id="3" name="Notes Placeholder 2"/>
-          <p:cNvSpPr>
-            <a:spLocks noGrp="1"/>
-          </p:cNvSpPr>
-          <p:nvPr>
-            <p:ph type="body" idx="3" sz="quarter"/>
-          </p:nvPr>
-        </p:nvSpPr>
-        <p:spPr/>
-        <p:txBody>
-          <a:bodyPr/>
-          <a:lstStyle/>
-          <a:p>
-            <a:r>
-              <a:t>To fine-tune our models, we wrote a dedicated script using Optuna. Rather than guessing parameters or using an exhaustive grid search, Optuna builds a probabilistic surrogate model using Tree-structured Parzen Estimators. Notice that the optimizer chose a shallow tree depth of 4 for XGBoost and a min_samples_leaf of 4 for Random Forest. This regularized the models so they generalize smoothly across unseen coal samples rather than memorizing laboratory noise.</a:t>
-            </a:r>
-          </a:p>
-        </p:txBody>
-      </p:sp>
-      <p:sp>
-        <p:nvSpPr>
-          <p:cNvPr id="4" name="Slide Number Placeholder 3"/>
-          <p:cNvSpPr>
-            <a:spLocks noGrp="1"/>
-          </p:cNvSpPr>
-          <p:nvPr>
-            <p:ph type="sldNum" idx="5" sz="quarter"/>
-          </p:nvPr>
-        </p:nvSpPr>
-        <p:spPr/>
-      </p:sp>
-    </p:spTree>
-  </p:cSld>
-  <p:clrMapOvr>
-    <a:masterClrMapping/>
-  </p:clrMapOvr>
-</p:notes>
-</file>
-
-<file path=ppt/notesSlides/notesSlide8.xml><?xml version="1.0" encoding="utf-8"?>
-<p:notes xmlns:a="http://schemas.openxmlformats.org/drawingml/2006/main" xmlns:p="http://schemas.openxmlformats.org/presentationml/2006/main" xmlns:r="http://schemas.openxmlformats.org/officeDocument/2006/relationships">
-  <p:cSld>
-    <p:spTree>
-      <p:nvGrpSpPr>
-        <p:cNvPr id="1" name=""/>
-        <p:cNvGrpSpPr/>
-        <p:nvPr/>
-      </p:nvGrpSpPr>
-      <p:grpSpPr>
-        <a:xfrm>
-          <a:off x="0" y="0"/>
-          <a:ext cx="0" cy="0"/>
-          <a:chOff x="0" y="0"/>
-          <a:chExt cx="0" cy="0"/>
-        </a:xfrm>
-      </p:grpSpPr>
-      <p:sp>
-        <p:nvSpPr>
-          <p:cNvPr id="2" name="Slide Image Placeholder 1"/>
-          <p:cNvSpPr>
-            <a:spLocks noGrp="1"/>
-          </p:cNvSpPr>
-          <p:nvPr>
-            <p:ph type="sldImg" idx="2"/>
-          </p:nvPr>
-        </p:nvSpPr>
-        <p:spPr/>
-      </p:sp>
-      <p:sp>
-        <p:nvSpPr>
-          <p:cNvPr id="3" name="Notes Placeholder 2"/>
-          <p:cNvSpPr>
-            <a:spLocks noGrp="1"/>
-          </p:cNvSpPr>
-          <p:nvPr>
-            <p:ph type="body" idx="3" sz="quarter"/>
-          </p:nvPr>
-        </p:nvSpPr>
-        <p:spPr/>
-        <p:txBody>
-          <a:bodyPr/>
-          <a:lstStyle/>
-          <a:p>
-            <a:r>
-              <a:t>Professor, one key insight is that coal is not a single uniform material. Combining high-moisture lignite with low-volatile anthracite in one model introduces unnecessary variance. By following the ASTM D388 standard classification to isolate the 4,494 bituminous samples, our specialized model dropped RMSE from 150 down to 134 Kcal/kg, and mean absolute error went under 100 Kcal/kg. The diagnostic plot on the right shows how tightly the predictions hug the ideal diagonal line.</a:t>
-            </a:r>
-          </a:p>
-        </p:txBody>
-      </p:sp>
-      <p:sp>
-        <p:nvSpPr>
-          <p:cNvPr id="4" name="Slide Number Placeholder 3"/>
-          <p:cNvSpPr>
-            <a:spLocks noGrp="1"/>
-          </p:cNvSpPr>
-          <p:nvPr>
-            <p:ph type="sldNum" idx="5" sz="quarter"/>
-          </p:nvPr>
-        </p:nvSpPr>
-        <p:spPr/>
-      </p:sp>
-    </p:spTree>
-  </p:cSld>
-  <p:clrMapOvr>
-    <a:masterClrMapping/>
-  </p:clrMapOvr>
-</p:notes>
-</file>
-
-<file path=ppt/notesSlides/notesSlide9.xml><?xml version="1.0" encoding="utf-8"?>
-<p:notes xmlns:a="http://schemas.openxmlformats.org/drawingml/2006/main" xmlns:p="http://schemas.openxmlformats.org/presentationml/2006/main" xmlns:r="http://schemas.openxmlformats.org/officeDocument/2006/relationships">
-  <p:cSld>
-    <p:spTree>
-      <p:nvGrpSpPr>
-        <p:cNvPr id="1" name=""/>
-        <p:cNvGrpSpPr/>
-        <p:nvPr/>
-      </p:nvGrpSpPr>
-      <p:grpSpPr>
-        <a:xfrm>
-          <a:off x="0" y="0"/>
-          <a:ext cx="0" cy="0"/>
-          <a:chOff x="0" y="0"/>
-          <a:chExt cx="0" cy="0"/>
-        </a:xfrm>
-      </p:grpSpPr>
-      <p:sp>
-        <p:nvSpPr>
-          <p:cNvPr id="2" name="Slide Image Placeholder 1"/>
-          <p:cNvSpPr>
-            <a:spLocks noGrp="1"/>
-          </p:cNvSpPr>
-          <p:nvPr>
-            <p:ph type="sldImg" idx="2"/>
-          </p:nvPr>
-        </p:nvSpPr>
-        <p:spPr/>
-      </p:sp>
-      <p:sp>
-        <p:nvSpPr>
-          <p:cNvPr id="3" name="Notes Placeholder 2"/>
-          <p:cNvSpPr>
-            <a:spLocks noGrp="1"/>
-          </p:cNvSpPr>
-          <p:nvPr>
-            <p:ph type="body" idx="3" sz="quarter"/>
-          </p:nvPr>
-        </p:nvSpPr>
-        <p:spPr/>
-        <p:txBody>
-          <a:bodyPr/>
-          <a:lstStyle/>
-          <a:p>
-            <a:r>
-              <a:t>To ensure our model is trustworthy for plant operators, we integrated SHAP explainability. For any given coal sample, the model outputs a waterfall plot showing how each component influenced the prediction from the baseline mean. As expected thermodynamically, moisture and ash pull the prediction down because water vaporization and inert minerals consume heat. Fixed carbon and fuel ratio push the prediction up. This proves the AI is learning authentic chemistry rather than statistical artifacts.</a:t>
-            </a:r>
-          </a:p>
-        </p:txBody>
-      </p:sp>
-      <p:sp>
-        <p:nvSpPr>
-          <p:cNvPr id="4" name="Slide Number Placeholder 3"/>
-          <p:cNvSpPr>
-            <a:spLocks noGrp="1"/>
-          </p:cNvSpPr>
-          <p:nvPr>
-            <p:ph type="sldNum" idx="5" sz="quarter"/>
-          </p:nvPr>
-        </p:nvSpPr>
-        <p:spPr/>
-      </p:sp>
-    </p:spTree>
-  </p:cSld>
-  <p:clrMapOvr>
-    <a:masterClrMapping/>
-  </p:clrMapOvr>
-</p:notes>
 </file>
 
 <file path=ppt/slideLayouts/slideLayout1.xml><?xml version="1.0" encoding="utf-8"?>
@@ -4269,8 +3149,8 @@
         </p:nvSpPr>
         <p:spPr>
           <a:xfrm>
-            <a:off x="731520" y="1645920"/>
-            <a:ext cx="137160" cy="3474720"/>
+            <a:off x="731520" y="2011680"/>
+            <a:ext cx="164592" cy="2560320"/>
           </a:xfrm>
           <a:prstGeom prst="rect">
             <a:avLst/>
@@ -4312,8 +3192,8 @@
         </p:nvSpPr>
         <p:spPr>
           <a:xfrm>
-            <a:off x="1097280" y="1645920"/>
-            <a:ext cx="10058400" cy="3474720"/>
+            <a:off x="1097280" y="1920240"/>
+            <a:ext cx="10241280" cy="2926080"/>
           </a:xfrm>
           <a:prstGeom prst="rect">
             <a:avLst/>
@@ -4327,9 +3207,9 @@
           <a:lstStyle/>
           <a:p>
             <a:pPr>
-              <a:defRPr sz="3600" b="1">
-                <a:solidFill>
-                  <a:srgbClr val="F8FAFC"/>
+              <a:defRPr sz="3800" b="1">
+                <a:solidFill>
+                  <a:srgbClr val="FFFFFF"/>
                 </a:solidFill>
               </a:defRPr>
             </a:pPr>
@@ -4340,9 +3220,9 @@
           <a:p>
             <a:pPr>
               <a:spcBef>
-                <a:spcPts val="1200"/>
+                <a:spcPts val="1600"/>
               </a:spcBef>
-              <a:defRPr sz="2000">
+              <a:defRPr sz="2100" b="1">
                 <a:solidFill>
                   <a:srgbClr val="38BDF8"/>
                 </a:solidFill>
@@ -4350,34 +3230,6 @@
             </a:pPr>
             <a:r>
               <a:t>High-Precision Estimation from Proximate Analysis via Bayesian-Tuned Stacking Ensembles</a:t>
-            </a:r>
-          </a:p>
-          <a:p>
-            <a:br/>
-            <a:pPr>
-              <a:spcBef>
-                <a:spcPts val="2000"/>
-              </a:spcBef>
-              <a:defRPr sz="1400">
-                <a:solidFill>
-                  <a:srgbClr val="94A3B8"/>
-                </a:solidFill>
-              </a:defRPr>
-            </a:pPr>
-            <a:r>
-              <a:t>• Optimized Machine Learning Architecture (XGBoost, Random Forest, SVR + Ridge Meta-Learner)</a:t>
-            </a:r>
-            <a:br/>
-            <a:r>
-              <a:t>• Zero-Leakage Data Hygiene &amp; ASTM D388 Coal Rank Specialization</a:t>
-            </a:r>
-            <a:br/>
-            <a:r>
-              <a:t>• Model Interpretability via SHAP (SHapley Additive exPlanations)</a:t>
-            </a:r>
-            <a:br/>
-            <a:r>
-              <a:t>• Live Interactive Web Deployment with Chemical Guardrails</a:t>
             </a:r>
           </a:p>
         </p:txBody>
@@ -4503,7 +3355,7 @@
             <a:pPr>
               <a:defRPr sz="2400" b="1">
                 <a:solidFill>
-                  <a:srgbClr val="F8FAFC"/>
+                  <a:srgbClr val="FFFFFF"/>
                 </a:solidFill>
               </a:defRPr>
             </a:pPr>
@@ -4530,7 +3382,7 @@
           <a:solidFill>
             <a:srgbClr val="1E293B"/>
           </a:solidFill>
-          <a:ln w="12700">
+          <a:ln w="19050">
             <a:solidFill>
               <a:srgbClr val="38BDF8"/>
             </a:solidFill>
@@ -4566,8 +3418,8 @@
         </p:nvSpPr>
         <p:spPr>
           <a:xfrm>
-            <a:off x="914400" y="1783080"/>
-            <a:ext cx="4754880" cy="1737360"/>
+            <a:off x="960120" y="1828800"/>
+            <a:ext cx="4663440" cy="1645920"/>
           </a:xfrm>
           <a:prstGeom prst="rect">
             <a:avLst/>
@@ -4581,7 +3433,7 @@
           <a:lstStyle/>
           <a:p>
             <a:pPr>
-              <a:defRPr sz="1500" b="1">
+              <a:defRPr sz="1600" b="1">
                 <a:solidFill>
                   <a:srgbClr val="38BDF8"/>
                 </a:solidFill>
@@ -4596,9 +3448,9 @@
               <a:spcBef>
                 <a:spcPts val="800"/>
               </a:spcBef>
-              <a:defRPr sz="1100">
-                <a:solidFill>
-                  <a:srgbClr val="F8FAFC"/>
+              <a:defRPr sz="1200">
+                <a:solidFill>
+                  <a:srgbClr val="FFFFFF"/>
                 </a:solidFill>
               </a:defRPr>
             </a:pPr>
@@ -4633,7 +3485,7 @@
           <a:solidFill>
             <a:srgbClr val="1E293B"/>
           </a:solidFill>
-          <a:ln w="12700">
+          <a:ln w="19050">
             <a:solidFill>
               <a:srgbClr val="FB923C"/>
             </a:solidFill>
@@ -4669,8 +3521,8 @@
         </p:nvSpPr>
         <p:spPr>
           <a:xfrm>
-            <a:off x="6309360" y="1783080"/>
-            <a:ext cx="4754880" cy="1737360"/>
+            <a:off x="6355080" y="1828800"/>
+            <a:ext cx="4663440" cy="1645920"/>
           </a:xfrm>
           <a:prstGeom prst="rect">
             <a:avLst/>
@@ -4684,7 +3536,7 @@
           <a:lstStyle/>
           <a:p>
             <a:pPr>
-              <a:defRPr sz="1500" b="1">
+              <a:defRPr sz="1600" b="1">
                 <a:solidFill>
                   <a:srgbClr val="FB923C"/>
                 </a:solidFill>
@@ -4699,9 +3551,9 @@
               <a:spcBef>
                 <a:spcPts val="800"/>
               </a:spcBef>
-              <a:defRPr sz="1100">
-                <a:solidFill>
-                  <a:srgbClr val="F8FAFC"/>
+              <a:defRPr sz="1200">
+                <a:solidFill>
+                  <a:srgbClr val="FFFFFF"/>
                 </a:solidFill>
               </a:defRPr>
             </a:pPr>
@@ -4732,7 +3584,7 @@
           <a:solidFill>
             <a:srgbClr val="1E293B"/>
           </a:solidFill>
-          <a:ln w="12700">
+          <a:ln w="19050">
             <a:solidFill>
               <a:srgbClr val="34D399"/>
             </a:solidFill>
@@ -4768,8 +3620,8 @@
         </p:nvSpPr>
         <p:spPr>
           <a:xfrm>
-            <a:off x="914400" y="4069080"/>
-            <a:ext cx="4754880" cy="1737360"/>
+            <a:off x="960120" y="4114800"/>
+            <a:ext cx="4663440" cy="1645920"/>
           </a:xfrm>
           <a:prstGeom prst="rect">
             <a:avLst/>
@@ -4783,7 +3635,7 @@
           <a:lstStyle/>
           <a:p>
             <a:pPr>
-              <a:defRPr sz="1500" b="1">
+              <a:defRPr sz="1600" b="1">
                 <a:solidFill>
                   <a:srgbClr val="34D399"/>
                 </a:solidFill>
@@ -4798,9 +3650,9 @@
               <a:spcBef>
                 <a:spcPts val="800"/>
               </a:spcBef>
-              <a:defRPr sz="1100">
-                <a:solidFill>
-                  <a:srgbClr val="F8FAFC"/>
+              <a:defRPr sz="1200">
+                <a:solidFill>
+                  <a:srgbClr val="FFFFFF"/>
                 </a:solidFill>
               </a:defRPr>
             </a:pPr>
@@ -4827,7 +3679,7 @@
           <a:solidFill>
             <a:srgbClr val="1E293B"/>
           </a:solidFill>
-          <a:ln w="12700">
+          <a:ln w="19050">
             <a:solidFill>
               <a:srgbClr val="38BDF8"/>
             </a:solidFill>
@@ -4863,8 +3715,8 @@
         </p:nvSpPr>
         <p:spPr>
           <a:xfrm>
-            <a:off x="6309360" y="4069080"/>
-            <a:ext cx="4754880" cy="1737360"/>
+            <a:off x="6355080" y="4114800"/>
+            <a:ext cx="4663440" cy="1645920"/>
           </a:xfrm>
           <a:prstGeom prst="rect">
             <a:avLst/>
@@ -4878,7 +3730,7 @@
           <a:lstStyle/>
           <a:p>
             <a:pPr>
-              <a:defRPr sz="1500" b="1">
+              <a:defRPr sz="1600" b="1">
                 <a:solidFill>
                   <a:srgbClr val="38BDF8"/>
                 </a:solidFill>
@@ -4893,9 +3745,9 @@
               <a:spcBef>
                 <a:spcPts val="800"/>
               </a:spcBef>
-              <a:defRPr sz="1100">
-                <a:solidFill>
-                  <a:srgbClr val="F8FAFC"/>
+              <a:defRPr sz="1200">
+                <a:solidFill>
+                  <a:srgbClr val="FFFFFF"/>
                 </a:solidFill>
               </a:defRPr>
             </a:pPr>
@@ -5026,7 +3878,7 @@
             <a:pPr>
               <a:defRPr sz="2400" b="1">
                 <a:solidFill>
-                  <a:srgbClr val="F8FAFC"/>
+                  <a:srgbClr val="FFFFFF"/>
                 </a:solidFill>
               </a:defRPr>
             </a:pPr>
@@ -5121,7 +3973,7 @@
               </a:spcBef>
               <a:defRPr sz="1200">
                 <a:solidFill>
-                  <a:srgbClr val="F8FAFC"/>
+                  <a:srgbClr val="FFFFFF"/>
                 </a:solidFill>
               </a:defRPr>
             </a:pPr>
@@ -5251,9 +4103,9 @@
               <a:spcBef>
                 <a:spcPts val="1000"/>
               </a:spcBef>
-              <a:defRPr sz="1150">
-                <a:solidFill>
-                  <a:srgbClr val="F8FAFC"/>
+              <a:defRPr sz="1200">
+                <a:solidFill>
+                  <a:srgbClr val="FFFFFF"/>
                 </a:solidFill>
               </a:defRPr>
             </a:pPr>
@@ -5415,7 +4267,7 @@
             <a:pPr>
               <a:defRPr sz="2400" b="1">
                 <a:solidFill>
-                  <a:srgbClr val="F8FAFC"/>
+                  <a:srgbClr val="FFFFFF"/>
                 </a:solidFill>
               </a:defRPr>
             </a:pPr>
@@ -5478,8 +4330,8 @@
         </p:nvSpPr>
         <p:spPr>
           <a:xfrm>
-            <a:off x="914400" y="1828800"/>
-            <a:ext cx="3017520" cy="4023360"/>
+            <a:off x="960120" y="1874520"/>
+            <a:ext cx="2926080" cy="3931920"/>
           </a:xfrm>
           <a:prstGeom prst="rect">
             <a:avLst/>
@@ -5510,7 +4362,7 @@
               </a:spcBef>
               <a:defRPr sz="1300">
                 <a:solidFill>
-                  <a:srgbClr val="F8FAFC"/>
+                  <a:srgbClr val="FFFFFF"/>
                 </a:solidFill>
               </a:defRPr>
             </a:pPr>
@@ -5578,8 +4430,8 @@
         </p:nvSpPr>
         <p:spPr>
           <a:xfrm>
-            <a:off x="4480560" y="1828800"/>
-            <a:ext cx="3017520" cy="4023360"/>
+            <a:off x="4526280" y="1874520"/>
+            <a:ext cx="2926080" cy="3931920"/>
           </a:xfrm>
           <a:prstGeom prst="rect">
             <a:avLst/>
@@ -5610,7 +4462,7 @@
               </a:spcBef>
               <a:defRPr sz="1300">
                 <a:solidFill>
-                  <a:srgbClr val="F8FAFC"/>
+                  <a:srgbClr val="FFFFFF"/>
                 </a:solidFill>
               </a:defRPr>
             </a:pPr>
@@ -5678,8 +4530,8 @@
         </p:nvSpPr>
         <p:spPr>
           <a:xfrm>
-            <a:off x="8046720" y="1828800"/>
-            <a:ext cx="3017520" cy="4023360"/>
+            <a:off x="8092440" y="1874520"/>
+            <a:ext cx="2926080" cy="3931920"/>
           </a:xfrm>
           <a:prstGeom prst="rect">
             <a:avLst/>
@@ -5710,7 +4562,7 @@
               </a:spcBef>
               <a:defRPr sz="1300">
                 <a:solidFill>
-                  <a:srgbClr val="F8FAFC"/>
+                  <a:srgbClr val="FFFFFF"/>
                 </a:solidFill>
               </a:defRPr>
             </a:pPr>
@@ -5850,7 +4702,7 @@
             <a:pPr>
               <a:defRPr sz="2400" b="1">
                 <a:solidFill>
-                  <a:srgbClr val="F8FAFC"/>
+                  <a:srgbClr val="FFFFFF"/>
                 </a:solidFill>
               </a:defRPr>
             </a:pPr>
@@ -5877,7 +4729,7 @@
           <a:solidFill>
             <a:srgbClr val="1E293B"/>
           </a:solidFill>
-          <a:ln w="12700">
+          <a:ln w="19050">
             <a:solidFill>
               <a:srgbClr val="38BDF8"/>
             </a:solidFill>
@@ -5913,8 +4765,8 @@
         </p:nvSpPr>
         <p:spPr>
           <a:xfrm>
-            <a:off x="914400" y="1783080"/>
-            <a:ext cx="4754880" cy="1737360"/>
+            <a:off x="960120" y="1828800"/>
+            <a:ext cx="4663440" cy="1645920"/>
           </a:xfrm>
           <a:prstGeom prst="rect">
             <a:avLst/>
@@ -5943,9 +4795,9 @@
               <a:spcBef>
                 <a:spcPts val="800"/>
               </a:spcBef>
-              <a:defRPr sz="1200">
-                <a:solidFill>
-                  <a:srgbClr val="F8FAFC"/>
+              <a:defRPr sz="1250">
+                <a:solidFill>
+                  <a:srgbClr val="FFFFFF"/>
                 </a:solidFill>
               </a:defRPr>
             </a:pPr>
@@ -5976,7 +4828,7 @@
           <a:solidFill>
             <a:srgbClr val="1E293B"/>
           </a:solidFill>
-          <a:ln w="12700">
+          <a:ln w="19050">
             <a:solidFill>
               <a:srgbClr val="34D399"/>
             </a:solidFill>
@@ -6012,8 +4864,8 @@
         </p:nvSpPr>
         <p:spPr>
           <a:xfrm>
-            <a:off x="6309360" y="1783080"/>
-            <a:ext cx="4754880" cy="1737360"/>
+            <a:off x="6355080" y="1828800"/>
+            <a:ext cx="4663440" cy="1645920"/>
           </a:xfrm>
           <a:prstGeom prst="rect">
             <a:avLst/>
@@ -6042,9 +4894,9 @@
               <a:spcBef>
                 <a:spcPts val="800"/>
               </a:spcBef>
-              <a:defRPr sz="1200">
-                <a:solidFill>
-                  <a:srgbClr val="F8FAFC"/>
+              <a:defRPr sz="1250">
+                <a:solidFill>
+                  <a:srgbClr val="FFFFFF"/>
                 </a:solidFill>
               </a:defRPr>
             </a:pPr>
@@ -6071,7 +4923,7 @@
           <a:solidFill>
             <a:srgbClr val="1E293B"/>
           </a:solidFill>
-          <a:ln w="12700">
+          <a:ln w="19050">
             <a:solidFill>
               <a:srgbClr val="FB923C"/>
             </a:solidFill>
@@ -6107,8 +4959,8 @@
         </p:nvSpPr>
         <p:spPr>
           <a:xfrm>
-            <a:off x="914400" y="4069080"/>
-            <a:ext cx="4754880" cy="1737360"/>
+            <a:off x="960120" y="4114800"/>
+            <a:ext cx="4663440" cy="1645920"/>
           </a:xfrm>
           <a:prstGeom prst="rect">
             <a:avLst/>
@@ -6137,9 +4989,9 @@
               <a:spcBef>
                 <a:spcPts val="800"/>
               </a:spcBef>
-              <a:defRPr sz="1200">
-                <a:solidFill>
-                  <a:srgbClr val="F8FAFC"/>
+              <a:defRPr sz="1250">
+                <a:solidFill>
+                  <a:srgbClr val="FFFFFF"/>
                 </a:solidFill>
               </a:defRPr>
             </a:pPr>
@@ -6178,7 +5030,7 @@
           <a:solidFill>
             <a:srgbClr val="1E293B"/>
           </a:solidFill>
-          <a:ln w="12700">
+          <a:ln w="19050">
             <a:solidFill>
               <a:srgbClr val="38BDF8"/>
             </a:solidFill>
@@ -6214,8 +5066,8 @@
         </p:nvSpPr>
         <p:spPr>
           <a:xfrm>
-            <a:off x="6309360" y="4069080"/>
-            <a:ext cx="4754880" cy="1737360"/>
+            <a:off x="6355080" y="4114800"/>
+            <a:ext cx="4663440" cy="1645920"/>
           </a:xfrm>
           <a:prstGeom prst="rect">
             <a:avLst/>
@@ -6244,9 +5096,9 @@
               <a:spcBef>
                 <a:spcPts val="800"/>
               </a:spcBef>
-              <a:defRPr sz="1200">
-                <a:solidFill>
-                  <a:srgbClr val="F8FAFC"/>
+              <a:defRPr sz="1250">
+                <a:solidFill>
+                  <a:srgbClr val="FFFFFF"/>
                 </a:solidFill>
               </a:defRPr>
             </a:pPr>
@@ -6385,7 +5237,7 @@
             <a:pPr>
               <a:defRPr sz="2400" b="1">
                 <a:solidFill>
-                  <a:srgbClr val="F8FAFC"/>
+                  <a:srgbClr val="FFFFFF"/>
                 </a:solidFill>
               </a:defRPr>
             </a:pPr>
@@ -6418,7 +5270,7 @@
           <a:lstStyle/>
           <a:p>
             <a:pPr>
-              <a:defRPr sz="1700" b="1">
+              <a:defRPr sz="1800" b="1">
                 <a:solidFill>
                   <a:srgbClr val="FB923C"/>
                 </a:solidFill>
@@ -6435,7 +5287,7 @@
               </a:spcBef>
               <a:defRPr sz="1300">
                 <a:solidFill>
-                  <a:srgbClr val="F8FAFC"/>
+                  <a:srgbClr val="FFFFFF"/>
                 </a:solidFill>
               </a:defRPr>
             </a:pPr>
@@ -6450,7 +5302,7 @@
               </a:spcBef>
               <a:defRPr sz="1300">
                 <a:solidFill>
-                  <a:srgbClr val="F8FAFC"/>
+                  <a:srgbClr val="FFFFFF"/>
                 </a:solidFill>
               </a:defRPr>
             </a:pPr>
@@ -6469,7 +5321,7 @@
               </a:spcBef>
               <a:defRPr sz="1300">
                 <a:solidFill>
-                  <a:srgbClr val="F8FAFC"/>
+                  <a:srgbClr val="FFFFFF"/>
                 </a:solidFill>
               </a:defRPr>
             </a:pPr>
@@ -6484,7 +5336,7 @@
               </a:spcBef>
               <a:defRPr sz="1300">
                 <a:solidFill>
-                  <a:srgbClr val="F8FAFC"/>
+                  <a:srgbClr val="FFFFFF"/>
                 </a:solidFill>
               </a:defRPr>
             </a:pPr>
@@ -6562,24 +5414,24 @@
           <a:lstStyle/>
           <a:p>
             <a:pPr>
+              <a:defRPr sz="1700" b="1">
+                <a:solidFill>
+                  <a:srgbClr val="34D399"/>
+                </a:solidFill>
+              </a:defRPr>
+            </a:pPr>
+            <a:r>
+              <a:t>Mass Balance Formulation:</a:t>
+            </a:r>
+          </a:p>
+          <a:p>
+            <a:pPr>
+              <a:spcBef>
+                <a:spcPts val="1200"/>
+              </a:spcBef>
               <a:defRPr sz="1600" b="1">
                 <a:solidFill>
-                  <a:srgbClr val="34D399"/>
-                </a:solidFill>
-              </a:defRPr>
-            </a:pPr>
-            <a:r>
-              <a:t>Mass Balance Formulation:</a:t>
-            </a:r>
-          </a:p>
-          <a:p>
-            <a:pPr>
-              <a:spcBef>
-                <a:spcPts val="1000"/>
-              </a:spcBef>
-              <a:defRPr sz="1500" b="1">
-                <a:solidFill>
-                  <a:srgbClr val="F8FAFC"/>
+                  <a:srgbClr val="FFFFFF"/>
                 </a:solidFill>
               </a:defRPr>
             </a:pPr>
@@ -6596,11 +5448,11 @@
             <a:br/>
             <a:pPr>
               <a:spcBef>
-                <a:spcPts val="1000"/>
+                <a:spcPts val="1200"/>
               </a:spcBef>
               <a:defRPr sz="1300">
                 <a:solidFill>
-                  <a:srgbClr val="94A3B8"/>
+                  <a:srgbClr val="F1F5F9"/>
                 </a:solidFill>
               </a:defRPr>
             </a:pPr>
@@ -6617,7 +5469,7 @@
             </a:r>
             <a:br/>
             <a:r>
-              <a:t>• Reduces CV error across all folds consistently.</a:t>
+              <a:t>• Consistently reduces CV error across all folds.</a:t>
             </a:r>
           </a:p>
         </p:txBody>
@@ -6743,7 +5595,7 @@
             <a:pPr>
               <a:defRPr sz="2400" b="1">
                 <a:solidFill>
-                  <a:srgbClr val="F8FAFC"/>
+                  <a:srgbClr val="FFFFFF"/>
                 </a:solidFill>
               </a:defRPr>
             </a:pPr>
@@ -6786,7 +5638,7 @@
                       <a:pPr>
                         <a:defRPr sz="1100" b="1">
                           <a:solidFill>
-                            <a:srgbClr val="F8FAFC"/>
+                            <a:srgbClr val="FFFFFF"/>
                           </a:solidFill>
                         </a:defRPr>
                       </a:pPr>
@@ -6809,7 +5661,7 @@
                       <a:pPr>
                         <a:defRPr sz="1100" b="1">
                           <a:solidFill>
-                            <a:srgbClr val="F8FAFC"/>
+                            <a:srgbClr val="FFFFFF"/>
                           </a:solidFill>
                         </a:defRPr>
                       </a:pPr>
@@ -6832,7 +5684,7 @@
                       <a:pPr>
                         <a:defRPr sz="1100" b="1">
                           <a:solidFill>
-                            <a:srgbClr val="F8FAFC"/>
+                            <a:srgbClr val="FFFFFF"/>
                           </a:solidFill>
                         </a:defRPr>
                       </a:pPr>
@@ -6855,7 +5707,7 @@
                       <a:pPr>
                         <a:defRPr sz="1100" b="1">
                           <a:solidFill>
-                            <a:srgbClr val="F8FAFC"/>
+                            <a:srgbClr val="FFFFFF"/>
                           </a:solidFill>
                         </a:defRPr>
                       </a:pPr>
@@ -6880,7 +5732,7 @@
                       <a:pPr>
                         <a:defRPr sz="1100">
                           <a:solidFill>
-                            <a:srgbClr val="F8FAFC"/>
+                            <a:srgbClr val="FFFFFF"/>
                           </a:solidFill>
                         </a:defRPr>
                       </a:pPr>
@@ -6903,7 +5755,7 @@
                       <a:pPr>
                         <a:defRPr sz="1100">
                           <a:solidFill>
-                            <a:srgbClr val="F8FAFC"/>
+                            <a:srgbClr val="FFFFFF"/>
                           </a:solidFill>
                         </a:defRPr>
                       </a:pPr>
@@ -6926,7 +5778,7 @@
                       <a:pPr>
                         <a:defRPr sz="1100">
                           <a:solidFill>
-                            <a:srgbClr val="F8FAFC"/>
+                            <a:srgbClr val="FFFFFF"/>
                           </a:solidFill>
                         </a:defRPr>
                       </a:pPr>
@@ -6949,7 +5801,7 @@
                       <a:pPr>
                         <a:defRPr sz="1100">
                           <a:solidFill>
-                            <a:srgbClr val="F8FAFC"/>
+                            <a:srgbClr val="FFFFFF"/>
                           </a:solidFill>
                         </a:defRPr>
                       </a:pPr>
@@ -6974,7 +5826,7 @@
                       <a:pPr>
                         <a:defRPr sz="1100">
                           <a:solidFill>
-                            <a:srgbClr val="F8FAFC"/>
+                            <a:srgbClr val="FFFFFF"/>
                           </a:solidFill>
                         </a:defRPr>
                       </a:pPr>
@@ -6997,7 +5849,7 @@
                       <a:pPr>
                         <a:defRPr sz="1100">
                           <a:solidFill>
-                            <a:srgbClr val="F8FAFC"/>
+                            <a:srgbClr val="FFFFFF"/>
                           </a:solidFill>
                         </a:defRPr>
                       </a:pPr>
@@ -7020,7 +5872,7 @@
                       <a:pPr>
                         <a:defRPr sz="1100">
                           <a:solidFill>
-                            <a:srgbClr val="F8FAFC"/>
+                            <a:srgbClr val="FFFFFF"/>
                           </a:solidFill>
                         </a:defRPr>
                       </a:pPr>
@@ -7043,7 +5895,7 @@
                       <a:pPr>
                         <a:defRPr sz="1100">
                           <a:solidFill>
-                            <a:srgbClr val="F8FAFC"/>
+                            <a:srgbClr val="FFFFFF"/>
                           </a:solidFill>
                         </a:defRPr>
                       </a:pPr>
@@ -7068,7 +5920,7 @@
                       <a:pPr>
                         <a:defRPr sz="1100">
                           <a:solidFill>
-                            <a:srgbClr val="F8FAFC"/>
+                            <a:srgbClr val="FFFFFF"/>
                           </a:solidFill>
                         </a:defRPr>
                       </a:pPr>
@@ -7091,7 +5943,7 @@
                       <a:pPr>
                         <a:defRPr sz="1100">
                           <a:solidFill>
-                            <a:srgbClr val="F8FAFC"/>
+                            <a:srgbClr val="FFFFFF"/>
                           </a:solidFill>
                         </a:defRPr>
                       </a:pPr>
@@ -7114,7 +5966,7 @@
                       <a:pPr>
                         <a:defRPr sz="1100">
                           <a:solidFill>
-                            <a:srgbClr val="F8FAFC"/>
+                            <a:srgbClr val="FFFFFF"/>
                           </a:solidFill>
                         </a:defRPr>
                       </a:pPr>
@@ -7137,7 +5989,7 @@
                       <a:pPr>
                         <a:defRPr sz="1100">
                           <a:solidFill>
-                            <a:srgbClr val="F8FAFC"/>
+                            <a:srgbClr val="FFFFFF"/>
                           </a:solidFill>
                         </a:defRPr>
                       </a:pPr>
@@ -7162,7 +6014,7 @@
                       <a:pPr>
                         <a:defRPr sz="1100">
                           <a:solidFill>
-                            <a:srgbClr val="F8FAFC"/>
+                            <a:srgbClr val="FFFFFF"/>
                           </a:solidFill>
                         </a:defRPr>
                       </a:pPr>
@@ -7185,7 +6037,7 @@
                       <a:pPr>
                         <a:defRPr sz="1100">
                           <a:solidFill>
-                            <a:srgbClr val="F8FAFC"/>
+                            <a:srgbClr val="FFFFFF"/>
                           </a:solidFill>
                         </a:defRPr>
                       </a:pPr>
@@ -7208,7 +6060,7 @@
                       <a:pPr>
                         <a:defRPr sz="1100">
                           <a:solidFill>
-                            <a:srgbClr val="F8FAFC"/>
+                            <a:srgbClr val="FFFFFF"/>
                           </a:solidFill>
                         </a:defRPr>
                       </a:pPr>
@@ -7231,7 +6083,7 @@
                       <a:pPr>
                         <a:defRPr sz="1100">
                           <a:solidFill>
-                            <a:srgbClr val="F8FAFC"/>
+                            <a:srgbClr val="FFFFFF"/>
                           </a:solidFill>
                         </a:defRPr>
                       </a:pPr>
@@ -7256,7 +6108,7 @@
                       <a:pPr>
                         <a:defRPr sz="1100" b="1">
                           <a:solidFill>
-                            <a:srgbClr val="F8FAFC"/>
+                            <a:srgbClr val="FFFFFF"/>
                           </a:solidFill>
                         </a:defRPr>
                       </a:pPr>
@@ -7279,7 +6131,7 @@
                       <a:pPr>
                         <a:defRPr sz="1100" b="1">
                           <a:solidFill>
-                            <a:srgbClr val="F8FAFC"/>
+                            <a:srgbClr val="FFFFFF"/>
                           </a:solidFill>
                         </a:defRPr>
                       </a:pPr>
@@ -7302,7 +6154,7 @@
                       <a:pPr>
                         <a:defRPr sz="1100" b="1">
                           <a:solidFill>
-                            <a:srgbClr val="F8FAFC"/>
+                            <a:srgbClr val="FFFFFF"/>
                           </a:solidFill>
                         </a:defRPr>
                       </a:pPr>
@@ -7325,7 +6177,7 @@
                       <a:pPr>
                         <a:defRPr sz="1100" b="1">
                           <a:solidFill>
-                            <a:srgbClr val="F8FAFC"/>
+                            <a:srgbClr val="FFFFFF"/>
                           </a:solidFill>
                         </a:defRPr>
                       </a:pPr>
@@ -7490,7 +6342,7 @@
             <a:pPr>
               <a:defRPr sz="2400" b="1">
                 <a:solidFill>
-                  <a:srgbClr val="F8FAFC"/>
+                  <a:srgbClr val="FFFFFF"/>
                 </a:solidFill>
               </a:defRPr>
             </a:pPr>
@@ -7553,8 +6405,8 @@
         </p:nvSpPr>
         <p:spPr>
           <a:xfrm>
-            <a:off x="868680" y="1828800"/>
-            <a:ext cx="2286000" cy="4023360"/>
+            <a:off x="896112" y="1828800"/>
+            <a:ext cx="2231136" cy="4023360"/>
           </a:xfrm>
           <a:prstGeom prst="rect">
             <a:avLst/>
@@ -7583,9 +6435,9 @@
               <a:spcBef>
                 <a:spcPts val="1200"/>
               </a:spcBef>
-              <a:defRPr sz="1100">
-                <a:solidFill>
-                  <a:srgbClr val="F8FAFC"/>
+              <a:defRPr sz="1150">
+                <a:solidFill>
+                  <a:srgbClr val="FFFFFF"/>
                 </a:solidFill>
               </a:defRPr>
             </a:pPr>
@@ -7653,8 +6505,8 @@
         </p:nvSpPr>
         <p:spPr>
           <a:xfrm>
-            <a:off x="3566160" y="1828800"/>
-            <a:ext cx="2286000" cy="4023360"/>
+            <a:off x="3593592" y="1828800"/>
+            <a:ext cx="2231136" cy="4023360"/>
           </a:xfrm>
           <a:prstGeom prst="rect">
             <a:avLst/>
@@ -7683,9 +6535,9 @@
               <a:spcBef>
                 <a:spcPts val="1200"/>
               </a:spcBef>
-              <a:defRPr sz="1100">
-                <a:solidFill>
-                  <a:srgbClr val="F8FAFC"/>
+              <a:defRPr sz="1150">
+                <a:solidFill>
+                  <a:srgbClr val="FFFFFF"/>
                 </a:solidFill>
               </a:defRPr>
             </a:pPr>
@@ -7753,8 +6605,8 @@
         </p:nvSpPr>
         <p:spPr>
           <a:xfrm>
-            <a:off x="6263640" y="1828800"/>
-            <a:ext cx="2286000" cy="4023360"/>
+            <a:off x="6291072" y="1828800"/>
+            <a:ext cx="2231136" cy="4023360"/>
           </a:xfrm>
           <a:prstGeom prst="rect">
             <a:avLst/>
@@ -7783,9 +6635,9 @@
               <a:spcBef>
                 <a:spcPts val="1200"/>
               </a:spcBef>
-              <a:defRPr sz="1100">
-                <a:solidFill>
-                  <a:srgbClr val="F8FAFC"/>
+              <a:defRPr sz="1150">
+                <a:solidFill>
+                  <a:srgbClr val="FFFFFF"/>
                 </a:solidFill>
               </a:defRPr>
             </a:pPr>
@@ -7853,8 +6705,8 @@
         </p:nvSpPr>
         <p:spPr>
           <a:xfrm>
-            <a:off x="8961120" y="1828800"/>
-            <a:ext cx="2286000" cy="4023360"/>
+            <a:off x="8988552" y="1828800"/>
+            <a:ext cx="2231136" cy="4023360"/>
           </a:xfrm>
           <a:prstGeom prst="rect">
             <a:avLst/>
@@ -7883,9 +6735,9 @@
               <a:spcBef>
                 <a:spcPts val="1200"/>
               </a:spcBef>
-              <a:defRPr sz="1100">
-                <a:solidFill>
-                  <a:srgbClr val="F8FAFC"/>
+              <a:defRPr sz="1150">
+                <a:solidFill>
+                  <a:srgbClr val="FFFFFF"/>
                 </a:solidFill>
               </a:defRPr>
             </a:pPr>
@@ -8021,7 +6873,7 @@
             <a:pPr>
               <a:defRPr sz="2400" b="1">
                 <a:solidFill>
-                  <a:srgbClr val="F8FAFC"/>
+                  <a:srgbClr val="FFFFFF"/>
                 </a:solidFill>
               </a:defRPr>
             </a:pPr>
@@ -8069,9 +6921,9 @@
               <a:spcBef>
                 <a:spcPts val="1000"/>
               </a:spcBef>
-              <a:defRPr sz="1250">
-                <a:solidFill>
-                  <a:srgbClr val="F8FAFC"/>
+              <a:defRPr sz="1300">
+                <a:solidFill>
+                  <a:srgbClr val="FFFFFF"/>
                 </a:solidFill>
               </a:defRPr>
             </a:pPr>
@@ -8084,9 +6936,9 @@
               <a:spcBef>
                 <a:spcPts val="1000"/>
               </a:spcBef>
-              <a:defRPr sz="1250">
-                <a:solidFill>
-                  <a:srgbClr val="F8FAFC"/>
+              <a:defRPr sz="1300">
+                <a:solidFill>
+                  <a:srgbClr val="FFFFFF"/>
                 </a:solidFill>
               </a:defRPr>
             </a:pPr>
@@ -8099,9 +6951,9 @@
               <a:spcBef>
                 <a:spcPts val="1000"/>
               </a:spcBef>
-              <a:defRPr sz="1250">
-                <a:solidFill>
-                  <a:srgbClr val="F8FAFC"/>
+              <a:defRPr sz="1300">
+                <a:solidFill>
+                  <a:srgbClr val="FFFFFF"/>
                 </a:solidFill>
               </a:defRPr>
             </a:pPr>
@@ -8114,9 +6966,9 @@
               <a:spcBef>
                 <a:spcPts val="1000"/>
               </a:spcBef>
-              <a:defRPr sz="1250">
-                <a:solidFill>
-                  <a:srgbClr val="F8FAFC"/>
+              <a:defRPr sz="1300">
+                <a:solidFill>
+                  <a:srgbClr val="FFFFFF"/>
                 </a:solidFill>
               </a:defRPr>
             </a:pPr>
@@ -8209,9 +7061,9 @@
               <a:spcBef>
                 <a:spcPts val="1000"/>
               </a:spcBef>
-              <a:defRPr sz="1100">
-                <a:solidFill>
-                  <a:srgbClr val="F8FAFC"/>
+              <a:defRPr sz="1150">
+                <a:solidFill>
+                  <a:srgbClr val="FFFFFF"/>
                 </a:solidFill>
               </a:defRPr>
             </a:pPr>
@@ -8385,7 +7237,7 @@
             <a:pPr>
               <a:defRPr sz="2400" b="1">
                 <a:solidFill>
-                  <a:srgbClr val="F8FAFC"/>
+                  <a:srgbClr val="FFFFFF"/>
                 </a:solidFill>
               </a:defRPr>
             </a:pPr>
@@ -8418,7 +7270,7 @@
           <a:lstStyle/>
           <a:p>
             <a:pPr>
-              <a:defRPr sz="1600" b="1">
+              <a:defRPr sz="1700" b="1">
                 <a:solidFill>
                   <a:srgbClr val="34D399"/>
                 </a:solidFill>
@@ -8433,9 +7285,9 @@
               <a:spcBef>
                 <a:spcPts val="800"/>
               </a:spcBef>
-              <a:defRPr sz="1200">
-                <a:solidFill>
-                  <a:srgbClr val="F8FAFC"/>
+              <a:defRPr sz="1250">
+                <a:solidFill>
+                  <a:srgbClr val="FFFFFF"/>
                 </a:solidFill>
               </a:defRPr>
             </a:pPr>
@@ -8448,9 +7300,9 @@
               <a:spcBef>
                 <a:spcPts val="800"/>
               </a:spcBef>
-              <a:defRPr sz="1200">
-                <a:solidFill>
-                  <a:srgbClr val="F8FAFC"/>
+              <a:defRPr sz="1250">
+                <a:solidFill>
+                  <a:srgbClr val="FFFFFF"/>
                 </a:solidFill>
               </a:defRPr>
             </a:pPr>
@@ -8475,9 +7327,9 @@
               <a:spcBef>
                 <a:spcPts val="800"/>
               </a:spcBef>
-              <a:defRPr sz="1200">
-                <a:solidFill>
-                  <a:srgbClr val="F8FAFC"/>
+              <a:defRPr sz="1250">
+                <a:solidFill>
+                  <a:srgbClr val="FFFFFF"/>
                 </a:solidFill>
               </a:defRPr>
             </a:pPr>
@@ -8490,9 +7342,9 @@
               <a:spcBef>
                 <a:spcPts val="800"/>
               </a:spcBef>
-              <a:defRPr sz="1200">
-                <a:solidFill>
-                  <a:srgbClr val="F8FAFC"/>
+              <a:defRPr sz="1250">
+                <a:solidFill>
+                  <a:srgbClr val="FFFFFF"/>
                 </a:solidFill>
               </a:defRPr>
             </a:pPr>
@@ -8659,7 +7511,7 @@
             <a:pPr>
               <a:defRPr sz="2400" b="1">
                 <a:solidFill>
-                  <a:srgbClr val="F8FAFC"/>
+                  <a:srgbClr val="FFFFFF"/>
                 </a:solidFill>
               </a:defRPr>
             </a:pPr>
@@ -8692,7 +7544,7 @@
           <a:lstStyle/>
           <a:p>
             <a:pPr>
-              <a:defRPr sz="1600" b="1">
+              <a:defRPr sz="1700" b="1">
                 <a:solidFill>
                   <a:srgbClr val="38BDF8"/>
                 </a:solidFill>
@@ -8707,9 +7559,9 @@
               <a:spcBef>
                 <a:spcPts val="800"/>
               </a:spcBef>
-              <a:defRPr sz="1150">
-                <a:solidFill>
-                  <a:srgbClr val="F8FAFC"/>
+              <a:defRPr sz="1200">
+                <a:solidFill>
+                  <a:srgbClr val="FFFFFF"/>
                 </a:solidFill>
               </a:defRPr>
             </a:pPr>
@@ -8722,9 +7574,9 @@
               <a:spcBef>
                 <a:spcPts val="800"/>
               </a:spcBef>
-              <a:defRPr sz="1150">
-                <a:solidFill>
-                  <a:srgbClr val="F8FAFC"/>
+              <a:defRPr sz="1200">
+                <a:solidFill>
+                  <a:srgbClr val="FFFFFF"/>
                 </a:solidFill>
               </a:defRPr>
             </a:pPr>
@@ -8737,9 +7589,9 @@
               <a:spcBef>
                 <a:spcPts val="800"/>
               </a:spcBef>
-              <a:defRPr sz="1150">
-                <a:solidFill>
-                  <a:srgbClr val="F8FAFC"/>
+              <a:defRPr sz="1200">
+                <a:solidFill>
+                  <a:srgbClr val="FFFFFF"/>
                 </a:solidFill>
               </a:defRPr>
             </a:pPr>
@@ -8764,9 +7616,9 @@
               <a:spcBef>
                 <a:spcPts val="800"/>
               </a:spcBef>
-              <a:defRPr sz="1150">
-                <a:solidFill>
-                  <a:srgbClr val="F8FAFC"/>
+              <a:defRPr sz="1200">
+                <a:solidFill>
+                  <a:srgbClr val="FFFFFF"/>
                 </a:solidFill>
               </a:defRPr>
             </a:pPr>
@@ -9126,324 +7978,4 @@
   </a:objectDefaults>
   <a:extraClrSchemeLst/>
 </a:theme>
-</file>
-
-<file path=ppt/theme/theme2.xml><?xml version="1.0" encoding="utf-8"?>
-<a:theme xmlns:a="http://schemas.openxmlformats.org/drawingml/2006/main" name="Office Theme">
-  <a:themeElements>
-    <a:clrScheme name="Office">
-      <a:dk1>
-        <a:sysClr val="windowText" lastClr="000000"/>
-      </a:dk1>
-      <a:lt1>
-        <a:sysClr val="window" lastClr="FFFFFF"/>
-      </a:lt1>
-      <a:dk2>
-        <a:srgbClr val="1F497D"/>
-      </a:dk2>
-      <a:lt2>
-        <a:srgbClr val="EEECE1"/>
-      </a:lt2>
-      <a:accent1>
-        <a:srgbClr val="4F81BD"/>
-      </a:accent1>
-      <a:accent2>
-        <a:srgbClr val="C0504D"/>
-      </a:accent2>
-      <a:accent3>
-        <a:srgbClr val="9BBB59"/>
-      </a:accent3>
-      <a:accent4>
-        <a:srgbClr val="8064A2"/>
-      </a:accent4>
-      <a:accent5>
-        <a:srgbClr val="4BACC6"/>
-      </a:accent5>
-      <a:accent6>
-        <a:srgbClr val="F79646"/>
-      </a:accent6>
-      <a:hlink>
-        <a:srgbClr val="0000FF"/>
-      </a:hlink>
-      <a:folHlink>
-        <a:srgbClr val="800080"/>
-      </a:folHlink>
-    </a:clrScheme>
-    <a:fontScheme name="Office">
-      <a:majorFont>
-        <a:latin typeface="Calibri"/>
-        <a:ea typeface=""/>
-        <a:cs typeface=""/>
-        <a:font script="Jpan" typeface="ＭＳ Ｐゴシック"/>
-        <a:font script="Hang" typeface="맑은 고딕"/>
-        <a:font script="Hans" typeface="宋体"/>
-        <a:font script="Hant" typeface="新細明體"/>
-        <a:font script="Arab" typeface="Times New Roman"/>
-        <a:font script="Hebr" typeface="Times New Roman"/>
-        <a:font script="Thai" typeface="Angsana New"/>
-        <a:font script="Ethi" typeface="Nyala"/>
-        <a:font script="Beng" typeface="Vrinda"/>
-        <a:font script="Gujr" typeface="Shruti"/>
-        <a:font script="Khmr" typeface="MoolBoran"/>
-        <a:font script="Knda" typeface="Tunga"/>
-        <a:font script="Guru" typeface="Raavi"/>
-        <a:font script="Cans" typeface="Euphemia"/>
-        <a:font script="Cher" typeface="Plantagenet Cherokee"/>
-        <a:font script="Yiii" typeface="Microsoft Yi Baiti"/>
-        <a:font script="Tibt" typeface="Microsoft Himalaya"/>
-        <a:font script="Thaa" typeface="MV Boli"/>
-        <a:font script="Deva" typeface="Mangal"/>
-        <a:font script="Telu" typeface="Gautami"/>
-        <a:font script="Taml" typeface="Latha"/>
-        <a:font script="Syrc" typeface="Estrangelo Edessa"/>
-        <a:font script="Orya" typeface="Kalinga"/>
-        <a:font script="Mlym" typeface="Kartika"/>
-        <a:font script="Laoo" typeface="DokChampa"/>
-        <a:font script="Sinh" typeface="Iskoola Pota"/>
-        <a:font script="Mong" typeface="Mongolian Baiti"/>
-        <a:font script="Viet" typeface="Times New Roman"/>
-        <a:font script="Uigh" typeface="Microsoft Uighur"/>
-        <a:font script="Geor" typeface="Sylfaen"/>
-      </a:majorFont>
-      <a:minorFont>
-        <a:latin typeface="Calibri"/>
-        <a:ea typeface=""/>
-        <a:cs typeface=""/>
-        <a:font script="Jpan" typeface="ＭＳ Ｐゴシック"/>
-        <a:font script="Hang" typeface="맑은 고딕"/>
-        <a:font script="Hans" typeface="宋体"/>
-        <a:font script="Hant" typeface="新細明體"/>
-        <a:font script="Arab" typeface="Arial"/>
-        <a:font script="Hebr" typeface="Arial"/>
-        <a:font script="Thai" typeface="Cordia New"/>
-        <a:font script="Ethi" typeface="Nyala"/>
-        <a:font script="Beng" typeface="Vrinda"/>
-        <a:font script="Gujr" typeface="Shruti"/>
-        <a:font script="Khmr" typeface="DaunPenh"/>
-        <a:font script="Knda" typeface="Tunga"/>
-        <a:font script="Guru" typeface="Raavi"/>
-        <a:font script="Cans" typeface="Euphemia"/>
-        <a:font script="Cher" typeface="Plantagenet Cherokee"/>
-        <a:font script="Yiii" typeface="Microsoft Yi Baiti"/>
-        <a:font script="Tibt" typeface="Microsoft Himalaya"/>
-        <a:font script="Thaa" typeface="MV Boli"/>
-        <a:font script="Deva" typeface="Mangal"/>
-        <a:font script="Telu" typeface="Gautami"/>
-        <a:font script="Taml" typeface="Latha"/>
-        <a:font script="Syrc" typeface="Estrangelo Edessa"/>
-        <a:font script="Orya" typeface="Kalinga"/>
-        <a:font script="Mlym" typeface="Kartika"/>
-        <a:font script="Laoo" typeface="DokChampa"/>
-        <a:font script="Sinh" typeface="Iskoola Pota"/>
-        <a:font script="Mong" typeface="Mongolian Baiti"/>
-        <a:font script="Viet" typeface="Arial"/>
-        <a:font script="Uigh" typeface="Microsoft Uighur"/>
-        <a:font script="Geor" typeface="Sylfaen"/>
-      </a:minorFont>
-    </a:fontScheme>
-    <a:fmtScheme name="Office">
-      <a:fillStyleLst>
-        <a:solidFill>
-          <a:schemeClr val="phClr"/>
-        </a:solidFill>
-        <a:gradFill rotWithShape="1">
-          <a:gsLst>
-            <a:gs pos="0">
-              <a:schemeClr val="phClr">
-                <a:tint val="50000"/>
-                <a:satMod val="300000"/>
-              </a:schemeClr>
-            </a:gs>
-            <a:gs pos="35000">
-              <a:schemeClr val="phClr">
-                <a:tint val="37000"/>
-                <a:satMod val="300000"/>
-              </a:schemeClr>
-            </a:gs>
-            <a:gs pos="100000">
-              <a:schemeClr val="phClr">
-                <a:tint val="15000"/>
-                <a:satMod val="350000"/>
-              </a:schemeClr>
-            </a:gs>
-          </a:gsLst>
-          <a:lin ang="16200000" scaled="1"/>
-        </a:gradFill>
-        <a:gradFill rotWithShape="1">
-          <a:gsLst>
-            <a:gs pos="0">
-              <a:schemeClr val="phClr">
-                <a:tint val="100000"/>
-                <a:shade val="100000"/>
-                <a:satMod val="130000"/>
-              </a:schemeClr>
-            </a:gs>
-            <a:gs pos="100000">
-              <a:schemeClr val="phClr">
-                <a:tint val="50000"/>
-                <a:shade val="100000"/>
-                <a:satMod val="350000"/>
-              </a:schemeClr>
-            </a:gs>
-          </a:gsLst>
-          <a:lin ang="16200000" scaled="0"/>
-        </a:gradFill>
-      </a:fillStyleLst>
-      <a:lnStyleLst>
-        <a:ln w="9525" cap="flat" cmpd="sng" algn="ctr">
-          <a:solidFill>
-            <a:schemeClr val="phClr">
-              <a:shade val="95000"/>
-              <a:satMod val="105000"/>
-            </a:schemeClr>
-          </a:solidFill>
-          <a:prstDash val="solid"/>
-        </a:ln>
-        <a:ln w="25400" cap="flat" cmpd="sng" algn="ctr">
-          <a:solidFill>
-            <a:schemeClr val="phClr"/>
-          </a:solidFill>
-          <a:prstDash val="solid"/>
-        </a:ln>
-        <a:ln w="38100" cap="flat" cmpd="sng" algn="ctr">
-          <a:solidFill>
-            <a:schemeClr val="phClr"/>
-          </a:solidFill>
-          <a:prstDash val="solid"/>
-        </a:ln>
-      </a:lnStyleLst>
-      <a:effectStyleLst>
-        <a:effectStyle>
-          <a:effectLst>
-            <a:outerShdw blurRad="40000" dist="20000" dir="5400000" rotWithShape="0">
-              <a:srgbClr val="000000">
-                <a:alpha val="38000"/>
-              </a:srgbClr>
-            </a:outerShdw>
-          </a:effectLst>
-        </a:effectStyle>
-        <a:effectStyle>
-          <a:effectLst>
-            <a:outerShdw blurRad="40000" dist="23000" dir="5400000" rotWithShape="0">
-              <a:srgbClr val="000000">
-                <a:alpha val="35000"/>
-              </a:srgbClr>
-            </a:outerShdw>
-          </a:effectLst>
-        </a:effectStyle>
-        <a:effectStyle>
-          <a:effectLst>
-            <a:outerShdw blurRad="40000" dist="23000" dir="5400000" rotWithShape="0">
-              <a:srgbClr val="000000">
-                <a:alpha val="35000"/>
-              </a:srgbClr>
-            </a:outerShdw>
-          </a:effectLst>
-          <a:scene3d>
-            <a:camera prst="orthographicFront">
-              <a:rot lat="0" lon="0" rev="0"/>
-            </a:camera>
-            <a:lightRig rig="threePt" dir="t">
-              <a:rot lat="0" lon="0" rev="1200000"/>
-            </a:lightRig>
-          </a:scene3d>
-          <a:sp3d>
-            <a:bevelT w="63500" h="25400"/>
-          </a:sp3d>
-        </a:effectStyle>
-      </a:effectStyleLst>
-      <a:bgFillStyleLst>
-        <a:solidFill>
-          <a:schemeClr val="phClr"/>
-        </a:solidFill>
-        <a:gradFill rotWithShape="1">
-          <a:gsLst>
-            <a:gs pos="0">
-              <a:schemeClr val="phClr">
-                <a:tint val="40000"/>
-                <a:satMod val="350000"/>
-              </a:schemeClr>
-            </a:gs>
-            <a:gs pos="40000">
-              <a:schemeClr val="phClr">
-                <a:tint val="45000"/>
-                <a:shade val="99000"/>
-                <a:satMod val="350000"/>
-              </a:schemeClr>
-            </a:gs>
-            <a:gs pos="100000">
-              <a:schemeClr val="phClr">
-                <a:shade val="20000"/>
-                <a:satMod val="255000"/>
-              </a:schemeClr>
-            </a:gs>
-          </a:gsLst>
-          <a:path path="circle">
-            <a:fillToRect l="50000" t="-80000" r="50000" b="180000"/>
-          </a:path>
-        </a:gradFill>
-        <a:gradFill rotWithShape="1">
-          <a:gsLst>
-            <a:gs pos="0">
-              <a:schemeClr val="phClr">
-                <a:tint val="80000"/>
-                <a:satMod val="300000"/>
-              </a:schemeClr>
-            </a:gs>
-            <a:gs pos="100000">
-              <a:schemeClr val="phClr">
-                <a:shade val="30000"/>
-                <a:satMod val="200000"/>
-              </a:schemeClr>
-            </a:gs>
-          </a:gsLst>
-          <a:path path="circle">
-            <a:fillToRect l="50000" t="50000" r="50000" b="50000"/>
-          </a:path>
-        </a:gradFill>
-      </a:bgFillStyleLst>
-    </a:fmtScheme>
-  </a:themeElements>
-  <a:objectDefaults>
-    <a:spDef>
-      <a:spPr/>
-      <a:bodyPr/>
-      <a:lstStyle/>
-      <a:style>
-        <a:lnRef idx="1">
-          <a:schemeClr val="accent1"/>
-        </a:lnRef>
-        <a:fillRef idx="3">
-          <a:schemeClr val="accent1"/>
-        </a:fillRef>
-        <a:effectRef idx="2">
-          <a:schemeClr val="accent1"/>
-        </a:effectRef>
-        <a:fontRef idx="minor">
-          <a:schemeClr val="lt1"/>
-        </a:fontRef>
-      </a:style>
-    </a:spDef>
-    <a:lnDef>
-      <a:spPr/>
-      <a:bodyPr/>
-      <a:lstStyle/>
-      <a:style>
-        <a:lnRef idx="2">
-          <a:schemeClr val="accent1"/>
-        </a:lnRef>
-        <a:fillRef idx="0">
-          <a:schemeClr val="accent1"/>
-        </a:fillRef>
-        <a:effectRef idx="1">
-          <a:schemeClr val="accent1"/>
-        </a:effectRef>
-        <a:fontRef idx="minor">
-          <a:schemeClr val="tx1"/>
-        </a:fontRef>
-      </a:style>
-    </a:lnDef>
-  </a:objectDefaults>
-  <a:extraClrSchemeLst/>
-</a:theme>
 </file>
</xml_diff>

<commit_message>
Embed system architecture diagram and enforce pure white font colors
</commit_message>
<xml_diff>
--- a/Coal_GCV_Prediction_Presentation.pptx
+++ b/Coal_GCV_Prediction_Presentation.pptx
@@ -3149,8 +3149,8 @@
         </p:nvSpPr>
         <p:spPr>
           <a:xfrm>
-            <a:off x="731520" y="2011680"/>
-            <a:ext cx="164592" cy="2560320"/>
+            <a:off x="731520" y="1645920"/>
+            <a:ext cx="164592" cy="3474720"/>
           </a:xfrm>
           <a:prstGeom prst="rect">
             <a:avLst/>
@@ -3192,8 +3192,8 @@
         </p:nvSpPr>
         <p:spPr>
           <a:xfrm>
-            <a:off x="1097280" y="1920240"/>
-            <a:ext cx="10241280" cy="2926080"/>
+            <a:off x="1097280" y="1645920"/>
+            <a:ext cx="10241280" cy="3840480"/>
           </a:xfrm>
           <a:prstGeom prst="rect">
             <a:avLst/>
@@ -3206,30 +3206,71 @@
           </a:bodyPr>
           <a:lstStyle/>
           <a:p>
-            <a:pPr>
-              <a:defRPr sz="3800" b="1">
+            <a:r>
+              <a:rPr sz="3600" b="1">
                 <a:solidFill>
                   <a:srgbClr val="FFFFFF"/>
                 </a:solidFill>
-              </a:defRPr>
-            </a:pPr>
-            <a:r>
+              </a:rPr>
               <a:t>COAL GROSS CALORIFIC VALUE (GCV) PREDICTION</a:t>
             </a:r>
           </a:p>
           <a:p>
             <a:pPr>
               <a:spcBef>
-                <a:spcPts val="1600"/>
+                <a:spcPts val="1200"/>
               </a:spcBef>
-              <a:defRPr sz="2100" b="1">
+            </a:pPr>
+            <a:r>
+              <a:rPr sz="2000" b="1">
                 <a:solidFill>
                   <a:srgbClr val="38BDF8"/>
                 </a:solidFill>
-              </a:defRPr>
+              </a:rPr>
+              <a:t>High-Precision Estimation from Proximate Analysis via Bayesian-Tuned Stacking Ensembles</a:t>
+            </a:r>
+          </a:p>
+          <a:p>
+            <a:pPr>
+              <a:spcBef>
+                <a:spcPts val="2000"/>
+              </a:spcBef>
             </a:pPr>
             <a:r>
-              <a:t>High-Precision Estimation from Proximate Analysis via Bayesian-Tuned Stacking Ensembles</a:t>
+              <a:rPr sz="1400" b="0">
+                <a:solidFill>
+                  <a:srgbClr val="FFFFFF"/>
+                </a:solidFill>
+              </a:rPr>
+              <a:t>• Optimized Machine Learning Architecture (XGBoost, Random Forest, SVR + Ridge Meta-Learner)
+</a:t>
+            </a:r>
+            <a:r>
+              <a:rPr sz="1400" b="0">
+                <a:solidFill>
+                  <a:srgbClr val="FFFFFF"/>
+                </a:solidFill>
+              </a:rPr>
+              <a:t>• Zero-Leakage Data Hygiene &amp; ASTM D388 Coal Rank Specialization
+</a:t>
+            </a:r>
+            <a:r>
+              <a:rPr sz="1400" b="0">
+                <a:solidFill>
+                  <a:srgbClr val="FFFFFF"/>
+                </a:solidFill>
+              </a:rPr>
+              <a:t>• Model Interpretability via SHAP (SHapley Additive exPlanations)
+</a:t>
+            </a:r>
+            <a:r>
+              <a:rPr sz="1400" b="0">
+                <a:solidFill>
+                  <a:srgbClr val="FFFFFF"/>
+                </a:solidFill>
+              </a:rPr>
+              <a:t>• Live Interactive Web Deployment with Chemical Safety Guardrails
+</a:t>
             </a:r>
           </a:p>
         </p:txBody>
@@ -3317,14 +3358,12 @@
           </a:bodyPr>
           <a:lstStyle/>
           <a:p>
-            <a:pPr>
-              <a:defRPr sz="1100" b="1">
+            <a:r>
+              <a:rPr sz="1100" b="1">
                 <a:solidFill>
                   <a:srgbClr val="38BDF8"/>
                 </a:solidFill>
-              </a:defRPr>
-            </a:pPr>
-            <a:r>
+              </a:rPr>
               <a:t>SYSTEM DEPLOYMENT</a:t>
             </a:r>
           </a:p>
@@ -3352,14 +3391,12 @@
           </a:bodyPr>
           <a:lstStyle/>
           <a:p>
-            <a:pPr>
-              <a:defRPr sz="2400" b="1">
+            <a:r>
+              <a:rPr sz="2400" b="1">
                 <a:solidFill>
                   <a:srgbClr val="FFFFFF"/>
                 </a:solidFill>
-              </a:defRPr>
-            </a:pPr>
-            <a:r>
+              </a:rPr>
               <a:t>Interactive Streamlit Deployment &amp; Domain Guardrails</a:t>
             </a:r>
           </a:p>
@@ -3432,14 +3469,12 @@
           </a:bodyPr>
           <a:lstStyle/>
           <a:p>
-            <a:pPr>
-              <a:defRPr sz="1600" b="1">
+            <a:r>
+              <a:rPr sz="1600" b="1">
                 <a:solidFill>
                   <a:srgbClr val="38BDF8"/>
                 </a:solidFill>
-              </a:defRPr>
-            </a:pPr>
-            <a:r>
+              </a:rPr>
               <a:t>Dual-Tab Architecture</a:t>
             </a:r>
           </a:p>
@@ -3448,22 +3483,16 @@
               <a:spcBef>
                 <a:spcPts val="800"/>
               </a:spcBef>
-              <a:defRPr sz="1200">
+            </a:pPr>
+            <a:r>
+              <a:rPr sz="1200" b="0">
                 <a:solidFill>
                   <a:srgbClr val="FFFFFF"/>
                 </a:solidFill>
-              </a:defRPr>
-            </a:pPr>
-            <a:r>
-              <a:t>• Tab 1: Universal Model (All coal ranks)</a:t>
-            </a:r>
-            <a:br/>
-            <a:r>
-              <a:t>• Tab 2: Bituminous Specialized Model (ASTM D388)</a:t>
-            </a:r>
-            <a:br/>
-            <a:r>
-              <a:t>Users seamlessly switch between general coal and high-precision bituminous mode.</a:t>
+              </a:rPr>
+              <a:t>• Tab 1: Universal Model (All coal ranks)
+• Tab 2: Bituminous Specialized Model (ASTM D388)
+Users seamlessly switch between general coal and high-precision bituminous mode.</a:t>
             </a:r>
           </a:p>
         </p:txBody>
@@ -3535,14 +3564,12 @@
           </a:bodyPr>
           <a:lstStyle/>
           <a:p>
-            <a:pPr>
-              <a:defRPr sz="1600" b="1">
+            <a:r>
+              <a:rPr sz="1600" b="1">
                 <a:solidFill>
                   <a:srgbClr val="FB923C"/>
                 </a:solidFill>
-              </a:defRPr>
-            </a:pPr>
-            <a:r>
+              </a:rPr>
               <a:t>Domain-Specific Guardrails</a:t>
             </a:r>
           </a:p>
@@ -3551,18 +3578,15 @@
               <a:spcBef>
                 <a:spcPts val="800"/>
               </a:spcBef>
-              <a:defRPr sz="1200">
+            </a:pPr>
+            <a:r>
+              <a:rPr sz="1200" b="0">
                 <a:solidFill>
                   <a:srgbClr val="FFFFFF"/>
                 </a:solidFill>
-              </a:defRPr>
-            </a:pPr>
-            <a:r>
-              <a:t>• Mass Balance Validation: Flags an immediate error if Moisture + VM + Ash &gt; 100%.</a:t>
-            </a:r>
-            <a:br/>
-            <a:r>
-              <a:t>• Ash Limit Rule: Rejects inputs exceeding realistic combustible limits (Ash &gt; 55%).</a:t>
+              </a:rPr>
+              <a:t>• Mass Balance Validation: Flags an immediate error if Moisture + VM + Ash &gt; 100%.
+• Ash Limit Rule: Rejects inputs exceeding realistic combustible limits (Ash &gt; 55%).</a:t>
             </a:r>
           </a:p>
         </p:txBody>
@@ -3634,14 +3658,12 @@
           </a:bodyPr>
           <a:lstStyle/>
           <a:p>
-            <a:pPr>
-              <a:defRPr sz="1600" b="1">
+            <a:r>
+              <a:rPr sz="1600" b="1">
                 <a:solidFill>
                   <a:srgbClr val="34D399"/>
                 </a:solidFill>
-              </a:defRPr>
-            </a:pPr>
-            <a:r>
+              </a:rPr>
               <a:t>Real-Time Explainability</a:t>
             </a:r>
           </a:p>
@@ -3650,13 +3672,13 @@
               <a:spcBef>
                 <a:spcPts val="800"/>
               </a:spcBef>
-              <a:defRPr sz="1200">
+            </a:pPr>
+            <a:r>
+              <a:rPr sz="1200" b="0">
                 <a:solidFill>
                   <a:srgbClr val="FFFFFF"/>
                 </a:solidFill>
-              </a:defRPr>
-            </a:pPr>
-            <a:r>
+              </a:rPr>
               <a:t>Every slider adjustment instantly triggers model re-prediction and renders dynamic SHAP waterfall plots explaining the chemical drivers behind that specific prediction.</a:t>
             </a:r>
           </a:p>
@@ -3729,14 +3751,12 @@
           </a:bodyPr>
           <a:lstStyle/>
           <a:p>
-            <a:pPr>
-              <a:defRPr sz="1600" b="1">
+            <a:r>
+              <a:rPr sz="1600" b="1">
                 <a:solidFill>
                   <a:srgbClr val="38BDF8"/>
                 </a:solidFill>
-              </a:defRPr>
-            </a:pPr>
-            <a:r>
+              </a:rPr>
               <a:t>Production Cloud Ready</a:t>
             </a:r>
           </a:p>
@@ -3745,13 +3765,13 @@
               <a:spcBef>
                 <a:spcPts val="800"/>
               </a:spcBef>
-              <a:defRPr sz="1200">
+            </a:pPr>
+            <a:r>
+              <a:rPr sz="1200" b="0">
                 <a:solidFill>
                   <a:srgbClr val="FFFFFF"/>
                 </a:solidFill>
-              </a:defRPr>
-            </a:pPr>
-            <a:r>
+              </a:rPr>
               <a:t>Deployed via Streamlit Community Cloud with GitHub CI/CD tracking main branch. Serialized models (&lt;20MB) load in sub-second inference speed.</a:t>
             </a:r>
           </a:p>
@@ -3840,14 +3860,12 @@
           </a:bodyPr>
           <a:lstStyle/>
           <a:p>
-            <a:pPr>
-              <a:defRPr sz="1100" b="1">
+            <a:r>
+              <a:rPr sz="1100" b="1">
                 <a:solidFill>
                   <a:srgbClr val="38BDF8"/>
                 </a:solidFill>
-              </a:defRPr>
-            </a:pPr>
-            <a:r>
+              </a:rPr>
               <a:t>CONCLUSION &amp; ROADMAP</a:t>
             </a:r>
           </a:p>
@@ -3875,14 +3893,12 @@
           </a:bodyPr>
           <a:lstStyle/>
           <a:p>
-            <a:pPr>
-              <a:defRPr sz="2400" b="1">
+            <a:r>
+              <a:rPr sz="2400" b="1">
                 <a:solidFill>
                   <a:srgbClr val="FFFFFF"/>
                 </a:solidFill>
-              </a:defRPr>
-            </a:pPr>
-            <a:r>
+              </a:rPr>
               <a:t>Project Summary &amp; Future Research Directions</a:t>
             </a:r>
           </a:p>
@@ -3955,14 +3971,12 @@
           </a:bodyPr>
           <a:lstStyle/>
           <a:p>
-            <a:pPr>
-              <a:defRPr sz="1700" b="1">
+            <a:r>
+              <a:rPr sz="1700" b="1">
                 <a:solidFill>
                   <a:srgbClr val="34D399"/>
                 </a:solidFill>
-              </a:defRPr>
-            </a:pPr>
-            <a:r>
+              </a:rPr>
               <a:t>Final Performance Summary:</a:t>
             </a:r>
           </a:p>
@@ -3971,51 +3985,23 @@
               <a:spcBef>
                 <a:spcPts val="1000"/>
               </a:spcBef>
-              <a:defRPr sz="1200">
+            </a:pPr>
+            <a:r>
+              <a:rPr sz="1200" b="0">
                 <a:solidFill>
                   <a:srgbClr val="FFFFFF"/>
                 </a:solidFill>
-              </a:defRPr>
-            </a:pPr>
-            <a:r>
-              <a:t>Universal Stacking Model (All Ranks):</a:t>
-            </a:r>
-            <a:br/>
-            <a:r>
-              <a:t>• 5-Fold CV RMSE: 150.28 Kcal/kg</a:t>
-            </a:r>
-            <a:br/>
-            <a:r>
-              <a:t>• 5-Fold CV MAE: 105.97 Kcal/kg</a:t>
-            </a:r>
-            <a:br/>
-            <a:r>
-              <a:t>• Coefficient of Variation (CV): 2.18%</a:t>
-            </a:r>
-            <a:br/>
-            <a:r>
-              <a:t>• Variance Explained (R²): 0.9595</a:t>
-            </a:r>
-            <a:br/>
-            <a:br/>
-            <a:r>
-              <a:t>Bituminous Specialized Model (ASTM D388):</a:t>
-            </a:r>
-            <a:br/>
-            <a:r>
-              <a:t>• 5-Fold CV RMSE: 134.18 Kcal/kg  (-16.10)</a:t>
-            </a:r>
-            <a:br/>
-            <a:r>
-              <a:t>• 5-Fold CV MAE: 96.29 Kcal/kg  (&lt;100!)</a:t>
-            </a:r>
-            <a:br/>
-            <a:r>
-              <a:t>• Coefficient of Variation (CV): 1.91%</a:t>
-            </a:r>
-            <a:br/>
-            <a:r>
-              <a:t>• Variance Explained (R²): 0.9524</a:t>
+              </a:rPr>
+              <a:t>Universal Stacking Model (All Ranks):
+• 5-Fold CV RMSE: 150.28 Kcal/kg
+• 5-Fold CV MAE: 105.97 Kcal/kg
+• Coefficient of Variation (CV): 2.18%
+• Variance Explained (R²): 0.9595
+Bituminous Specialized Model (ASTM D388):
+• 5-Fold CV RMSE: 134.18 Kcal/kg  (-16.10)
+• 5-Fold CV MAE: 96.29 Kcal/kg  (&lt;100!)
+• Coefficient of Variation (CV): 1.91%
+• Variance Explained (R²): 0.9524</a:t>
             </a:r>
           </a:p>
         </p:txBody>
@@ -4087,14 +4073,12 @@
           </a:bodyPr>
           <a:lstStyle/>
           <a:p>
-            <a:pPr>
-              <a:defRPr sz="1700" b="1">
+            <a:r>
+              <a:rPr sz="1700" b="1">
                 <a:solidFill>
                   <a:srgbClr val="38BDF8"/>
                 </a:solidFill>
-              </a:defRPr>
-            </a:pPr>
-            <a:r>
+              </a:rPr>
               <a:t>Future Research &amp; Engineering Scope:</a:t>
             </a:r>
           </a:p>
@@ -4103,45 +4087,21 @@
               <a:spcBef>
                 <a:spcPts val="1000"/>
               </a:spcBef>
-              <a:defRPr sz="1200">
+            </a:pPr>
+            <a:r>
+              <a:rPr sz="1200" b="0">
                 <a:solidFill>
                   <a:srgbClr val="FFFFFF"/>
                 </a:solidFill>
-              </a:defRPr>
-            </a:pPr>
-            <a:r>
-              <a:t>1. Dual-Tier Elemental Analysis Mode:</a:t>
-            </a:r>
-            <a:br/>
-            <a:r>
-              <a:t>Ingest Ultimate Analysis (Carbon, Hydrogen, Oxygen, Sulfur) when available to drive RMSE below 50 Kcal/kg.</a:t>
-            </a:r>
-            <a:br/>
-            <a:br/>
-            <a:r>
-              <a:t>2. Quantile Regression &amp; Uncertainty Bounds:</a:t>
-            </a:r>
-            <a:br/>
-            <a:r>
-              <a:t>Predict 90% confidence intervals around GCV values rather than point estimates to inform risk-aware procurement.</a:t>
-            </a:r>
-            <a:br/>
-            <a:br/>
-            <a:r>
-              <a:t>3. High-Throughput Batch Processing:</a:t>
-            </a:r>
-            <a:br/>
-            <a:r>
-              <a:t>Enable bulk CSV uploads for trainload shipments with automated PDF laboratory certificates.</a:t>
-            </a:r>
-            <a:br/>
-            <a:br/>
-            <a:r>
-              <a:t>4. Classical Formula Benchmarking:</a:t>
-            </a:r>
-            <a:br/>
-            <a:r>
-              <a:t>Provide direct mathematical comparisons against Goutal and Dulong empirical equations.</a:t>
+              </a:rPr>
+              <a:t>1. Dual-Tier Elemental Analysis Mode:
+Ingest Ultimate Analysis (Carbon, Hydrogen, Oxygen, Sulfur) when available to drive RMSE below 50 Kcal/kg.
+2. Quantile Regression &amp; Uncertainty Bounds:
+Predict 90% confidence intervals around GCV values rather than point estimates to inform risk-aware procurement.
+3. High-Throughput Batch Processing:
+Enable bulk CSV uploads for trainload shipments with automated PDF laboratory certificates.
+4. Classical Formula Benchmarking:
+Provide direct mathematical comparisons against Goutal and Dulong empirical equations.</a:t>
             </a:r>
           </a:p>
         </p:txBody>
@@ -4229,14 +4189,12 @@
           </a:bodyPr>
           <a:lstStyle/>
           <a:p>
-            <a:pPr>
-              <a:defRPr sz="1100" b="1">
+            <a:r>
+              <a:rPr sz="1100" b="1">
                 <a:solidFill>
                   <a:srgbClr val="38BDF8"/>
                 </a:solidFill>
-              </a:defRPr>
-            </a:pPr>
-            <a:r>
+              </a:rPr>
               <a:t>CONTEXT &amp; OBJECTIVE</a:t>
             </a:r>
           </a:p>
@@ -4264,14 +4222,12 @@
           </a:bodyPr>
           <a:lstStyle/>
           <a:p>
-            <a:pPr>
-              <a:defRPr sz="2400" b="1">
+            <a:r>
+              <a:rPr sz="2400" b="1">
                 <a:solidFill>
                   <a:srgbClr val="FFFFFF"/>
                 </a:solidFill>
-              </a:defRPr>
-            </a:pPr>
-            <a:r>
+              </a:rPr>
               <a:t>Industrial Motivation &amp; Problem Formulation</a:t>
             </a:r>
           </a:p>
@@ -4344,14 +4300,12 @@
           </a:bodyPr>
           <a:lstStyle/>
           <a:p>
-            <a:pPr>
-              <a:defRPr sz="1800" b="1">
+            <a:r>
+              <a:rPr sz="1800" b="1">
                 <a:solidFill>
                   <a:srgbClr val="FB923C"/>
                 </a:solidFill>
-              </a:defRPr>
-            </a:pPr>
-            <a:r>
+              </a:rPr>
               <a:t>The Laboratory Bottleneck</a:t>
             </a:r>
           </a:p>
@@ -4360,19 +4314,15 @@
               <a:spcBef>
                 <a:spcPts val="1400"/>
               </a:spcBef>
-              <a:defRPr sz="1300">
+            </a:pPr>
+            <a:r>
+              <a:rPr sz="1300" b="0">
                 <a:solidFill>
                   <a:srgbClr val="FFFFFF"/>
                 </a:solidFill>
-              </a:defRPr>
-            </a:pPr>
-            <a:r>
-              <a:t>Standard bomb calorimetry requires oxygen-pressurized combustion bombs, calibrated water jackets, and skilled technicians.</a:t>
-            </a:r>
-            <a:br/>
-            <a:br/>
-            <a:r>
-              <a:t>Result: 24–48 hour turnaround times delay critical coal blending decisions in power plants.</a:t>
+              </a:rPr>
+              <a:t>Standard bomb calorimetry requires oxygen-pressurized combustion bombs, calibrated water jackets, and skilled technicians.
+Result: 24–48 hour turnaround times delay critical coal blending decisions in power plants.</a:t>
             </a:r>
           </a:p>
         </p:txBody>
@@ -4444,14 +4394,12 @@
           </a:bodyPr>
           <a:lstStyle/>
           <a:p>
-            <a:pPr>
-              <a:defRPr sz="1800" b="1">
+            <a:r>
+              <a:rPr sz="1800" b="1">
                 <a:solidFill>
                   <a:srgbClr val="38BDF8"/>
                 </a:solidFill>
-              </a:defRPr>
-            </a:pPr>
-            <a:r>
+              </a:rPr>
               <a:t>The Proximate Advantage</a:t>
             </a:r>
           </a:p>
@@ -4460,19 +4408,15 @@
               <a:spcBef>
                 <a:spcPts val="1400"/>
               </a:spcBef>
-              <a:defRPr sz="1300">
+            </a:pPr>
+            <a:r>
+              <a:rPr sz="1300" b="0">
                 <a:solidFill>
                   <a:srgbClr val="FFFFFF"/>
                 </a:solidFill>
-              </a:defRPr>
-            </a:pPr>
-            <a:r>
-              <a:t>Proximate analysis (Moisture, Volatile Matter, Ash) is rapid, inexpensive, and standardized.</a:t>
-            </a:r>
-            <a:br/>
-            <a:br/>
-            <a:r>
-              <a:t>Goal: Map proximate parameters directly to GCV with high fidelity, enabling immediate day-of-delivery decision making.</a:t>
+              </a:rPr>
+              <a:t>Proximate analysis (Moisture, Volatile Matter, Ash) is rapid, inexpensive, and standardized.
+Goal: Map proximate parameters directly to GCV with high fidelity, enabling immediate day-of-delivery decision making.</a:t>
             </a:r>
           </a:p>
         </p:txBody>
@@ -4544,14 +4488,12 @@
           </a:bodyPr>
           <a:lstStyle/>
           <a:p>
-            <a:pPr>
-              <a:defRPr sz="1800" b="1">
+            <a:r>
+              <a:rPr sz="1800" b="1">
                 <a:solidFill>
                   <a:srgbClr val="34D399"/>
                 </a:solidFill>
-              </a:defRPr>
-            </a:pPr>
-            <a:r>
+              </a:rPr>
               <a:t>Rigorous Target Metrics</a:t>
             </a:r>
           </a:p>
@@ -4560,23 +4502,16 @@
               <a:spcBef>
                 <a:spcPts val="1400"/>
               </a:spcBef>
-              <a:defRPr sz="1300">
+            </a:pPr>
+            <a:r>
+              <a:rPr sz="1300" b="0">
                 <a:solidFill>
                   <a:srgbClr val="FFFFFF"/>
                 </a:solidFill>
-              </a:defRPr>
-            </a:pPr>
-            <a:r>
-              <a:t>Target RMSE: &lt;= 200 Kcal/kg</a:t>
-            </a:r>
-            <a:br/>
-            <a:r>
-              <a:t>Target CV Score: &lt; 8.0%</a:t>
-            </a:r>
-            <a:br/>
-            <a:br/>
-            <a:r>
-              <a:t>Our system surpassed both tolerances, delivering 150.28 Kcal/kg (2.18% CV) overall and 134.18 Kcal/kg (1.91% CV) for bituminous coal.</a:t>
+              </a:rPr>
+              <a:t>Target RMSE: &lt;= 200 Kcal/kg
+Target CV Score: &lt; 8.0%
+Our system surpassed both tolerances, delivering 150.28 Kcal/kg (2.18% CV) overall and 134.18 Kcal/kg (1.91% CV) for bituminous coal.</a:t>
             </a:r>
           </a:p>
         </p:txBody>
@@ -4664,14 +4599,12 @@
           </a:bodyPr>
           <a:lstStyle/>
           <a:p>
-            <a:pPr>
-              <a:defRPr sz="1100" b="1">
+            <a:r>
+              <a:rPr sz="1100" b="1">
                 <a:solidFill>
                   <a:srgbClr val="38BDF8"/>
                 </a:solidFill>
-              </a:defRPr>
-            </a:pPr>
-            <a:r>
+              </a:rPr>
               <a:t>DATASET &amp; PREPROCESSING</a:t>
             </a:r>
           </a:p>
@@ -4699,14 +4632,12 @@
           </a:bodyPr>
           <a:lstStyle/>
           <a:p>
-            <a:pPr>
-              <a:defRPr sz="2400" b="1">
+            <a:r>
+              <a:rPr sz="2400" b="1">
                 <a:solidFill>
                   <a:srgbClr val="FFFFFF"/>
                 </a:solidFill>
-              </a:defRPr>
-            </a:pPr>
-            <a:r>
+              </a:rPr>
               <a:t>Data Hygiene &amp; Zero-Target-Leakage Protocol</a:t>
             </a:r>
           </a:p>
@@ -4779,14 +4710,12 @@
           </a:bodyPr>
           <a:lstStyle/>
           <a:p>
-            <a:pPr>
-              <a:defRPr sz="1600" b="1">
+            <a:r>
+              <a:rPr sz="1600" b="1">
                 <a:solidFill>
                   <a:srgbClr val="38BDF8"/>
                 </a:solidFill>
-              </a:defRPr>
-            </a:pPr>
-            <a:r>
+              </a:rPr>
               <a:t>1. Unit Standardization</a:t>
             </a:r>
           </a:p>
@@ -4795,18 +4724,15 @@
               <a:spcBef>
                 <a:spcPts val="800"/>
               </a:spcBef>
-              <a:defRPr sz="1250">
+            </a:pPr>
+            <a:r>
+              <a:rPr sz="1250" b="0">
                 <a:solidFill>
                   <a:srgbClr val="FFFFFF"/>
                 </a:solidFill>
-              </a:defRPr>
-            </a:pPr>
-            <a:r>
-              <a:t>Raw dataset contains imperial heating values in Btu/lb. Converted to international metric standard:</a:t>
-            </a:r>
-            <a:br/>
-            <a:r>
-              <a:t>GCV (Kcal/kg) = Btu / 1.8</a:t>
+              </a:rPr>
+              <a:t>Raw dataset contains imperial heating values in Btu/lb. Converted to international metric standard:
+GCV (Kcal/kg) = Btu / 1.8</a:t>
             </a:r>
           </a:p>
         </p:txBody>
@@ -4878,14 +4804,12 @@
           </a:bodyPr>
           <a:lstStyle/>
           <a:p>
-            <a:pPr>
-              <a:defRPr sz="1600" b="1">
+            <a:r>
+              <a:rPr sz="1600" b="1">
                 <a:solidFill>
                   <a:srgbClr val="34D399"/>
                 </a:solidFill>
-              </a:defRPr>
-            </a:pPr>
-            <a:r>
+              </a:rPr>
               <a:t>2. Zero Target Leakage</a:t>
             </a:r>
           </a:p>
@@ -4894,13 +4818,13 @@
               <a:spcBef>
                 <a:spcPts val="800"/>
               </a:spcBef>
-              <a:defRPr sz="1250">
+            </a:pPr>
+            <a:r>
+              <a:rPr sz="1250" b="0">
                 <a:solidFill>
                   <a:srgbClr val="FFFFFF"/>
                 </a:solidFill>
-              </a:defRPr>
-            </a:pPr>
-            <a:r>
+              </a:rPr>
               <a:t>In amateur ML workflows, imputers often fit across features AND target GCV. We enforced strict isolation: KNN imputation fits ONLY on features [Moisture, VM, Ash].</a:t>
             </a:r>
           </a:p>
@@ -4973,14 +4897,12 @@
           </a:bodyPr>
           <a:lstStyle/>
           <a:p>
-            <a:pPr>
-              <a:defRPr sz="1600" b="1">
+            <a:r>
+              <a:rPr sz="1600" b="1">
                 <a:solidFill>
                   <a:srgbClr val="FB923C"/>
                 </a:solidFill>
-              </a:defRPr>
-            </a:pPr>
-            <a:r>
+              </a:rPr>
               <a:t>3. Physical Bounds</a:t>
             </a:r>
           </a:p>
@@ -4989,26 +4911,17 @@
               <a:spcBef>
                 <a:spcPts val="800"/>
               </a:spcBef>
-              <a:defRPr sz="1250">
+            </a:pPr>
+            <a:r>
+              <a:rPr sz="1250" b="0">
                 <a:solidFill>
                   <a:srgbClr val="FFFFFF"/>
                 </a:solidFill>
-              </a:defRPr>
-            </a:pPr>
-            <a:r>
-              <a:t>Enforced physical combustion realism:</a:t>
-            </a:r>
-            <a:br/>
-            <a:r>
-              <a:t>• GCV: 2000 to 9000 Kcal/kg</a:t>
-            </a:r>
-            <a:br/>
-            <a:r>
-              <a:t>• Standard Ash &lt;= 55%</a:t>
-            </a:r>
-            <a:br/>
-            <a:r>
-              <a:t>• Moisture &lt;= 45%, VM &lt;= 60%</a:t>
+              </a:rPr>
+              <a:t>Enforced physical combustion realism:
+• GCV: 2000 to 9000 Kcal/kg
+• Standard Ash &lt;= 55%
+• Moisture &lt;= 45%, VM &lt;= 60%</a:t>
             </a:r>
           </a:p>
         </p:txBody>
@@ -5080,14 +4993,12 @@
           </a:bodyPr>
           <a:lstStyle/>
           <a:p>
-            <a:pPr>
-              <a:defRPr sz="1600" b="1">
+            <a:r>
+              <a:rPr sz="1600" b="1">
                 <a:solidFill>
                   <a:srgbClr val="38BDF8"/>
                 </a:solidFill>
-              </a:defRPr>
-            </a:pPr>
-            <a:r>
+              </a:rPr>
               <a:t>4. Mass Balance Integrity</a:t>
             </a:r>
           </a:p>
@@ -5096,22 +5007,16 @@
               <a:spcBef>
                 <a:spcPts val="800"/>
               </a:spcBef>
-              <a:defRPr sz="1250">
+            </a:pPr>
+            <a:r>
+              <a:rPr sz="1250" b="0">
                 <a:solidFill>
                   <a:srgbClr val="FFFFFF"/>
                 </a:solidFill>
-              </a:defRPr>
-            </a:pPr>
-            <a:r>
-              <a:t>By proximate definition, components sum to 100%:</a:t>
-            </a:r>
-            <a:br/>
-            <a:r>
-              <a:t>Fixed Carbon = 100 - (Moisture + VM + Ash)</a:t>
-            </a:r>
-            <a:br/>
-            <a:r>
-              <a:t>Retained exclusively samples with Fixed Carbon &gt; 0.</a:t>
+              </a:rPr>
+              <a:t>By proximate definition, components sum to 100%:
+Fixed Carbon = 100 - (Moisture + VM + Ash)
+Retained exclusively samples with Fixed Carbon &gt; 0.</a:t>
             </a:r>
           </a:p>
         </p:txBody>
@@ -5199,14 +5104,12 @@
           </a:bodyPr>
           <a:lstStyle/>
           <a:p>
-            <a:pPr>
-              <a:defRPr sz="1100" b="1">
+            <a:r>
+              <a:rPr sz="1100" b="1">
                 <a:solidFill>
                   <a:srgbClr val="38BDF8"/>
                 </a:solidFill>
-              </a:defRPr>
-            </a:pPr>
-            <a:r>
+              </a:rPr>
               <a:t>FEATURE ENGINEERING</a:t>
             </a:r>
           </a:p>
@@ -5234,14 +5137,12 @@
           </a:bodyPr>
           <a:lstStyle/>
           <a:p>
-            <a:pPr>
-              <a:defRPr sz="2400" b="1">
+            <a:r>
+              <a:rPr sz="2400" b="1">
                 <a:solidFill>
                   <a:srgbClr val="FFFFFF"/>
                 </a:solidFill>
-              </a:defRPr>
-            </a:pPr>
-            <a:r>
+              </a:rPr>
               <a:t>Domain Feature Engineering: Why Add Fuel Ratio?</a:t>
             </a:r>
           </a:p>
@@ -5269,14 +5170,12 @@
           </a:bodyPr>
           <a:lstStyle/>
           <a:p>
-            <a:pPr>
-              <a:defRPr sz="1800" b="1">
+            <a:r>
+              <a:rPr sz="1800" b="1">
                 <a:solidFill>
                   <a:srgbClr val="FB923C"/>
                 </a:solidFill>
-              </a:defRPr>
-            </a:pPr>
-            <a:r>
+              </a:rPr>
               <a:t>The Mathematical Limitation of Tree Models:</a:t>
             </a:r>
           </a:p>
@@ -5285,13 +5184,13 @@
               <a:spcBef>
                 <a:spcPts val="1000"/>
               </a:spcBef>
-              <a:defRPr sz="1300">
+            </a:pPr>
+            <a:r>
+              <a:rPr sz="1300" b="0">
                 <a:solidFill>
                   <a:srgbClr val="FFFFFF"/>
                 </a:solidFill>
-              </a:defRPr>
-            </a:pPr>
-            <a:r>
+              </a:rPr>
               <a:t>• Decision trees split orthogonally (Xi &gt; c). They cannot naturally compute division between features without hundreds of step-wise splits.</a:t>
             </a:r>
           </a:p>
@@ -5300,18 +5199,15 @@
               <a:spcBef>
                 <a:spcPts val="1000"/>
               </a:spcBef>
-              <a:defRPr sz="1300">
+            </a:pPr>
+            <a:r>
+              <a:rPr sz="1300" b="0">
                 <a:solidFill>
                   <a:srgbClr val="FFFFFF"/>
                 </a:solidFill>
-              </a:defRPr>
-            </a:pPr>
-            <a:r>
-              <a:t>• In coal petrology, the Fuel Ratio is defined as:</a:t>
-            </a:r>
-            <a:br/>
-            <a:r>
-              <a:t>Fuel Ratio = Fixed Carbon / Volatile Matter</a:t>
+              </a:rPr>
+              <a:t>• In coal petrology, the Fuel Ratio is defined as:
+Fuel Ratio = Fixed Carbon / Volatile Matter</a:t>
             </a:r>
           </a:p>
           <a:p>
@@ -5319,13 +5215,13 @@
               <a:spcBef>
                 <a:spcPts val="1000"/>
               </a:spcBef>
-              <a:defRPr sz="1300">
+            </a:pPr>
+            <a:r>
+              <a:rPr sz="1300" b="0">
                 <a:solidFill>
                   <a:srgbClr val="FFFFFF"/>
                 </a:solidFill>
-              </a:defRPr>
-            </a:pPr>
-            <a:r>
+              </a:rPr>
               <a:t>• Fuel Ratio is the universally accepted chemical proxy for coal rank (Anthracite vs Bituminous vs Lignite).</a:t>
             </a:r>
           </a:p>
@@ -5334,13 +5230,13 @@
               <a:spcBef>
                 <a:spcPts val="1000"/>
               </a:spcBef>
-              <a:defRPr sz="1300">
+            </a:pPr>
+            <a:r>
+              <a:rPr sz="1300" b="0">
                 <a:solidFill>
                   <a:srgbClr val="FFFFFF"/>
                 </a:solidFill>
-              </a:defRPr>
-            </a:pPr>
-            <a:r>
+              </a:rPr>
               <a:t>• By calculating it explicitly prior to training, we feed the model an explicit rank descriptor without requiring extra lab testing.</a:t>
             </a:r>
           </a:p>
@@ -5413,14 +5309,12 @@
           </a:bodyPr>
           <a:lstStyle/>
           <a:p>
-            <a:pPr>
-              <a:defRPr sz="1700" b="1">
+            <a:r>
+              <a:rPr sz="1700" b="1">
                 <a:solidFill>
                   <a:srgbClr val="34D399"/>
                 </a:solidFill>
-              </a:defRPr>
-            </a:pPr>
-            <a:r>
+              </a:rPr>
               <a:t>Mass Balance Formulation:</a:t>
             </a:r>
           </a:p>
@@ -5429,47 +5323,34 @@
               <a:spcBef>
                 <a:spcPts val="1200"/>
               </a:spcBef>
-              <a:defRPr sz="1600" b="1">
+            </a:pPr>
+            <a:r>
+              <a:rPr sz="1600" b="1">
                 <a:solidFill>
                   <a:srgbClr val="FFFFFF"/>
                 </a:solidFill>
-              </a:defRPr>
-            </a:pPr>
-            <a:r>
-              <a:t>FC = 100 - (Moisture + VM + Ash)</a:t>
-            </a:r>
-            <a:br/>
-            <a:br/>
-            <a:r>
-              <a:t>Fuel Ratio = FC / VM</a:t>
-            </a:r>
-          </a:p>
-          <a:p>
-            <a:br/>
+              </a:rPr>
+              <a:t>FC = 100 - (Moisture + VM + Ash)
+Fuel Ratio = FC / VM</a:t>
+            </a:r>
+          </a:p>
+          <a:p>
             <a:pPr>
               <a:spcBef>
                 <a:spcPts val="1200"/>
               </a:spcBef>
-              <a:defRPr sz="1300">
-                <a:solidFill>
-                  <a:srgbClr val="F1F5F9"/>
-                </a:solidFill>
-              </a:defRPr>
             </a:pPr>
             <a:r>
-              <a:t>Impact on Training:</a:t>
-            </a:r>
-            <a:br/>
-            <a:r>
-              <a:t>• Drastically simplifies tree depth requirements.</a:t>
-            </a:r>
-            <a:br/>
-            <a:r>
-              <a:t>• Enables shallow XGBoost trees (depth 4) to capture coal rank variations.</a:t>
-            </a:r>
-            <a:br/>
-            <a:r>
-              <a:t>• Consistently reduces CV error across all folds.</a:t>
+              <a:rPr sz="1300" b="0">
+                <a:solidFill>
+                  <a:srgbClr val="FFFFFF"/>
+                </a:solidFill>
+              </a:rPr>
+              <a:t>
+Impact on Training:
+• Drastically simplifies tree depth requirements.
+• Enables shallow XGBoost trees (depth 4) to capture coal rank variations.
+• Consistently reduces CV error across all folds.</a:t>
             </a:r>
           </a:p>
         </p:txBody>
@@ -5557,14 +5438,12 @@
           </a:bodyPr>
           <a:lstStyle/>
           <a:p>
-            <a:pPr>
-              <a:defRPr sz="1100" b="1">
+            <a:r>
+              <a:rPr sz="1100" b="1">
                 <a:solidFill>
                   <a:srgbClr val="38BDF8"/>
                 </a:solidFill>
-              </a:defRPr>
-            </a:pPr>
-            <a:r>
+              </a:rPr>
               <a:t>MODEL EVALUATION</a:t>
             </a:r>
           </a:p>
@@ -5592,14 +5471,12 @@
           </a:bodyPr>
           <a:lstStyle/>
           <a:p>
-            <a:pPr>
-              <a:defRPr sz="2400" b="1">
+            <a:r>
+              <a:rPr sz="2400" b="1">
                 <a:solidFill>
                   <a:srgbClr val="FFFFFF"/>
                 </a:solidFill>
-              </a:defRPr>
-            </a:pPr>
-            <a:r>
+              </a:rPr>
               <a:t>Quantitative Benchmarking: Proving Ensemble Superiority</a:t>
             </a:r>
           </a:p>
@@ -5635,14 +5512,12 @@
                     <a:bodyPr/>
                     <a:lstStyle/>
                     <a:p>
-                      <a:pPr>
-                        <a:defRPr sz="1100" b="1">
+                      <a:r>
+                        <a:rPr sz="1100" b="1">
                           <a:solidFill>
                             <a:srgbClr val="FFFFFF"/>
                           </a:solidFill>
-                        </a:defRPr>
-                      </a:pPr>
-                      <a:r>
+                        </a:rPr>
                         <a:t>Model Architecture</a:t>
                       </a:r>
                     </a:p>
@@ -5658,14 +5533,12 @@
                     <a:bodyPr/>
                     <a:lstStyle/>
                     <a:p>
-                      <a:pPr>
-                        <a:defRPr sz="1100" b="1">
+                      <a:r>
+                        <a:rPr sz="1100" b="1">
                           <a:solidFill>
                             <a:srgbClr val="FFFFFF"/>
                           </a:solidFill>
-                        </a:defRPr>
-                      </a:pPr>
-                      <a:r>
+                        </a:rPr>
                         <a:t>5-Fold RMSE</a:t>
                       </a:r>
                     </a:p>
@@ -5681,14 +5554,12 @@
                     <a:bodyPr/>
                     <a:lstStyle/>
                     <a:p>
-                      <a:pPr>
-                        <a:defRPr sz="1100" b="1">
+                      <a:r>
+                        <a:rPr sz="1100" b="1">
                           <a:solidFill>
                             <a:srgbClr val="FFFFFF"/>
                           </a:solidFill>
-                        </a:defRPr>
-                      </a:pPr>
-                      <a:r>
+                        </a:rPr>
                         <a:t>5-Fold MAE</a:t>
                       </a:r>
                     </a:p>
@@ -5704,14 +5575,12 @@
                     <a:bodyPr/>
                     <a:lstStyle/>
                     <a:p>
-                      <a:pPr>
-                        <a:defRPr sz="1100" b="1">
+                      <a:r>
+                        <a:rPr sz="1100" b="1">
                           <a:solidFill>
                             <a:srgbClr val="FFFFFF"/>
                           </a:solidFill>
-                        </a:defRPr>
-                      </a:pPr>
-                      <a:r>
+                        </a:rPr>
                         <a:t>R² Score</a:t>
                       </a:r>
                     </a:p>
@@ -5729,14 +5598,12 @@
                     <a:bodyPr/>
                     <a:lstStyle/>
                     <a:p>
-                      <a:pPr>
-                        <a:defRPr sz="1100">
+                      <a:r>
+                        <a:rPr sz="1100" b="0">
                           <a:solidFill>
                             <a:srgbClr val="FFFFFF"/>
                           </a:solidFill>
-                        </a:defRPr>
-                      </a:pPr>
-                      <a:r>
+                        </a:rPr>
                         <a:t>Support Vector Machine (SVR)</a:t>
                       </a:r>
                     </a:p>
@@ -5752,14 +5619,12 @@
                     <a:bodyPr/>
                     <a:lstStyle/>
                     <a:p>
-                      <a:pPr>
-                        <a:defRPr sz="1100">
+                      <a:r>
+                        <a:rPr sz="1100" b="0">
                           <a:solidFill>
                             <a:srgbClr val="FFFFFF"/>
                           </a:solidFill>
-                        </a:defRPr>
-                      </a:pPr>
-                      <a:r>
+                        </a:rPr>
                         <a:t>612.45</a:t>
                       </a:r>
                     </a:p>
@@ -5775,14 +5640,12 @@
                     <a:bodyPr/>
                     <a:lstStyle/>
                     <a:p>
-                      <a:pPr>
-                        <a:defRPr sz="1100">
+                      <a:r>
+                        <a:rPr sz="1100" b="0">
                           <a:solidFill>
                             <a:srgbClr val="FFFFFF"/>
                           </a:solidFill>
-                        </a:defRPr>
-                      </a:pPr>
-                      <a:r>
+                        </a:rPr>
                         <a:t>487.12</a:t>
                       </a:r>
                     </a:p>
@@ -5798,14 +5661,12 @@
                     <a:bodyPr/>
                     <a:lstStyle/>
                     <a:p>
-                      <a:pPr>
-                        <a:defRPr sz="1100">
+                      <a:r>
+                        <a:rPr sz="1100" b="0">
                           <a:solidFill>
                             <a:srgbClr val="FFFFFF"/>
                           </a:solidFill>
-                        </a:defRPr>
-                      </a:pPr>
-                      <a:r>
+                        </a:rPr>
                         <a:t>0.3541</a:t>
                       </a:r>
                     </a:p>
@@ -5823,14 +5684,12 @@
                     <a:bodyPr/>
                     <a:lstStyle/>
                     <a:p>
-                      <a:pPr>
-                        <a:defRPr sz="1100">
+                      <a:r>
+                        <a:rPr sz="1100" b="0">
                           <a:solidFill>
                             <a:srgbClr val="FFFFFF"/>
                           </a:solidFill>
-                        </a:defRPr>
-                      </a:pPr>
-                      <a:r>
+                        </a:rPr>
                         <a:t>Decision Tree Regressor</a:t>
                       </a:r>
                     </a:p>
@@ -5846,14 +5705,12 @@
                     <a:bodyPr/>
                     <a:lstStyle/>
                     <a:p>
-                      <a:pPr>
-                        <a:defRPr sz="1100">
+                      <a:r>
+                        <a:rPr sz="1100" b="0">
                           <a:solidFill>
                             <a:srgbClr val="FFFFFF"/>
                           </a:solidFill>
-                        </a:defRPr>
-                      </a:pPr>
-                      <a:r>
+                        </a:rPr>
                         <a:t>217.30</a:t>
                       </a:r>
                     </a:p>
@@ -5869,14 +5726,12 @@
                     <a:bodyPr/>
                     <a:lstStyle/>
                     <a:p>
-                      <a:pPr>
-                        <a:defRPr sz="1100">
+                      <a:r>
+                        <a:rPr sz="1100" b="0">
                           <a:solidFill>
                             <a:srgbClr val="FFFFFF"/>
                           </a:solidFill>
-                        </a:defRPr>
-                      </a:pPr>
-                      <a:r>
+                        </a:rPr>
                         <a:t>148.80</a:t>
                       </a:r>
                     </a:p>
@@ -5892,14 +5747,12 @@
                     <a:bodyPr/>
                     <a:lstStyle/>
                     <a:p>
-                      <a:pPr>
-                        <a:defRPr sz="1100">
+                      <a:r>
+                        <a:rPr sz="1100" b="0">
                           <a:solidFill>
                             <a:srgbClr val="FFFFFF"/>
                           </a:solidFill>
-                        </a:defRPr>
-                      </a:pPr>
-                      <a:r>
+                        </a:rPr>
                         <a:t>0.9168</a:t>
                       </a:r>
                     </a:p>
@@ -5917,14 +5770,12 @@
                     <a:bodyPr/>
                     <a:lstStyle/>
                     <a:p>
-                      <a:pPr>
-                        <a:defRPr sz="1100">
+                      <a:r>
+                        <a:rPr sz="1100" b="0">
                           <a:solidFill>
                             <a:srgbClr val="FFFFFF"/>
                           </a:solidFill>
-                        </a:defRPr>
-                      </a:pPr>
-                      <a:r>
+                        </a:rPr>
                         <a:t>Random Forest Regressor</a:t>
                       </a:r>
                     </a:p>
@@ -5940,14 +5791,12 @@
                     <a:bodyPr/>
                     <a:lstStyle/>
                     <a:p>
-                      <a:pPr>
-                        <a:defRPr sz="1100">
+                      <a:r>
+                        <a:rPr sz="1100" b="0">
                           <a:solidFill>
                             <a:srgbClr val="FFFFFF"/>
                           </a:solidFill>
-                        </a:defRPr>
-                      </a:pPr>
-                      <a:r>
+                        </a:rPr>
                         <a:t>154.84</a:t>
                       </a:r>
                     </a:p>
@@ -5963,14 +5812,12 @@
                     <a:bodyPr/>
                     <a:lstStyle/>
                     <a:p>
-                      <a:pPr>
-                        <a:defRPr sz="1100">
+                      <a:r>
+                        <a:rPr sz="1100" b="0">
                           <a:solidFill>
                             <a:srgbClr val="FFFFFF"/>
                           </a:solidFill>
-                        </a:defRPr>
-                      </a:pPr>
-                      <a:r>
+                        </a:rPr>
                         <a:t>109.12</a:t>
                       </a:r>
                     </a:p>
@@ -5986,14 +5833,12 @@
                     <a:bodyPr/>
                     <a:lstStyle/>
                     <a:p>
-                      <a:pPr>
-                        <a:defRPr sz="1100">
+                      <a:r>
+                        <a:rPr sz="1100" b="0">
                           <a:solidFill>
                             <a:srgbClr val="FFFFFF"/>
                           </a:solidFill>
-                        </a:defRPr>
-                      </a:pPr>
-                      <a:r>
+                        </a:rPr>
                         <a:t>0.9571</a:t>
                       </a:r>
                     </a:p>
@@ -6011,14 +5856,12 @@
                     <a:bodyPr/>
                     <a:lstStyle/>
                     <a:p>
-                      <a:pPr>
-                        <a:defRPr sz="1100">
+                      <a:r>
+                        <a:rPr sz="1100" b="0">
                           <a:solidFill>
                             <a:srgbClr val="FFFFFF"/>
                           </a:solidFill>
-                        </a:defRPr>
-                      </a:pPr>
-                      <a:r>
+                        </a:rPr>
                         <a:t>XGBoost Regressor</a:t>
                       </a:r>
                     </a:p>
@@ -6034,14 +5877,12 @@
                     <a:bodyPr/>
                     <a:lstStyle/>
                     <a:p>
-                      <a:pPr>
-                        <a:defRPr sz="1100">
+                      <a:r>
+                        <a:rPr sz="1100" b="0">
                           <a:solidFill>
                             <a:srgbClr val="FFFFFF"/>
                           </a:solidFill>
-                        </a:defRPr>
-                      </a:pPr>
-                      <a:r>
+                        </a:rPr>
                         <a:t>152.14</a:t>
                       </a:r>
                     </a:p>
@@ -6057,14 +5898,12 @@
                     <a:bodyPr/>
                     <a:lstStyle/>
                     <a:p>
-                      <a:pPr>
-                        <a:defRPr sz="1100">
+                      <a:r>
+                        <a:rPr sz="1100" b="0">
                           <a:solidFill>
                             <a:srgbClr val="FFFFFF"/>
                           </a:solidFill>
-                        </a:defRPr>
-                      </a:pPr>
-                      <a:r>
+                        </a:rPr>
                         <a:t>107.45</a:t>
                       </a:r>
                     </a:p>
@@ -6080,14 +5919,12 @@
                     <a:bodyPr/>
                     <a:lstStyle/>
                     <a:p>
-                      <a:pPr>
-                        <a:defRPr sz="1100">
+                      <a:r>
+                        <a:rPr sz="1100" b="0">
                           <a:solidFill>
                             <a:srgbClr val="FFFFFF"/>
                           </a:solidFill>
-                        </a:defRPr>
-                      </a:pPr>
-                      <a:r>
+                        </a:rPr>
                         <a:t>0.9585</a:t>
                       </a:r>
                     </a:p>
@@ -6105,14 +5942,12 @@
                     <a:bodyPr/>
                     <a:lstStyle/>
                     <a:p>
-                      <a:pPr>
-                        <a:defRPr sz="1100" b="1">
+                      <a:r>
+                        <a:rPr sz="1100" b="1">
                           <a:solidFill>
                             <a:srgbClr val="FFFFFF"/>
                           </a:solidFill>
-                        </a:defRPr>
-                      </a:pPr>
-                      <a:r>
+                        </a:rPr>
                         <a:t>Stacked Ensemble (Ours)</a:t>
                       </a:r>
                     </a:p>
@@ -6128,14 +5963,12 @@
                     <a:bodyPr/>
                     <a:lstStyle/>
                     <a:p>
-                      <a:pPr>
-                        <a:defRPr sz="1100" b="1">
+                      <a:r>
+                        <a:rPr sz="1100" b="1">
                           <a:solidFill>
                             <a:srgbClr val="FFFFFF"/>
                           </a:solidFill>
-                        </a:defRPr>
-                      </a:pPr>
-                      <a:r>
+                        </a:rPr>
                         <a:t>150.28</a:t>
                       </a:r>
                     </a:p>
@@ -6151,14 +5984,12 @@
                     <a:bodyPr/>
                     <a:lstStyle/>
                     <a:p>
-                      <a:pPr>
-                        <a:defRPr sz="1100" b="1">
+                      <a:r>
+                        <a:rPr sz="1100" b="1">
                           <a:solidFill>
                             <a:srgbClr val="FFFFFF"/>
                           </a:solidFill>
-                        </a:defRPr>
-                      </a:pPr>
-                      <a:r>
+                        </a:rPr>
                         <a:t>105.97</a:t>
                       </a:r>
                     </a:p>
@@ -6174,14 +6005,12 @@
                     <a:bodyPr/>
                     <a:lstStyle/>
                     <a:p>
-                      <a:pPr>
-                        <a:defRPr sz="1100" b="1">
+                      <a:r>
+                        <a:rPr sz="1100" b="1">
                           <a:solidFill>
                             <a:srgbClr val="FFFFFF"/>
                           </a:solidFill>
-                        </a:defRPr>
-                      </a:pPr>
-                      <a:r>
+                        </a:rPr>
                         <a:t>0.9595</a:t>
                       </a:r>
                     </a:p>
@@ -6304,15 +6133,13 @@
           </a:bodyPr>
           <a:lstStyle/>
           <a:p>
-            <a:pPr>
-              <a:defRPr sz="1100" b="1">
+            <a:r>
+              <a:rPr sz="1100" b="1">
                 <a:solidFill>
                   <a:srgbClr val="38BDF8"/>
                 </a:solidFill>
-              </a:defRPr>
-            </a:pPr>
-            <a:r>
-              <a:t>MODEL ARCHITECTURE</a:t>
+              </a:rPr>
+              <a:t>SYSTEM ARCHITECTURE</a:t>
             </a:r>
           </a:p>
         </p:txBody>
@@ -6339,419 +6166,41 @@
           </a:bodyPr>
           <a:lstStyle/>
           <a:p>
-            <a:pPr>
-              <a:defRPr sz="2400" b="1">
+            <a:r>
+              <a:rPr sz="2400" b="1">
                 <a:solidFill>
                   <a:srgbClr val="FFFFFF"/>
                 </a:solidFill>
-              </a:defRPr>
-            </a:pPr>
-            <a:r>
-              <a:t>Stacking Ensemble Architecture &amp; SVR Normalization</a:t>
-            </a:r>
-          </a:p>
-        </p:txBody>
-      </p:sp>
-      <p:sp>
-        <p:nvSpPr>
-          <p:cNvPr id="5" name="Rounded Rectangle 4"/>
-          <p:cNvSpPr/>
+              </a:rPr>
+              <a:t>End-to-End System &amp; Stacking Architecture</a:t>
+            </a:r>
+          </a:p>
+        </p:txBody>
+      </p:sp>
+      <p:pic>
+        <p:nvPicPr>
+          <p:cNvPr id="5" name="Picture 4" descr="architecture_diagram.png"/>
+          <p:cNvPicPr>
+            <a:picLocks noChangeAspect="1"/>
+          </p:cNvPicPr>
           <p:nvPr/>
-        </p:nvSpPr>
-        <p:spPr>
-          <a:xfrm>
-            <a:off x="731520" y="1645920"/>
-            <a:ext cx="2560320" cy="4389120"/>
-          </a:xfrm>
-          <a:prstGeom prst="roundRect">
-            <a:avLst/>
-          </a:prstGeom>
-          <a:solidFill>
-            <a:srgbClr val="1E293B"/>
-          </a:solidFill>
-          <a:ln w="19050">
-            <a:solidFill>
-              <a:srgbClr val="38BDF8"/>
-            </a:solidFill>
-          </a:ln>
-        </p:spPr>
-        <p:style>
-          <a:lnRef idx="1">
-            <a:schemeClr val="accent1"/>
-          </a:lnRef>
-          <a:fillRef idx="3">
-            <a:schemeClr val="accent1"/>
-          </a:fillRef>
-          <a:effectRef idx="2">
-            <a:schemeClr val="accent1"/>
-          </a:effectRef>
-          <a:fontRef idx="minor">
-            <a:schemeClr val="lt1"/>
-          </a:fontRef>
-        </p:style>
-        <p:txBody>
-          <a:bodyPr rtlCol="0" anchor="ctr"/>
-          <a:lstStyle/>
-          <a:p>
-            <a:pPr algn="ctr"/>
-          </a:p>
-        </p:txBody>
-      </p:sp>
-      <p:sp>
-        <p:nvSpPr>
-          <p:cNvPr id="6" name="TextBox 5"/>
-          <p:cNvSpPr txBox="1"/>
-          <p:nvPr/>
-        </p:nvSpPr>
-        <p:spPr>
-          <a:xfrm>
-            <a:off x="896112" y="1828800"/>
-            <a:ext cx="2231136" cy="4023360"/>
+        </p:nvPicPr>
+        <p:blipFill>
+          <a:blip r:embed="rId2"/>
+          <a:stretch>
+            <a:fillRect/>
+          </a:stretch>
+        </p:blipFill>
+        <p:spPr>
+          <a:xfrm>
+            <a:off x="731520" y="1463040"/>
+            <a:ext cx="10725912" cy="6096022"/>
           </a:xfrm>
           <a:prstGeom prst="rect">
             <a:avLst/>
           </a:prstGeom>
-          <a:noFill/>
-        </p:spPr>
-        <p:txBody>
-          <a:bodyPr wrap="square">
-            <a:spAutoFit/>
-          </a:bodyPr>
-          <a:lstStyle/>
-          <a:p>
-            <a:pPr>
-              <a:defRPr sz="1500" b="1">
-                <a:solidFill>
-                  <a:srgbClr val="38BDF8"/>
-                </a:solidFill>
-              </a:defRPr>
-            </a:pPr>
-            <a:r>
-              <a:t>Level-0: Random Forest</a:t>
-            </a:r>
-          </a:p>
-          <a:p>
-            <a:pPr>
-              <a:spcBef>
-                <a:spcPts val="1200"/>
-              </a:spcBef>
-              <a:defRPr sz="1150">
-                <a:solidFill>
-                  <a:srgbClr val="FFFFFF"/>
-                </a:solidFill>
-              </a:defRPr>
-            </a:pPr>
-            <a:r>
-              <a:t>Bagging Regressor (200 trees, max depth 15).</a:t>
-            </a:r>
-            <a:br/>
-            <a:br/>
-            <a:r>
-              <a:t>Role: Smooths predictive variance by averaging across de-correlated bootstrapped subsets. Resilient to isolated lab noise.</a:t>
-            </a:r>
-          </a:p>
-        </p:txBody>
-      </p:sp>
-      <p:sp>
-        <p:nvSpPr>
-          <p:cNvPr id="7" name="Rounded Rectangle 6"/>
-          <p:cNvSpPr/>
-          <p:nvPr/>
-        </p:nvSpPr>
-        <p:spPr>
-          <a:xfrm>
-            <a:off x="3429000" y="1645920"/>
-            <a:ext cx="2560320" cy="4389120"/>
-          </a:xfrm>
-          <a:prstGeom prst="roundRect">
-            <a:avLst/>
-          </a:prstGeom>
-          <a:solidFill>
-            <a:srgbClr val="1E293B"/>
-          </a:solidFill>
-          <a:ln w="19050">
-            <a:solidFill>
-              <a:srgbClr val="FB923C"/>
-            </a:solidFill>
-          </a:ln>
-        </p:spPr>
-        <p:style>
-          <a:lnRef idx="1">
-            <a:schemeClr val="accent1"/>
-          </a:lnRef>
-          <a:fillRef idx="3">
-            <a:schemeClr val="accent1"/>
-          </a:fillRef>
-          <a:effectRef idx="2">
-            <a:schemeClr val="accent1"/>
-          </a:effectRef>
-          <a:fontRef idx="minor">
-            <a:schemeClr val="lt1"/>
-          </a:fontRef>
-        </p:style>
-        <p:txBody>
-          <a:bodyPr rtlCol="0" anchor="ctr"/>
-          <a:lstStyle/>
-          <a:p>
-            <a:pPr algn="ctr"/>
-          </a:p>
-        </p:txBody>
-      </p:sp>
-      <p:sp>
-        <p:nvSpPr>
-          <p:cNvPr id="8" name="TextBox 7"/>
-          <p:cNvSpPr txBox="1"/>
-          <p:nvPr/>
-        </p:nvSpPr>
-        <p:spPr>
-          <a:xfrm>
-            <a:off x="3593592" y="1828800"/>
-            <a:ext cx="2231136" cy="4023360"/>
-          </a:xfrm>
-          <a:prstGeom prst="rect">
-            <a:avLst/>
-          </a:prstGeom>
-          <a:noFill/>
-        </p:spPr>
-        <p:txBody>
-          <a:bodyPr wrap="square">
-            <a:spAutoFit/>
-          </a:bodyPr>
-          <a:lstStyle/>
-          <a:p>
-            <a:pPr>
-              <a:defRPr sz="1500" b="1">
-                <a:solidFill>
-                  <a:srgbClr val="FB923C"/>
-                </a:solidFill>
-              </a:defRPr>
-            </a:pPr>
-            <a:r>
-              <a:t>Level-0: XGBoost</a:t>
-            </a:r>
-          </a:p>
-          <a:p>
-            <a:pPr>
-              <a:spcBef>
-                <a:spcPts val="1200"/>
-              </a:spcBef>
-              <a:defRPr sz="1150">
-                <a:solidFill>
-                  <a:srgbClr val="FFFFFF"/>
-                </a:solidFill>
-              </a:defRPr>
-            </a:pPr>
-            <a:r>
-              <a:t>Gradient Boosted Trees (300 estimators, depth 4, lr 0.025).</a:t>
-            </a:r>
-            <a:br/>
-            <a:br/>
-            <a:r>
-              <a:t>Role: Minimizes residual bias sequentially. Captures non-linear chemical interactions between moisture and ash.</a:t>
-            </a:r>
-          </a:p>
-        </p:txBody>
-      </p:sp>
-      <p:sp>
-        <p:nvSpPr>
-          <p:cNvPr id="9" name="Rounded Rectangle 8"/>
-          <p:cNvSpPr/>
-          <p:nvPr/>
-        </p:nvSpPr>
-        <p:spPr>
-          <a:xfrm>
-            <a:off x="6126480" y="1645920"/>
-            <a:ext cx="2560320" cy="4389120"/>
-          </a:xfrm>
-          <a:prstGeom prst="roundRect">
-            <a:avLst/>
-          </a:prstGeom>
-          <a:solidFill>
-            <a:srgbClr val="1E293B"/>
-          </a:solidFill>
-          <a:ln w="19050">
-            <a:solidFill>
-              <a:srgbClr val="34D399"/>
-            </a:solidFill>
-          </a:ln>
-        </p:spPr>
-        <p:style>
-          <a:lnRef idx="1">
-            <a:schemeClr val="accent1"/>
-          </a:lnRef>
-          <a:fillRef idx="3">
-            <a:schemeClr val="accent1"/>
-          </a:fillRef>
-          <a:effectRef idx="2">
-            <a:schemeClr val="accent1"/>
-          </a:effectRef>
-          <a:fontRef idx="minor">
-            <a:schemeClr val="lt1"/>
-          </a:fontRef>
-        </p:style>
-        <p:txBody>
-          <a:bodyPr rtlCol="0" anchor="ctr"/>
-          <a:lstStyle/>
-          <a:p>
-            <a:pPr algn="ctr"/>
-          </a:p>
-        </p:txBody>
-      </p:sp>
-      <p:sp>
-        <p:nvSpPr>
-          <p:cNvPr id="10" name="TextBox 9"/>
-          <p:cNvSpPr txBox="1"/>
-          <p:nvPr/>
-        </p:nvSpPr>
-        <p:spPr>
-          <a:xfrm>
-            <a:off x="6291072" y="1828800"/>
-            <a:ext cx="2231136" cy="4023360"/>
-          </a:xfrm>
-          <a:prstGeom prst="rect">
-            <a:avLst/>
-          </a:prstGeom>
-          <a:noFill/>
-        </p:spPr>
-        <p:txBody>
-          <a:bodyPr wrap="square">
-            <a:spAutoFit/>
-          </a:bodyPr>
-          <a:lstStyle/>
-          <a:p>
-            <a:pPr>
-              <a:defRPr sz="1500" b="1">
-                <a:solidFill>
-                  <a:srgbClr val="34D399"/>
-                </a:solidFill>
-              </a:defRPr>
-            </a:pPr>
-            <a:r>
-              <a:t>Level-0: Scaled SVR</a:t>
-            </a:r>
-          </a:p>
-          <a:p>
-            <a:pPr>
-              <a:spcBef>
-                <a:spcPts val="1200"/>
-              </a:spcBef>
-              <a:defRPr sz="1150">
-                <a:solidFill>
-                  <a:srgbClr val="FFFFFF"/>
-                </a:solidFill>
-              </a:defRPr>
-            </a:pPr>
-            <a:r>
-              <a:t>Support Vector Regressor with RBF kernel.</a:t>
-            </a:r>
-            <a:br/>
-            <a:br/>
-            <a:r>
-              <a:t>Key Solution: Wrapped inside TransformedTargetRegressor(StandardScaler) to normalize both inputs AND target GCV during kernel evaluation.</a:t>
-            </a:r>
-          </a:p>
-        </p:txBody>
-      </p:sp>
-      <p:sp>
-        <p:nvSpPr>
-          <p:cNvPr id="11" name="Rounded Rectangle 10"/>
-          <p:cNvSpPr/>
-          <p:nvPr/>
-        </p:nvSpPr>
-        <p:spPr>
-          <a:xfrm>
-            <a:off x="8823960" y="1645920"/>
-            <a:ext cx="2560320" cy="4389120"/>
-          </a:xfrm>
-          <a:prstGeom prst="roundRect">
-            <a:avLst/>
-          </a:prstGeom>
-          <a:solidFill>
-            <a:srgbClr val="1E293B"/>
-          </a:solidFill>
-          <a:ln w="19050">
-            <a:solidFill>
-              <a:srgbClr val="38BDF8"/>
-            </a:solidFill>
-          </a:ln>
-        </p:spPr>
-        <p:style>
-          <a:lnRef idx="1">
-            <a:schemeClr val="accent1"/>
-          </a:lnRef>
-          <a:fillRef idx="3">
-            <a:schemeClr val="accent1"/>
-          </a:fillRef>
-          <a:effectRef idx="2">
-            <a:schemeClr val="accent1"/>
-          </a:effectRef>
-          <a:fontRef idx="minor">
-            <a:schemeClr val="lt1"/>
-          </a:fontRef>
-        </p:style>
-        <p:txBody>
-          <a:bodyPr rtlCol="0" anchor="ctr"/>
-          <a:lstStyle/>
-          <a:p>
-            <a:pPr algn="ctr"/>
-          </a:p>
-        </p:txBody>
-      </p:sp>
-      <p:sp>
-        <p:nvSpPr>
-          <p:cNvPr id="12" name="TextBox 11"/>
-          <p:cNvSpPr txBox="1"/>
-          <p:nvPr/>
-        </p:nvSpPr>
-        <p:spPr>
-          <a:xfrm>
-            <a:off x="8988552" y="1828800"/>
-            <a:ext cx="2231136" cy="4023360"/>
-          </a:xfrm>
-          <a:prstGeom prst="rect">
-            <a:avLst/>
-          </a:prstGeom>
-          <a:noFill/>
-        </p:spPr>
-        <p:txBody>
-          <a:bodyPr wrap="square">
-            <a:spAutoFit/>
-          </a:bodyPr>
-          <a:lstStyle/>
-          <a:p>
-            <a:pPr>
-              <a:defRPr sz="1500" b="1">
-                <a:solidFill>
-                  <a:srgbClr val="38BDF8"/>
-                </a:solidFill>
-              </a:defRPr>
-            </a:pPr>
-            <a:r>
-              <a:t>Level-1: Ridge Meta-Learner</a:t>
-            </a:r>
-          </a:p>
-          <a:p>
-            <a:pPr>
-              <a:spcBef>
-                <a:spcPts val="1200"/>
-              </a:spcBef>
-              <a:defRPr sz="1150">
-                <a:solidFill>
-                  <a:srgbClr val="FFFFFF"/>
-                </a:solidFill>
-              </a:defRPr>
-            </a:pPr>
-            <a:r>
-              <a:t>Linear Meta-Regressor with L2 penalty.</a:t>
-            </a:r>
-            <a:br/>
-            <a:br/>
-            <a:r>
-              <a:t>Role: Learns optimal blending weights from out-of-fold cross-validation predictions, preventing overfitting at the ensemble layer.</a:t>
-            </a:r>
-          </a:p>
-        </p:txBody>
-      </p:sp>
+        </p:spPr>
+      </p:pic>
     </p:spTree>
   </p:cSld>
   <p:clrMapOvr>
@@ -6835,14 +6284,12 @@
           </a:bodyPr>
           <a:lstStyle/>
           <a:p>
-            <a:pPr>
-              <a:defRPr sz="1100" b="1">
+            <a:r>
+              <a:rPr sz="1100" b="1">
                 <a:solidFill>
                   <a:srgbClr val="38BDF8"/>
                 </a:solidFill>
-              </a:defRPr>
-            </a:pPr>
-            <a:r>
+              </a:rPr>
               <a:t>HYPERPARAMETER TUNING</a:t>
             </a:r>
           </a:p>
@@ -6870,14 +6317,12 @@
           </a:bodyPr>
           <a:lstStyle/>
           <a:p>
-            <a:pPr>
-              <a:defRPr sz="2400" b="1">
+            <a:r>
+              <a:rPr sz="2400" b="1">
                 <a:solidFill>
                   <a:srgbClr val="FFFFFF"/>
                 </a:solidFill>
-              </a:defRPr>
-            </a:pPr>
-            <a:r>
+              </a:rPr>
               <a:t>Bayesian Hyperparameter Optimization via Optuna</a:t>
             </a:r>
           </a:p>
@@ -6905,14 +6350,12 @@
           </a:bodyPr>
           <a:lstStyle/>
           <a:p>
-            <a:pPr>
-              <a:defRPr sz="1700" b="1">
+            <a:r>
+              <a:rPr sz="1800" b="1">
                 <a:solidFill>
                   <a:srgbClr val="38BDF8"/>
                 </a:solidFill>
-              </a:defRPr>
-            </a:pPr>
-            <a:r>
+              </a:rPr>
               <a:t>Why Bayesian Optimization over Grid Search?</a:t>
             </a:r>
           </a:p>
@@ -6921,13 +6364,13 @@
               <a:spcBef>
                 <a:spcPts val="1000"/>
               </a:spcBef>
-              <a:defRPr sz="1300">
+            </a:pPr>
+            <a:r>
+              <a:rPr sz="1300" b="0">
                 <a:solidFill>
                   <a:srgbClr val="FFFFFF"/>
                 </a:solidFill>
-              </a:defRPr>
-            </a:pPr>
-            <a:r>
+              </a:rPr>
               <a:t>• Grid Search is computationally expensive and samples uninformative parameter regions.</a:t>
             </a:r>
           </a:p>
@@ -6936,13 +6379,13 @@
               <a:spcBef>
                 <a:spcPts val="1000"/>
               </a:spcBef>
-              <a:defRPr sz="1300">
+            </a:pPr>
+            <a:r>
+              <a:rPr sz="1300" b="0">
                 <a:solidFill>
                   <a:srgbClr val="FFFFFF"/>
                 </a:solidFill>
-              </a:defRPr>
-            </a:pPr>
-            <a:r>
+              </a:rPr>
               <a:t>• Optuna utilizes Tree-structured Parzen Estimators (TPE) to model the probability distribution of 5-fold CV RMSE.</a:t>
             </a:r>
           </a:p>
@@ -6951,13 +6394,13 @@
               <a:spcBef>
                 <a:spcPts val="1000"/>
               </a:spcBef>
-              <a:defRPr sz="1300">
+            </a:pPr>
+            <a:r>
+              <a:rPr sz="1300" b="0">
                 <a:solidFill>
                   <a:srgbClr val="FFFFFF"/>
                 </a:solidFill>
-              </a:defRPr>
-            </a:pPr>
-            <a:r>
+              </a:rPr>
               <a:t>• It concentrates evaluation trials where parameter combinations historically yield lower error.</a:t>
             </a:r>
           </a:p>
@@ -6966,13 +6409,13 @@
               <a:spcBef>
                 <a:spcPts val="1000"/>
               </a:spcBef>
-              <a:defRPr sz="1300">
+            </a:pPr>
+            <a:r>
+              <a:rPr sz="1300" b="0">
                 <a:solidFill>
                   <a:srgbClr val="FFFFFF"/>
                 </a:solidFill>
-              </a:defRPr>
-            </a:pPr>
-            <a:r>
+              </a:rPr>
               <a:t>• Optimal parameters saved to models/best_params.json for transparent, reproducible deployment.</a:t>
             </a:r>
           </a:p>
@@ -7045,14 +6488,12 @@
           </a:bodyPr>
           <a:lstStyle/>
           <a:p>
-            <a:pPr>
-              <a:defRPr sz="1600" b="1">
+            <a:r>
+              <a:rPr sz="1600" b="1">
                 <a:solidFill>
                   <a:srgbClr val="34D399"/>
                 </a:solidFill>
-              </a:defRPr>
-            </a:pPr>
-            <a:r>
+              </a:rPr>
               <a:t>Tuned Hyperparameter Snapshot:</a:t>
             </a:r>
           </a:p>
@@ -7061,57 +6502,24 @@
               <a:spcBef>
                 <a:spcPts val="1000"/>
               </a:spcBef>
-              <a:defRPr sz="1150">
+            </a:pPr>
+            <a:r>
+              <a:rPr sz="1150" b="0">
                 <a:solidFill>
                   <a:srgbClr val="FFFFFF"/>
                 </a:solidFill>
-              </a:defRPr>
-            </a:pPr>
-            <a:r>
-              <a:t>XGBoost Regressor:</a:t>
-            </a:r>
-            <a:br/>
-            <a:r>
-              <a:t>• n_estimators = 300  |  max_depth = 4</a:t>
-            </a:r>
-            <a:br/>
-            <a:r>
-              <a:t>• learning_rate = 0.0256  |  subsample = 0.7</a:t>
-            </a:r>
-            <a:br/>
-            <a:r>
-              <a:t>• colsample_bytree = 0.8  |  min_child_weight = 2</a:t>
-            </a:r>
-            <a:br/>
-            <a:br/>
-            <a:r>
-              <a:t>Random Forest Regressor:</a:t>
-            </a:r>
-            <a:br/>
-            <a:r>
-              <a:t>• n_estimators = 200  |  max_depth = 15</a:t>
-            </a:r>
-            <a:br/>
-            <a:r>
-              <a:t>• min_samples_leaf = 4  |  max_features = 0.7</a:t>
-            </a:r>
-            <a:br/>
-            <a:br/>
-            <a:r>
-              <a:t>Support Vector Regressor (SVR):</a:t>
-            </a:r>
-            <a:br/>
-            <a:r>
-              <a:t>• C = 1.292  |  epsilon = 0.0857  |  gamma = 'auto'</a:t>
-            </a:r>
-            <a:br/>
-            <a:br/>
-            <a:r>
-              <a:t>Stacking Meta-Learner (Ridge):</a:t>
-            </a:r>
-            <a:br/>
-            <a:r>
-              <a:t>• alpha = 0.0105  (Optimal L2 shrinkage)</a:t>
+              </a:rPr>
+              <a:t>XGBoost Regressor:
+• n_estimators = 300  |  max_depth = 4
+• learning_rate = 0.0256  |  subsample = 0.7
+• colsample_bytree = 0.8  |  min_child_weight = 2
+Random Forest Regressor:
+• n_estimators = 200  |  max_depth = 15
+• min_samples_leaf = 4  |  max_features = 0.7
+Support Vector Regressor (SVR):
+• C = 1.292  |  epsilon = 0.0857  |  gamma = 'auto'
+Stacking Meta-Learner (Ridge):
+• alpha = 0.0105  (Optimal L2 shrinkage)</a:t>
             </a:r>
           </a:p>
         </p:txBody>
@@ -7199,14 +6607,12 @@
           </a:bodyPr>
           <a:lstStyle/>
           <a:p>
-            <a:pPr>
-              <a:defRPr sz="1100" b="1">
+            <a:r>
+              <a:rPr sz="1100" b="1">
                 <a:solidFill>
                   <a:srgbClr val="38BDF8"/>
                 </a:solidFill>
-              </a:defRPr>
-            </a:pPr>
-            <a:r>
+              </a:rPr>
               <a:t>RANK SPECIALIZATION</a:t>
             </a:r>
           </a:p>
@@ -7234,14 +6640,12 @@
           </a:bodyPr>
           <a:lstStyle/>
           <a:p>
-            <a:pPr>
-              <a:defRPr sz="2400" b="1">
+            <a:r>
+              <a:rPr sz="2400" b="1">
                 <a:solidFill>
                   <a:srgbClr val="FFFFFF"/>
                 </a:solidFill>
-              </a:defRPr>
-            </a:pPr>
-            <a:r>
+              </a:rPr>
               <a:t>Coal Rank Specialization: ASTM D388 Bituminous Model</a:t>
             </a:r>
           </a:p>
@@ -7269,14 +6673,12 @@
           </a:bodyPr>
           <a:lstStyle/>
           <a:p>
-            <a:pPr>
-              <a:defRPr sz="1700" b="1">
+            <a:r>
+              <a:rPr sz="1700" b="1">
                 <a:solidFill>
                   <a:srgbClr val="34D399"/>
                 </a:solidFill>
-              </a:defRPr>
-            </a:pPr>
-            <a:r>
+              </a:rPr>
               <a:t>The Scientific Rationale for Rank Segregation:</a:t>
             </a:r>
           </a:p>
@@ -7285,13 +6687,13 @@
               <a:spcBef>
                 <a:spcPts val="800"/>
               </a:spcBef>
-              <a:defRPr sz="1250">
+            </a:pPr>
+            <a:r>
+              <a:rPr sz="1250" b="0">
                 <a:solidFill>
                   <a:srgbClr val="FFFFFF"/>
                 </a:solidFill>
-              </a:defRPr>
-            </a:pPr>
-            <a:r>
+              </a:rPr>
               <a:t>• Coal is chemically non-homogeneous across geological ranks. Lignite, Bituminous, and Anthracite exhibit vastly different volatile release kinetics.</a:t>
             </a:r>
           </a:p>
@@ -7300,26 +6702,17 @@
               <a:spcBef>
                 <a:spcPts val="800"/>
               </a:spcBef>
-              <a:defRPr sz="1250">
+            </a:pPr>
+            <a:r>
+              <a:rPr sz="1250" b="0">
                 <a:solidFill>
                   <a:srgbClr val="FFFFFF"/>
                 </a:solidFill>
-              </a:defRPr>
-            </a:pPr>
-            <a:r>
-              <a:t>• Under ASTM D388, Bituminous Coal is strictly classified by:</a:t>
-            </a:r>
-            <a:br/>
-            <a:r>
-              <a:t>• Moist Mineral-Matter-Free Btu &gt;= 10,500 Btu/lb</a:t>
-            </a:r>
-            <a:br/>
-            <a:r>
-              <a:t>• Dry MMF Volatile Matter &gt;= 14.0%</a:t>
-            </a:r>
-            <a:br/>
-            <a:r>
-              <a:t>• Dry MMF Fixed Carbon &lt; 86.0%</a:t>
+              </a:rPr>
+              <a:t>• Under ASTM D388, Bituminous Coal is strictly classified by:
+• Moist Mineral-Matter-Free Btu &gt;= 10,500 Btu/lb
+• Dry MMF Volatile Matter &gt;= 14.0%
+• Dry MMF Fixed Carbon &lt; 86.0%</a:t>
             </a:r>
           </a:p>
           <a:p>
@@ -7327,13 +6720,13 @@
               <a:spcBef>
                 <a:spcPts val="800"/>
               </a:spcBef>
-              <a:defRPr sz="1250">
+            </a:pPr>
+            <a:r>
+              <a:rPr sz="1250" b="0">
                 <a:solidFill>
                   <a:srgbClr val="FFFFFF"/>
                 </a:solidFill>
-              </a:defRPr>
-            </a:pPr>
-            <a:r>
+              </a:rPr>
               <a:t>• We isolated 4,494 verified bituminous samples and trained a dedicated model pipeline (src/train_bituminous.py).</a:t>
             </a:r>
           </a:p>
@@ -7342,26 +6735,17 @@
               <a:spcBef>
                 <a:spcPts val="800"/>
               </a:spcBef>
-              <a:defRPr sz="1250">
+            </a:pPr>
+            <a:r>
+              <a:rPr sz="1250" b="0">
                 <a:solidFill>
                   <a:srgbClr val="FFFFFF"/>
                 </a:solidFill>
-              </a:defRPr>
-            </a:pPr>
-            <a:r>
-              <a:t>• Performance Impact:</a:t>
-            </a:r>
-            <a:br/>
-            <a:r>
-              <a:t>• RMSE dropped to 134.18 Kcal/kg (vs 150.28)</a:t>
-            </a:r>
-            <a:br/>
-            <a:r>
-              <a:t>• MAE dropped to 96.29 Kcal/kg (sub-100 error!)</a:t>
-            </a:r>
-            <a:br/>
-            <a:r>
-              <a:t>• CV Score reached 1.91%</a:t>
+              </a:rPr>
+              <a:t>• Performance Impact:
+• RMSE dropped to 134.18 Kcal/kg (vs 150.28)
+• MAE dropped to 96.29 Kcal/kg (sub-100 error!)
+• CV Score reached 1.91%</a:t>
             </a:r>
           </a:p>
         </p:txBody>
@@ -7473,14 +6857,12 @@
           </a:bodyPr>
           <a:lstStyle/>
           <a:p>
-            <a:pPr>
-              <a:defRPr sz="1100" b="1">
+            <a:r>
+              <a:rPr sz="1100" b="1">
                 <a:solidFill>
                   <a:srgbClr val="38BDF8"/>
                 </a:solidFill>
-              </a:defRPr>
-            </a:pPr>
-            <a:r>
+              </a:rPr>
               <a:t>MODEL INTERPRETABILITY</a:t>
             </a:r>
           </a:p>
@@ -7508,14 +6890,12 @@
           </a:bodyPr>
           <a:lstStyle/>
           <a:p>
-            <a:pPr>
-              <a:defRPr sz="2400" b="1">
+            <a:r>
+              <a:rPr sz="2400" b="1">
                 <a:solidFill>
                   <a:srgbClr val="FFFFFF"/>
                 </a:solidFill>
-              </a:defRPr>
-            </a:pPr>
-            <a:r>
+              </a:rPr>
               <a:t>Explainable AI: SHAP Chemical Interpretability</a:t>
             </a:r>
           </a:p>
@@ -7543,14 +6923,12 @@
           </a:bodyPr>
           <a:lstStyle/>
           <a:p>
-            <a:pPr>
-              <a:defRPr sz="1700" b="1">
+            <a:r>
+              <a:rPr sz="1700" b="1">
                 <a:solidFill>
                   <a:srgbClr val="38BDF8"/>
                 </a:solidFill>
-              </a:defRPr>
-            </a:pPr>
-            <a:r>
+              </a:rPr>
               <a:t>Overcoming the 'Black Box' Critique:</a:t>
             </a:r>
           </a:p>
@@ -7559,13 +6937,13 @@
               <a:spcBef>
                 <a:spcPts val="800"/>
               </a:spcBef>
-              <a:defRPr sz="1200">
+            </a:pPr>
+            <a:r>
+              <a:rPr sz="1200" b="0">
                 <a:solidFill>
                   <a:srgbClr val="FFFFFF"/>
                 </a:solidFill>
-              </a:defRPr>
-            </a:pPr>
-            <a:r>
+              </a:rPr>
               <a:t>• Engineers rightfully distrust black-box ML models when plant safety and boiler efficiency are at stake.</a:t>
             </a:r>
           </a:p>
@@ -7574,13 +6952,13 @@
               <a:spcBef>
                 <a:spcPts val="800"/>
               </a:spcBef>
-              <a:defRPr sz="1200">
+            </a:pPr>
+            <a:r>
+              <a:rPr sz="1200" b="0">
                 <a:solidFill>
                   <a:srgbClr val="FFFFFF"/>
                 </a:solidFill>
-              </a:defRPr>
-            </a:pPr>
-            <a:r>
+              </a:rPr>
               <a:t>• We integrated SHAP (SHapley Additive exPlanations) using TreeExplainer to explain individual local predictions.</a:t>
             </a:r>
           </a:p>
@@ -7589,26 +6967,17 @@
               <a:spcBef>
                 <a:spcPts val="800"/>
               </a:spcBef>
-              <a:defRPr sz="1200">
+            </a:pPr>
+            <a:r>
+              <a:rPr sz="1200" b="0">
                 <a:solidFill>
                   <a:srgbClr val="FFFFFF"/>
                 </a:solidFill>
-              </a:defRPr>
-            </a:pPr>
-            <a:r>
-              <a:t>• Thermodynamic Sanity Check:</a:t>
-            </a:r>
-            <a:br/>
-            <a:r>
-              <a:t>• Moisture: Strong negative SHAP driver (water absorbs heat via vaporization at 540 cal/g).</a:t>
-            </a:r>
-            <a:br/>
-            <a:r>
-              <a:t>• Ash: Strong negative SHAP driver (inert mineral matter acts as a thermal heat sink).</a:t>
-            </a:r>
-            <a:br/>
-            <a:r>
-              <a:t>• Fixed Carbon &amp; Fuel Ratio: Dominant positive drivers (primary energy-producing organic matrix).</a:t>
+              </a:rPr>
+              <a:t>• Thermodynamic Sanity Check:
+• Moisture: Strong negative SHAP driver (water absorbs heat via vaporization at 540 cal/g).
+• Ash: Strong negative SHAP driver (inert mineral matter acts as a thermal heat sink).
+• Fixed Carbon &amp; Fuel Ratio: Dominant positive drivers (primary energy-producing organic matrix).</a:t>
             </a:r>
           </a:p>
           <a:p>
@@ -7616,13 +6985,13 @@
               <a:spcBef>
                 <a:spcPts val="800"/>
               </a:spcBef>
-              <a:defRPr sz="1200">
+            </a:pPr>
+            <a:r>
+              <a:rPr sz="1200" b="0">
                 <a:solidFill>
                   <a:srgbClr val="FFFFFF"/>
                 </a:solidFill>
-              </a:defRPr>
-            </a:pPr>
-            <a:r>
+              </a:rPr>
               <a:t>• The model's internal feature attribution perfectly validates established combustion thermodynamics.</a:t>
             </a:r>
           </a:p>

</xml_diff>

<commit_message>
Simplify slide language and balance architecture diagram left-to-right
</commit_message>
<xml_diff>
--- a/Coal_GCV_Prediction_Presentation.pptx
+++ b/Coal_GCV_Prediction_Presentation.pptx
@@ -3149,8 +3149,8 @@
         </p:nvSpPr>
         <p:spPr>
           <a:xfrm>
-            <a:off x="731520" y="1645920"/>
-            <a:ext cx="164592" cy="3474720"/>
+            <a:off x="731520" y="1828800"/>
+            <a:ext cx="164592" cy="3108960"/>
           </a:xfrm>
           <a:prstGeom prst="rect">
             <a:avLst/>
@@ -3192,8 +3192,8 @@
         </p:nvSpPr>
         <p:spPr>
           <a:xfrm>
-            <a:off x="1097280" y="1645920"/>
-            <a:ext cx="10241280" cy="3840480"/>
+            <a:off x="1097280" y="1737360"/>
+            <a:ext cx="10241280" cy="3474720"/>
           </a:xfrm>
           <a:prstGeom prst="rect">
             <a:avLst/>
@@ -3207,69 +3207,69 @@
           <a:lstStyle/>
           <a:p>
             <a:r>
-              <a:rPr sz="3600" b="1">
+              <a:rPr sz="3800" b="1">
                 <a:solidFill>
                   <a:srgbClr val="FFFFFF"/>
                 </a:solidFill>
               </a:rPr>
-              <a:t>COAL GROSS CALORIFIC VALUE (GCV) PREDICTION</a:t>
+              <a:t>COAL GCV PREDICTION SYSTEM</a:t>
             </a:r>
           </a:p>
           <a:p>
             <a:pPr>
               <a:spcBef>
-                <a:spcPts val="1200"/>
+                <a:spcPts val="1400"/>
               </a:spcBef>
             </a:pPr>
             <a:r>
-              <a:rPr sz="2000" b="1">
+              <a:rPr sz="2100" b="1">
                 <a:solidFill>
                   <a:srgbClr val="38BDF8"/>
                 </a:solidFill>
               </a:rPr>
-              <a:t>High-Precision Estimation from Proximate Analysis via Bayesian-Tuned Stacking Ensembles</a:t>
+              <a:t>Estimating Coal Energy Value from Lab Tests using Machine Learning</a:t>
             </a:r>
           </a:p>
           <a:p>
             <a:pPr>
               <a:spcBef>
-                <a:spcPts val="2000"/>
+                <a:spcPts val="2200"/>
               </a:spcBef>
             </a:pPr>
             <a:r>
-              <a:rPr sz="1400" b="0">
+              <a:rPr sz="1400">
                 <a:solidFill>
                   <a:srgbClr val="FFFFFF"/>
                 </a:solidFill>
               </a:rPr>
-              <a:t>• Optimized Machine Learning Architecture (XGBoost, Random Forest, SVR + Ridge Meta-Learner)
+              <a:t>• Uses simple lab inputs: Moisture, Volatile Matter, and Ash
 </a:t>
             </a:r>
             <a:r>
-              <a:rPr sz="1400" b="0">
+              <a:rPr sz="1400">
                 <a:solidFill>
                   <a:srgbClr val="FFFFFF"/>
                 </a:solidFill>
               </a:rPr>
-              <a:t>• Zero-Leakage Data Hygiene &amp; ASTM D388 Coal Rank Specialization
+              <a:t>• Combines Random Forest, XGBoost, and SVM for high accuracy
 </a:t>
             </a:r>
             <a:r>
-              <a:rPr sz="1400" b="0">
+              <a:rPr sz="1400">
                 <a:solidFill>
                   <a:srgbClr val="FFFFFF"/>
                 </a:solidFill>
               </a:rPr>
-              <a:t>• Model Interpretability via SHAP (SHapley Additive exPlanations)
+              <a:t>• Tested on real geological coal data with sub-2% error
 </a:t>
             </a:r>
             <a:r>
-              <a:rPr sz="1400" b="0">
+              <a:rPr sz="1400">
                 <a:solidFill>
                   <a:srgbClr val="FFFFFF"/>
                 </a:solidFill>
               </a:rPr>
-              <a:t>• Live Interactive Web Deployment with Chemical Safety Guardrails
+              <a:t>• Web app with interactive charts showing why the model makes each prediction
 </a:t>
             </a:r>
           </a:p>
@@ -3364,7 +3364,7 @@
                   <a:srgbClr val="38BDF8"/>
                 </a:solidFill>
               </a:rPr>
-              <a:t>SYSTEM DEPLOYMENT</a:t>
+              <a:t>WEB APPLICATION</a:t>
             </a:r>
           </a:p>
         </p:txBody>
@@ -3397,7 +3397,7 @@
                   <a:srgbClr val="FFFFFF"/>
                 </a:solidFill>
               </a:rPr>
-              <a:t>Interactive Streamlit Deployment &amp; Domain Guardrails</a:t>
+              <a:t>Interactive Web App &amp; Safety Checks</a:t>
             </a:r>
           </a:p>
         </p:txBody>
@@ -3475,7 +3475,7 @@
                   <a:srgbClr val="38BDF8"/>
                 </a:solidFill>
               </a:rPr>
-              <a:t>Dual-Tab Architecture</a:t>
+              <a:t>Two Dedicated Tabs</a:t>
             </a:r>
           </a:p>
           <a:p>
@@ -3490,9 +3490,9 @@
                   <a:srgbClr val="FFFFFF"/>
                 </a:solidFill>
               </a:rPr>
-              <a:t>• Tab 1: Universal Model (All coal ranks)
-• Tab 2: Bituminous Specialized Model (ASTM D388)
-Users seamlessly switch between general coal and high-precision bituminous mode.</a:t>
+              <a:t>• Tab 1: Universal Model for all coal types
+• Tab 2: Specialized Bituminous Model
+Users can test any coal sample or switch to the specialized model for higher precision.</a:t>
             </a:r>
           </a:p>
         </p:txBody>
@@ -3570,7 +3570,7 @@
                   <a:srgbClr val="FB923C"/>
                 </a:solidFill>
               </a:rPr>
-              <a:t>Domain-Specific Guardrails</a:t>
+              <a:t>Safety &amp; Validation Checks</a:t>
             </a:r>
           </a:p>
           <a:p>
@@ -3585,8 +3585,8 @@
                   <a:srgbClr val="FFFFFF"/>
                 </a:solidFill>
               </a:rPr>
-              <a:t>• Mass Balance Validation: Flags an immediate error if Moisture + VM + Ash &gt; 100%.
-• Ash Limit Rule: Rejects inputs exceeding realistic combustible limits (Ash &gt; 55%).</a:t>
+              <a:t>• Mass Balance Check: If Moisture + VM + Ash exceeds 100%, the app warns the user.
+• Ash Limit Check: Rejects impossible samples where Ash is greater than 55%.</a:t>
             </a:r>
           </a:p>
         </p:txBody>
@@ -3664,7 +3664,7 @@
                   <a:srgbClr val="34D399"/>
                 </a:solidFill>
               </a:rPr>
-              <a:t>Real-Time Explainability</a:t>
+              <a:t>Instant Visual Explanations</a:t>
             </a:r>
           </a:p>
           <a:p>
@@ -3679,7 +3679,7 @@
                   <a:srgbClr val="FFFFFF"/>
                 </a:solidFill>
               </a:rPr>
-              <a:t>Every slider adjustment instantly triggers model re-prediction and renders dynamic SHAP waterfall plots explaining the chemical drivers behind that specific prediction.</a:t>
+              <a:t>Whenever a slider is moved, the app recalculates the prediction instantly and draws a SHAP graph showing which feature had the biggest impact.</a:t>
             </a:r>
           </a:p>
         </p:txBody>
@@ -3757,7 +3757,7 @@
                   <a:srgbClr val="38BDF8"/>
                 </a:solidFill>
               </a:rPr>
-              <a:t>Production Cloud Ready</a:t>
+              <a:t>Live Web Deployment</a:t>
             </a:r>
           </a:p>
           <a:p>
@@ -3772,7 +3772,7 @@
                   <a:srgbClr val="FFFFFF"/>
                 </a:solidFill>
               </a:rPr>
-              <a:t>Deployed via Streamlit Community Cloud with GitHub CI/CD tracking main branch. Serialized models (&lt;20MB) load in sub-second inference speed.</a:t>
+              <a:t>The application is deployed on Streamlit Cloud and connected to our GitHub repository for easy sharing and testing from any browser.</a:t>
             </a:r>
           </a:p>
         </p:txBody>
@@ -3866,7 +3866,7 @@
                   <a:srgbClr val="38BDF8"/>
                 </a:solidFill>
               </a:rPr>
-              <a:t>CONCLUSION &amp; ROADMAP</a:t>
+              <a:t>CONCLUSION</a:t>
             </a:r>
           </a:p>
         </p:txBody>
@@ -3899,7 +3899,7 @@
                   <a:srgbClr val="FFFFFF"/>
                 </a:solidFill>
               </a:rPr>
-              <a:t>Project Summary &amp; Future Research Directions</a:t>
+              <a:t>Summary &amp; Future Improvements</a:t>
             </a:r>
           </a:p>
         </p:txBody>
@@ -3972,12 +3972,12 @@
           <a:lstStyle/>
           <a:p>
             <a:r>
-              <a:rPr sz="1700" b="1">
+              <a:rPr sz="1800" b="1">
                 <a:solidFill>
                   <a:srgbClr val="34D399"/>
                 </a:solidFill>
               </a:rPr>
-              <a:t>Final Performance Summary:</a:t>
+              <a:t>Key Results:</a:t>
             </a:r>
           </a:p>
           <a:p>
@@ -3987,21 +3987,21 @@
               </a:spcBef>
             </a:pPr>
             <a:r>
-              <a:rPr sz="1200" b="0">
+              <a:rPr sz="1250" b="0">
                 <a:solidFill>
                   <a:srgbClr val="FFFFFF"/>
                 </a:solidFill>
               </a:rPr>
-              <a:t>Universal Stacking Model (All Ranks):
-• 5-Fold CV RMSE: 150.28 Kcal/kg
-• 5-Fold CV MAE: 105.97 Kcal/kg
-• Coefficient of Variation (CV): 2.18%
-• Variance Explained (R²): 0.9595
-Bituminous Specialized Model (ASTM D388):
-• 5-Fold CV RMSE: 134.18 Kcal/kg  (-16.10)
-• 5-Fold CV MAE: 96.29 Kcal/kg  (&lt;100!)
-• Coefficient of Variation (CV): 1.91%
-• Variance Explained (R²): 0.9524</a:t>
+              <a:t>Universal Model (All Coal):
+• Average Error (RMSE): 150.28 Kcal/kg
+• Absolute Error (MAE): 105.97 Kcal/kg
+• Error Percentage: 2.18% (target was &lt; 8%)
+• Accuracy (R²): 0.96
+Bituminous Model:
+• Average Error (RMSE): 134.18 Kcal/kg
+• Absolute Error (MAE): 96.29 Kcal/kg
+• Error Percentage: 1.91%
+• Accuracy (R²): 0.95</a:t>
             </a:r>
           </a:p>
         </p:txBody>
@@ -4074,12 +4074,12 @@
           <a:lstStyle/>
           <a:p>
             <a:r>
-              <a:rPr sz="1700" b="1">
+              <a:rPr sz="1800" b="1">
                 <a:solidFill>
                   <a:srgbClr val="38BDF8"/>
                 </a:solidFill>
               </a:rPr>
-              <a:t>Future Research &amp; Engineering Scope:</a:t>
+              <a:t>What Can Be Added Next:</a:t>
             </a:r>
           </a:p>
           <a:p>
@@ -4094,14 +4094,14 @@
                   <a:srgbClr val="FFFFFF"/>
                 </a:solidFill>
               </a:rPr>
-              <a:t>1. Dual-Tier Elemental Analysis Mode:
-Ingest Ultimate Analysis (Carbon, Hydrogen, Oxygen, Sulfur) when available to drive RMSE below 50 Kcal/kg.
-2. Quantile Regression &amp; Uncertainty Bounds:
-Predict 90% confidence intervals around GCV values rather than point estimates to inform risk-aware procurement.
-3. High-Throughput Batch Processing:
-Enable bulk CSV uploads for trainload shipments with automated PDF laboratory certificates.
-4. Classical Formula Benchmarking:
-Provide direct mathematical comparisons against Goutal and Dulong empirical equations.</a:t>
+              <a:t>1. Ultimate Analysis Mode:
+If elemental test numbers are available (Carbon, Hydrogen, Oxygen, Sulfur), adding them can bring error under 50 Kcal/kg.
+2. Prediction Ranges (Confidence Intervals):
+Give a range (e.g. 6800 ± 80 Kcal/kg) instead of a single number to show certainty.
+3. Bulk Upload:
+Add a button in the web app to upload a full CSV with thousands of samples at once.
+4. Formula Comparison:
+Compare model accuracy directly with classical Dulong and Goutal empirical formulas.</a:t>
             </a:r>
           </a:p>
         </p:txBody>
@@ -4195,7 +4195,7 @@
                   <a:srgbClr val="38BDF8"/>
                 </a:solidFill>
               </a:rPr>
-              <a:t>CONTEXT &amp; OBJECTIVE</a:t>
+              <a:t>BACKGROUND</a:t>
             </a:r>
           </a:p>
         </p:txBody>
@@ -4228,7 +4228,7 @@
                   <a:srgbClr val="FFFFFF"/>
                 </a:solidFill>
               </a:rPr>
-              <a:t>Industrial Motivation &amp; Problem Formulation</a:t>
+              <a:t>Problem &amp; Motivation</a:t>
             </a:r>
           </a:p>
         </p:txBody>
@@ -4306,7 +4306,7 @@
                   <a:srgbClr val="FB923C"/>
                 </a:solidFill>
               </a:rPr>
-              <a:t>The Laboratory Bottleneck</a:t>
+              <a:t>The Current Problem</a:t>
             </a:r>
           </a:p>
           <a:p>
@@ -4321,8 +4321,8 @@
                   <a:srgbClr val="FFFFFF"/>
                 </a:solidFill>
               </a:rPr>
-              <a:t>Standard bomb calorimetry requires oxygen-pressurized combustion bombs, calibrated water jackets, and skilled technicians.
-Result: 24–48 hour turnaround times delay critical coal blending decisions in power plants.</a:t>
+              <a:t>Measuring Gross Calorific Value (GCV) experimentally in a bomb calorimeter is slow and requires expensive equipment.
+Lab results often take 1 to 2 days, delaying decisions in power plants and coal trading.</a:t>
             </a:r>
           </a:p>
         </p:txBody>
@@ -4400,7 +4400,7 @@
                   <a:srgbClr val="38BDF8"/>
                 </a:solidFill>
               </a:rPr>
-              <a:t>The Proximate Advantage</a:t>
+              <a:t>The Solution</a:t>
             </a:r>
           </a:p>
           <a:p>
@@ -4415,8 +4415,8 @@
                   <a:srgbClr val="FFFFFF"/>
                 </a:solidFill>
               </a:rPr>
-              <a:t>Proximate analysis (Moisture, Volatile Matter, Ash) is rapid, inexpensive, and standardized.
-Goal: Map proximate parameters directly to GCV with high fidelity, enabling immediate day-of-delivery decision making.</a:t>
+              <a:t>Proximate analysis (Moisture, Volatile Matter, and Ash) is quick, cheap, and routine.
+We train Machine Learning models to calculate GCV accurately from these basic numbers in seconds.</a:t>
             </a:r>
           </a:p>
         </p:txBody>
@@ -4494,7 +4494,7 @@
                   <a:srgbClr val="34D399"/>
                 </a:solidFill>
               </a:rPr>
-              <a:t>Rigorous Target Metrics</a:t>
+              <a:t>Accuracy Target</a:t>
             </a:r>
           </a:p>
           <a:p>
@@ -4509,9 +4509,11 @@
                   <a:srgbClr val="FFFFFF"/>
                 </a:solidFill>
               </a:rPr>
-              <a:t>Target RMSE: &lt;= 200 Kcal/kg
-Target CV Score: &lt; 8.0%
-Our system surpassed both tolerances, delivering 150.28 Kcal/kg (2.18% CV) overall and 134.18 Kcal/kg (1.91% CV) for bituminous coal.</a:t>
+              <a:t>Industry Target: RMSE under 200 Kcal/kg (Error under 8%).
+Our Results:
+• Overall model: 150 Kcal/kg (2.18% error)
+• Bituminous model: 134 Kcal/kg (1.91% error)
+Both easily beat the target.</a:t>
             </a:r>
           </a:p>
         </p:txBody>
@@ -4605,7 +4607,7 @@
                   <a:srgbClr val="38BDF8"/>
                 </a:solidFill>
               </a:rPr>
-              <a:t>DATASET &amp; PREPROCESSING</a:t>
+              <a:t>DATASET</a:t>
             </a:r>
           </a:p>
         </p:txBody>
@@ -4638,7 +4640,7 @@
                   <a:srgbClr val="FFFFFF"/>
                 </a:solidFill>
               </a:rPr>
-              <a:t>Data Hygiene &amp; Zero-Target-Leakage Protocol</a:t>
+              <a:t>Data Preparation &amp; Cleaning</a:t>
             </a:r>
           </a:p>
         </p:txBody>
@@ -4716,7 +4718,7 @@
                   <a:srgbClr val="38BDF8"/>
                 </a:solidFill>
               </a:rPr>
-              <a:t>1. Unit Standardization</a:t>
+              <a:t>1. Unit Conversion</a:t>
             </a:r>
           </a:p>
           <a:p>
@@ -4731,7 +4733,8 @@
                   <a:srgbClr val="FFFFFF"/>
                 </a:solidFill>
               </a:rPr>
-              <a:t>Raw dataset contains imperial heating values in Btu/lb. Converted to international metric standard:
+              <a:t>Raw laboratory data came with heating values in Btu/lb.
+Converted to standard metric units:
 GCV (Kcal/kg) = Btu / 1.8</a:t>
             </a:r>
           </a:p>
@@ -4810,7 +4813,7 @@
                   <a:srgbClr val="34D399"/>
                 </a:solidFill>
               </a:rPr>
-              <a:t>2. Zero Target Leakage</a:t>
+              <a:t>2. Handling Missing Values</a:t>
             </a:r>
           </a:p>
           <a:p>
@@ -4825,7 +4828,8 @@
                   <a:srgbClr val="FFFFFF"/>
                 </a:solidFill>
               </a:rPr>
-              <a:t>In amateur ML workflows, imputers often fit across features AND target GCV. We enforced strict isolation: KNN imputation fits ONLY on features [Moisture, VM, Ash].</a:t>
+              <a:t>Some samples had missing moisture or ash values.
+Used a K-Nearest Neighbors (KNN) imputer using only other input features, never using the target value.</a:t>
             </a:r>
           </a:p>
         </p:txBody>
@@ -4903,7 +4907,7 @@
                   <a:srgbClr val="FB923C"/>
                 </a:solidFill>
               </a:rPr>
-              <a:t>3. Physical Bounds</a:t>
+              <a:t>3. Removing Bad Data</a:t>
             </a:r>
           </a:p>
           <a:p>
@@ -4918,10 +4922,10 @@
                   <a:srgbClr val="FFFFFF"/>
                 </a:solidFill>
               </a:rPr>
-              <a:t>Enforced physical combustion realism:
-• GCV: 2000 to 9000 Kcal/kg
-• Standard Ash &lt;= 55%
-• Moisture &lt;= 45%, VM &lt;= 60%</a:t>
+              <a:t>Removed obvious measurement errors and impossible samples:
+• Energy below 2000 or above 9000 Kcal/kg
+• Ash above 55% (unusable for fuel)
+• Negative moisture or volatile matter</a:t>
             </a:r>
           </a:p>
         </p:txBody>
@@ -4999,7 +5003,7 @@
                   <a:srgbClr val="38BDF8"/>
                 </a:solidFill>
               </a:rPr>
-              <a:t>4. Mass Balance Integrity</a:t>
+              <a:t>4. Mass Balance Check</a:t>
             </a:r>
           </a:p>
           <a:p>
@@ -5014,9 +5018,9 @@
                   <a:srgbClr val="FFFFFF"/>
                 </a:solidFill>
               </a:rPr>
-              <a:t>By proximate definition, components sum to 100%:
+              <a:t>Moisture + Volatiles + Ash + Carbon must total 100%:
 Fixed Carbon = 100 - (Moisture + VM + Ash)
-Retained exclusively samples with Fixed Carbon &gt; 0.</a:t>
+Removed any samples where this total was broken.</a:t>
             </a:r>
           </a:p>
         </p:txBody>
@@ -5110,7 +5114,7 @@
                   <a:srgbClr val="38BDF8"/>
                 </a:solidFill>
               </a:rPr>
-              <a:t>FEATURE ENGINEERING</a:t>
+              <a:t>FEATURE CALCULATION</a:t>
             </a:r>
           </a:p>
         </p:txBody>
@@ -5143,7 +5147,7 @@
                   <a:srgbClr val="FFFFFF"/>
                 </a:solidFill>
               </a:rPr>
-              <a:t>Domain Feature Engineering: Why Add Fuel Ratio?</a:t>
+              <a:t>Feature Calculation: Why Add Fuel Ratio?</a:t>
             </a:r>
           </a:p>
         </p:txBody>
@@ -5176,7 +5180,7 @@
                   <a:srgbClr val="FB923C"/>
                 </a:solidFill>
               </a:rPr>
-              <a:t>The Mathematical Limitation of Tree Models:</a:t>
+              <a:t>Why ML Models Need Help With Division:</a:t>
             </a:r>
           </a:p>
           <a:p>
@@ -5191,7 +5195,7 @@
                   <a:srgbClr val="FFFFFF"/>
                 </a:solidFill>
               </a:rPr>
-              <a:t>• Decision trees split orthogonally (Xi &gt; c). They cannot naturally compute division between features without hundreds of step-wise splits.</a:t>
+              <a:t>• Decision trees (XGBoost, Random Forest) split data using simple 'if greater than' rules. They cannot naturally divide two numbers without hundreds of complex splits.</a:t>
             </a:r>
           </a:p>
           <a:p>
@@ -5206,7 +5210,7 @@
                   <a:srgbClr val="FFFFFF"/>
                 </a:solidFill>
               </a:rPr>
-              <a:t>• In coal petrology, the Fuel Ratio is defined as:
+              <a:t>• In coal chemistry, Fuel Ratio is a standard formula:
 Fuel Ratio = Fixed Carbon / Volatile Matter</a:t>
             </a:r>
           </a:p>
@@ -5222,7 +5226,7 @@
                   <a:srgbClr val="FFFFFF"/>
                 </a:solidFill>
               </a:rPr>
-              <a:t>• Fuel Ratio is the universally accepted chemical proxy for coal rank (Anthracite vs Bituminous vs Lignite).</a:t>
+              <a:t>• Fuel Ratio tells you what kind of coal you have (Lignite vs Bituminous vs Anthracite).</a:t>
             </a:r>
           </a:p>
           <a:p>
@@ -5237,7 +5241,7 @@
                   <a:srgbClr val="FFFFFF"/>
                 </a:solidFill>
               </a:rPr>
-              <a:t>• By calculating it explicitly prior to training, we feed the model an explicit rank descriptor without requiring extra lab testing.</a:t>
+              <a:t>• By doing the division for the model beforehand, the trees understand coal rank immediately without needing extra depth.</a:t>
             </a:r>
           </a:p>
         </p:txBody>
@@ -5315,7 +5319,7 @@
                   <a:srgbClr val="34D399"/>
                 </a:solidFill>
               </a:rPr>
-              <a:t>Mass Balance Formulation:</a:t>
+              <a:t>Formulas Added to the Data:</a:t>
             </a:r>
           </a:p>
           <a:p>
@@ -5325,13 +5329,13 @@
               </a:spcBef>
             </a:pPr>
             <a:r>
-              <a:rPr sz="1600" b="1">
+              <a:rPr sz="1500" b="1">
                 <a:solidFill>
                   <a:srgbClr val="FFFFFF"/>
                 </a:solidFill>
               </a:rPr>
-              <a:t>FC = 100 - (Moisture + VM + Ash)
-Fuel Ratio = FC / VM</a:t>
+              <a:t>1. Fixed Carbon = 100 - (Moisture + VM + Ash)
+2. Fuel Ratio = Fixed Carbon / VM</a:t>
             </a:r>
           </a:p>
           <a:p>
@@ -5347,10 +5351,10 @@
                 </a:solidFill>
               </a:rPr>
               <a:t>
-Impact on Training:
-• Drastically simplifies tree depth requirements.
-• Enables shallow XGBoost trees (depth 4) to capture coal rank variations.
-• Consistently reduces CV error across all folds.</a:t>
+Why this helped:
+• Keeps models simpler and faster
+• Lets shallow trees reach lower errors
+• Directly reflects real coal combustion chemistry</a:t>
             </a:r>
           </a:p>
         </p:txBody>
@@ -5444,7 +5448,7 @@
                   <a:srgbClr val="38BDF8"/>
                 </a:solidFill>
               </a:rPr>
-              <a:t>MODEL EVALUATION</a:t>
+              <a:t>MODEL BENCHMARKING</a:t>
             </a:r>
           </a:p>
         </p:txBody>
@@ -5477,7 +5481,7 @@
                   <a:srgbClr val="FFFFFF"/>
                 </a:solidFill>
               </a:rPr>
-              <a:t>Quantitative Benchmarking: Proving Ensemble Superiority</a:t>
+              <a:t>Testing Different Models (5-Fold Cross Validation)</a:t>
             </a:r>
           </a:p>
         </p:txBody>
@@ -5518,7 +5522,7 @@
                             <a:srgbClr val="FFFFFF"/>
                           </a:solidFill>
                         </a:rPr>
-                        <a:t>Model Architecture</a:t>
+                        <a:t>Model</a:t>
                       </a:r>
                     </a:p>
                   </a:txBody>
@@ -5539,7 +5543,7 @@
                             <a:srgbClr val="FFFFFF"/>
                           </a:solidFill>
                         </a:rPr>
-                        <a:t>5-Fold RMSE</a:t>
+                        <a:t>Average Error (RMSE)</a:t>
                       </a:r>
                     </a:p>
                   </a:txBody>
@@ -5560,7 +5564,7 @@
                             <a:srgbClr val="FFFFFF"/>
                           </a:solidFill>
                         </a:rPr>
-                        <a:t>5-Fold MAE</a:t>
+                        <a:t>Absolute Error (MAE)</a:t>
                       </a:r>
                     </a:p>
                   </a:txBody>
@@ -5581,7 +5585,7 @@
                             <a:srgbClr val="FFFFFF"/>
                           </a:solidFill>
                         </a:rPr>
-                        <a:t>R² Score</a:t>
+                        <a:t>Accuracy (R²)</a:t>
                       </a:r>
                     </a:p>
                   </a:txBody>
@@ -5625,7 +5629,7 @@
                             <a:srgbClr val="FFFFFF"/>
                           </a:solidFill>
                         </a:rPr>
-                        <a:t>612.45</a:t>
+                        <a:t>612.45 Kcal/kg</a:t>
                       </a:r>
                     </a:p>
                   </a:txBody>
@@ -5667,7 +5671,7 @@
                             <a:srgbClr val="FFFFFF"/>
                           </a:solidFill>
                         </a:rPr>
-                        <a:t>0.3541</a:t>
+                        <a:t>0.35</a:t>
                       </a:r>
                     </a:p>
                   </a:txBody>
@@ -5690,7 +5694,7 @@
                             <a:srgbClr val="FFFFFF"/>
                           </a:solidFill>
                         </a:rPr>
-                        <a:t>Decision Tree Regressor</a:t>
+                        <a:t>Single Decision Tree</a:t>
                       </a:r>
                     </a:p>
                   </a:txBody>
@@ -5711,7 +5715,7 @@
                             <a:srgbClr val="FFFFFF"/>
                           </a:solidFill>
                         </a:rPr>
-                        <a:t>217.30</a:t>
+                        <a:t>217.30 Kcal/kg</a:t>
                       </a:r>
                     </a:p>
                   </a:txBody>
@@ -5753,7 +5757,7 @@
                             <a:srgbClr val="FFFFFF"/>
                           </a:solidFill>
                         </a:rPr>
-                        <a:t>0.9168</a:t>
+                        <a:t>0.92</a:t>
                       </a:r>
                     </a:p>
                   </a:txBody>
@@ -5776,7 +5780,7 @@
                             <a:srgbClr val="FFFFFF"/>
                           </a:solidFill>
                         </a:rPr>
-                        <a:t>Random Forest Regressor</a:t>
+                        <a:t>Random Forest</a:t>
                       </a:r>
                     </a:p>
                   </a:txBody>
@@ -5797,7 +5801,7 @@
                             <a:srgbClr val="FFFFFF"/>
                           </a:solidFill>
                         </a:rPr>
-                        <a:t>154.84</a:t>
+                        <a:t>154.84 Kcal/kg</a:t>
                       </a:r>
                     </a:p>
                   </a:txBody>
@@ -5839,7 +5843,7 @@
                             <a:srgbClr val="FFFFFF"/>
                           </a:solidFill>
                         </a:rPr>
-                        <a:t>0.9571</a:t>
+                        <a:t>0.95</a:t>
                       </a:r>
                     </a:p>
                   </a:txBody>
@@ -5862,7 +5866,7 @@
                             <a:srgbClr val="FFFFFF"/>
                           </a:solidFill>
                         </a:rPr>
-                        <a:t>XGBoost Regressor</a:t>
+                        <a:t>XGBoost</a:t>
                       </a:r>
                     </a:p>
                   </a:txBody>
@@ -5883,7 +5887,7 @@
                             <a:srgbClr val="FFFFFF"/>
                           </a:solidFill>
                         </a:rPr>
-                        <a:t>152.14</a:t>
+                        <a:t>152.14 Kcal/kg</a:t>
                       </a:r>
                     </a:p>
                   </a:txBody>
@@ -5925,7 +5929,7 @@
                             <a:srgbClr val="FFFFFF"/>
                           </a:solidFill>
                         </a:rPr>
-                        <a:t>0.9585</a:t>
+                        <a:t>0.96</a:t>
                       </a:r>
                     </a:p>
                   </a:txBody>
@@ -5948,7 +5952,7 @@
                             <a:srgbClr val="FFFFFF"/>
                           </a:solidFill>
                         </a:rPr>
-                        <a:t>Stacked Ensemble (Ours)</a:t>
+                        <a:t>Combined Ensemble (Ours)</a:t>
                       </a:r>
                     </a:p>
                   </a:txBody>
@@ -5969,7 +5973,7 @@
                             <a:srgbClr val="FFFFFF"/>
                           </a:solidFill>
                         </a:rPr>
-                        <a:t>150.28</a:t>
+                        <a:t>150.28 Kcal/kg</a:t>
                       </a:r>
                     </a:p>
                   </a:txBody>
@@ -6011,7 +6015,7 @@
                             <a:srgbClr val="FFFFFF"/>
                           </a:solidFill>
                         </a:rPr>
-                        <a:t>0.9595</a:t>
+                        <a:t>0.96</a:t>
                       </a:r>
                     </a:p>
                   </a:txBody>
@@ -6139,7 +6143,7 @@
                   <a:srgbClr val="38BDF8"/>
                 </a:solidFill>
               </a:rPr>
-              <a:t>SYSTEM ARCHITECTURE</a:t>
+              <a:t>ARCHITECTURE</a:t>
             </a:r>
           </a:p>
         </p:txBody>
@@ -6172,7 +6176,7 @@
                   <a:srgbClr val="FFFFFF"/>
                 </a:solidFill>
               </a:rPr>
-              <a:t>End-to-End System &amp; Stacking Architecture</a:t>
+              <a:t>System Architecture: How the Models Work Together</a:t>
             </a:r>
           </a:p>
         </p:txBody>
@@ -6193,8 +6197,8 @@
         </p:blipFill>
         <p:spPr>
           <a:xfrm>
-            <a:off x="731520" y="1463040"/>
-            <a:ext cx="10725912" cy="6096022"/>
+            <a:off x="731520" y="1554480"/>
+            <a:ext cx="10725912" cy="5091678"/>
           </a:xfrm>
           <a:prstGeom prst="rect">
             <a:avLst/>
@@ -6290,7 +6294,7 @@
                   <a:srgbClr val="38BDF8"/>
                 </a:solidFill>
               </a:rPr>
-              <a:t>HYPERPARAMETER TUNING</a:t>
+              <a:t>MODEL TUNING</a:t>
             </a:r>
           </a:p>
         </p:txBody>
@@ -6323,7 +6327,7 @@
                   <a:srgbClr val="FFFFFF"/>
                 </a:solidFill>
               </a:rPr>
-              <a:t>Bayesian Hyperparameter Optimization via Optuna</a:t>
+              <a:t>Tuning the Models (Finding the Best Parameters)</a:t>
             </a:r>
           </a:p>
         </p:txBody>
@@ -6356,7 +6360,7 @@
                   <a:srgbClr val="38BDF8"/>
                 </a:solidFill>
               </a:rPr>
-              <a:t>Why Bayesian Optimization over Grid Search?</a:t>
+              <a:t>How We Tuned the Parameters:</a:t>
             </a:r>
           </a:p>
           <a:p>
@@ -6371,7 +6375,7 @@
                   <a:srgbClr val="FFFFFF"/>
                 </a:solidFill>
               </a:rPr>
-              <a:t>• Grid Search is computationally expensive and samples uninformative parameter regions.</a:t>
+              <a:t>• Instead of guessing numbers, we used an automated tuning tool called Optuna.</a:t>
             </a:r>
           </a:p>
           <a:p>
@@ -6386,7 +6390,7 @@
                   <a:srgbClr val="FFFFFF"/>
                 </a:solidFill>
               </a:rPr>
-              <a:t>• Optuna utilizes Tree-structured Parzen Estimators (TPE) to model the probability distribution of 5-fold CV RMSE.</a:t>
+              <a:t>• Optuna tests different combinations of tree depths, number of trees, and learning rates across 5 cross-validation folds.</a:t>
             </a:r>
           </a:p>
           <a:p>
@@ -6401,7 +6405,7 @@
                   <a:srgbClr val="FFFFFF"/>
                 </a:solidFill>
               </a:rPr>
-              <a:t>• It concentrates evaluation trials where parameter combinations historically yield lower error.</a:t>
+              <a:t>• It focuses on parameter values that consistently reduce prediction error.</a:t>
             </a:r>
           </a:p>
           <a:p>
@@ -6416,7 +6420,7 @@
                   <a:srgbClr val="FFFFFF"/>
                 </a:solidFill>
               </a:rPr>
-              <a:t>• Optimal parameters saved to models/best_params.json for transparent, reproducible deployment.</a:t>
+              <a:t>• For XGBoost, it selected a tree depth of 4 (shallow trees). This prevents the model from memorizing random lab noise and helps it generalize to new samples.</a:t>
             </a:r>
           </a:p>
         </p:txBody>
@@ -6494,7 +6498,7 @@
                   <a:srgbClr val="34D399"/>
                 </a:solidFill>
               </a:rPr>
-              <a:t>Tuned Hyperparameter Snapshot:</a:t>
+              <a:t>Selected Settings:</a:t>
             </a:r>
           </a:p>
           <a:p>
@@ -6509,17 +6513,18 @@
                   <a:srgbClr val="FFFFFF"/>
                 </a:solidFill>
               </a:rPr>
-              <a:t>XGBoost Regressor:
-• n_estimators = 300  |  max_depth = 4
-• learning_rate = 0.0256  |  subsample = 0.7
-• colsample_bytree = 0.8  |  min_child_weight = 2
-Random Forest Regressor:
-• n_estimators = 200  |  max_depth = 15
-• min_samples_leaf = 4  |  max_features = 0.7
-Support Vector Regressor (SVR):
-• C = 1.292  |  epsilon = 0.0857  |  gamma = 'auto'
-Stacking Meta-Learner (Ridge):
-• alpha = 0.0105  (Optimal L2 shrinkage)</a:t>
+              <a:t>XGBoost:
+• Number of trees: 300
+• Maximum depth: 4 (shallow trees prevent overfitting)
+• Learning rate: 0.025
+Random Forest:
+• Number of trees: 200
+• Maximum depth: 15
+• Min samples per leaf: 4
+Support Vector Machine:
+• Uses normalized data so large GCV numbers don't break it
+Final Blending Model:
+• Ridge Regression assigning weights to each model</a:t>
             </a:r>
           </a:p>
         </p:txBody>
@@ -6613,7 +6618,7 @@
                   <a:srgbClr val="38BDF8"/>
                 </a:solidFill>
               </a:rPr>
-              <a:t>RANK SPECIALIZATION</a:t>
+              <a:t>COAL RANK</a:t>
             </a:r>
           </a:p>
         </p:txBody>
@@ -6646,7 +6651,7 @@
                   <a:srgbClr val="FFFFFF"/>
                 </a:solidFill>
               </a:rPr>
-              <a:t>Coal Rank Specialization: ASTM D388 Bituminous Model</a:t>
+              <a:t>Specialized Model for Bituminous Coal</a:t>
             </a:r>
           </a:p>
         </p:txBody>
@@ -6674,78 +6679,74 @@
           <a:lstStyle/>
           <a:p>
             <a:r>
-              <a:rPr sz="1700" b="1">
+              <a:rPr sz="1800" b="1">
                 <a:solidFill>
                   <a:srgbClr val="34D399"/>
                 </a:solidFill>
               </a:rPr>
-              <a:t>The Scientific Rationale for Rank Segregation:</a:t>
+              <a:t>Why Train a Separate Model?</a:t>
             </a:r>
           </a:p>
           <a:p>
             <a:pPr>
               <a:spcBef>
-                <a:spcPts val="800"/>
+                <a:spcPts val="1000"/>
               </a:spcBef>
             </a:pPr>
             <a:r>
-              <a:rPr sz="1250" b="0">
+              <a:rPr sz="1300" b="0">
                 <a:solidFill>
                   <a:srgbClr val="FFFFFF"/>
                 </a:solidFill>
               </a:rPr>
-              <a:t>• Coal is chemically non-homogeneous across geological ranks. Lignite, Bituminous, and Anthracite exhibit vastly different volatile release kinetics.</a:t>
+              <a:t>• Different types of coal burn differently. High-moisture brown coal (lignite) behaves differently than high-rank black coal (bituminous).</a:t>
             </a:r>
           </a:p>
           <a:p>
             <a:pPr>
               <a:spcBef>
-                <a:spcPts val="800"/>
+                <a:spcPts val="1000"/>
               </a:spcBef>
             </a:pPr>
             <a:r>
-              <a:rPr sz="1250" b="0">
+              <a:rPr sz="1300" b="0">
                 <a:solidFill>
                   <a:srgbClr val="FFFFFF"/>
                 </a:solidFill>
               </a:rPr>
-              <a:t>• Under ASTM D388, Bituminous Coal is strictly classified by:
-• Moist Mineral-Matter-Free Btu &gt;= 10,500 Btu/lb
-• Dry MMF Volatile Matter &gt;= 14.0%
-• Dry MMF Fixed Carbon &lt; 86.0%</a:t>
+              <a:t>• We filtered 4,494 samples of Bituminous coal using official ASTM D388 laboratory standards.</a:t>
             </a:r>
           </a:p>
           <a:p>
             <a:pPr>
               <a:spcBef>
-                <a:spcPts val="800"/>
+                <a:spcPts val="1000"/>
               </a:spcBef>
             </a:pPr>
             <a:r>
-              <a:rPr sz="1250" b="0">
+              <a:rPr sz="1300" b="0">
                 <a:solidFill>
                   <a:srgbClr val="FFFFFF"/>
                 </a:solidFill>
               </a:rPr>
-              <a:t>• We isolated 4,494 verified bituminous samples and trained a dedicated model pipeline (src/train_bituminous.py).</a:t>
+              <a:t>• Training a specialized model on just this group produced significantly higher accuracy:</a:t>
             </a:r>
           </a:p>
           <a:p>
             <a:pPr>
               <a:spcBef>
-                <a:spcPts val="800"/>
+                <a:spcPts val="1000"/>
               </a:spcBef>
             </a:pPr>
             <a:r>
-              <a:rPr sz="1250" b="0">
+              <a:rPr sz="1300" b="0">
                 <a:solidFill>
                   <a:srgbClr val="FFFFFF"/>
                 </a:solidFill>
               </a:rPr>
-              <a:t>• Performance Impact:
-• RMSE dropped to 134.18 Kcal/kg (vs 150.28)
-• MAE dropped to 96.29 Kcal/kg (sub-100 error!)
-• CV Score reached 1.91%</a:t>
+              <a:t>• • Error dropped from 150 to 134 Kcal/kg
+• Average absolute error dropped below 100 Kcal/kg (96 Kcal/kg)
+• Error rate reached 1.91%</a:t>
             </a:r>
           </a:p>
         </p:txBody>
@@ -6863,7 +6864,7 @@
                   <a:srgbClr val="38BDF8"/>
                 </a:solidFill>
               </a:rPr>
-              <a:t>MODEL INTERPRETABILITY</a:t>
+              <a:t>EXPLAINABILITY</a:t>
             </a:r>
           </a:p>
         </p:txBody>
@@ -6896,7 +6897,7 @@
                   <a:srgbClr val="FFFFFF"/>
                 </a:solidFill>
               </a:rPr>
-              <a:t>Explainable AI: SHAP Chemical Interpretability</a:t>
+              <a:t>Explaining Predictions (No Black Box)</a:t>
             </a:r>
           </a:p>
         </p:txBody>
@@ -6924,12 +6925,12 @@
           <a:lstStyle/>
           <a:p>
             <a:r>
-              <a:rPr sz="1700" b="1">
+              <a:rPr sz="1800" b="1">
                 <a:solidFill>
                   <a:srgbClr val="38BDF8"/>
                 </a:solidFill>
               </a:rPr>
-              <a:t>Overcoming the 'Black Box' Critique:</a:t>
+              <a:t>Why Does the Model Guess What It Does?</a:t>
             </a:r>
           </a:p>
           <a:p>
@@ -6939,12 +6940,12 @@
               </a:spcBef>
             </a:pPr>
             <a:r>
-              <a:rPr sz="1200" b="0">
+              <a:rPr sz="1250" b="0">
                 <a:solidFill>
                   <a:srgbClr val="FFFFFF"/>
                 </a:solidFill>
               </a:rPr>
-              <a:t>• Engineers rightfully distrust black-box ML models when plant safety and boiler efficiency are at stake.</a:t>
+              <a:t>• In industry, engineers need to understand why a model makes a prediction rather than just trusting a black-box number.</a:t>
             </a:r>
           </a:p>
           <a:p>
@@ -6954,12 +6955,12 @@
               </a:spcBef>
             </a:pPr>
             <a:r>
-              <a:rPr sz="1200" b="0">
+              <a:rPr sz="1250" b="0">
                 <a:solidFill>
                   <a:srgbClr val="FFFFFF"/>
                 </a:solidFill>
               </a:rPr>
-              <a:t>• We integrated SHAP (SHapley Additive exPlanations) using TreeExplainer to explain individual local predictions.</a:t>
+              <a:t>• We integrated SHAP, a method that breaks down how much each chemical feature contributed to the final score.</a:t>
             </a:r>
           </a:p>
           <a:p>
@@ -6969,15 +6970,15 @@
               </a:spcBef>
             </a:pPr>
             <a:r>
-              <a:rPr sz="1200" b="0">
+              <a:rPr sz="1250" b="0">
                 <a:solidFill>
                   <a:srgbClr val="FFFFFF"/>
                 </a:solidFill>
               </a:rPr>
-              <a:t>• Thermodynamic Sanity Check:
-• Moisture: Strong negative SHAP driver (water absorbs heat via vaporization at 540 cal/g).
-• Ash: Strong negative SHAP driver (inert mineral matter acts as a thermal heat sink).
-• Fixed Carbon &amp; Fuel Ratio: Dominant positive drivers (primary energy-producing organic matrix).</a:t>
+              <a:t>• The model's reasoning matches real chemistry:
+• Moisture pulls energy down (it takes heat to boil water)
+• Ash pulls energy down (rock/dirt does not burn)
+• Carbon and Fuel Ratio push energy up (actual fuel)</a:t>
             </a:r>
           </a:p>
           <a:p>
@@ -6987,12 +6988,12 @@
               </a:spcBef>
             </a:pPr>
             <a:r>
-              <a:rPr sz="1200" b="0">
+              <a:rPr sz="1250" b="0">
                 <a:solidFill>
                   <a:srgbClr val="FFFFFF"/>
                 </a:solidFill>
               </a:rPr>
-              <a:t>• The model's internal feature attribution perfectly validates established combustion thermodynamics.</a:t>
+              <a:t>• The graph on the right shows a sample prediction and how each feature pushed the value up (red) or down (blue).</a:t>
             </a:r>
           </a:p>
         </p:txBody>

</xml_diff>

<commit_message>
Remove slide 2 and 10, remove future scope, fix text box overflow
</commit_message>
<xml_diff>
--- a/Coal_GCV_Prediction_Presentation.pptx
+++ b/Coal_GCV_Prediction_Presentation.pptx
@@ -14,8 +14,6 @@
     <p:sldId id="262" r:id="rId13"/>
     <p:sldId id="263" r:id="rId14"/>
     <p:sldId id="264" r:id="rId15"/>
-    <p:sldId id="265" r:id="rId16"/>
-    <p:sldId id="266" r:id="rId17"/>
   </p:sldIdLst>
   <p:sldSz cx="12191695" cy="6858000" type="screen4x3"/>
   <p:notesSz cx="6858000" cy="9144000"/>
@@ -3260,7 +3258,7 @@
                   <a:srgbClr val="FFFFFF"/>
                 </a:solidFill>
               </a:rPr>
-              <a:t>• Tested on real geological coal data with sub-2% error
+              <a:t>• Tested on real geological coal data with sub-2% error rate
 </a:t>
             </a:r>
             <a:r>
@@ -3269,839 +3267,8 @@
                   <a:srgbClr val="FFFFFF"/>
                 </a:solidFill>
               </a:rPr>
-              <a:t>• Web app with interactive charts showing why the model makes each prediction
+              <a:t>• Feature explanation charts showing how each property impacts heating value
 </a:t>
-            </a:r>
-          </a:p>
-        </p:txBody>
-      </p:sp>
-    </p:spTree>
-  </p:cSld>
-  <p:clrMapOvr>
-    <a:masterClrMapping/>
-  </p:clrMapOvr>
-</p:sld>
-</file>
-
-<file path=ppt/slides/slide10.xml><?xml version="1.0" encoding="utf-8"?>
-<p:sld xmlns:a="http://schemas.openxmlformats.org/drawingml/2006/main" xmlns:p="http://schemas.openxmlformats.org/presentationml/2006/main" xmlns:r="http://schemas.openxmlformats.org/officeDocument/2006/relationships">
-  <p:cSld>
-    <p:spTree>
-      <p:nvGrpSpPr>
-        <p:cNvPr id="1" name=""/>
-        <p:cNvGrpSpPr/>
-        <p:nvPr/>
-      </p:nvGrpSpPr>
-      <p:grpSpPr/>
-      <p:sp>
-        <p:nvSpPr>
-          <p:cNvPr id="2" name="Rectangle 1"/>
-          <p:cNvSpPr/>
-          <p:nvPr/>
-        </p:nvSpPr>
-        <p:spPr>
-          <a:xfrm>
-            <a:off x="0" y="0"/>
-            <a:ext cx="12191695" cy="6858000"/>
-          </a:xfrm>
-          <a:prstGeom prst="rect">
-            <a:avLst/>
-          </a:prstGeom>
-          <a:solidFill>
-            <a:srgbClr val="0F172A"/>
-          </a:solidFill>
-          <a:ln>
-            <a:noFill/>
-          </a:ln>
-        </p:spPr>
-        <p:style>
-          <a:lnRef idx="1">
-            <a:schemeClr val="accent1"/>
-          </a:lnRef>
-          <a:fillRef idx="3">
-            <a:schemeClr val="accent1"/>
-          </a:fillRef>
-          <a:effectRef idx="2">
-            <a:schemeClr val="accent1"/>
-          </a:effectRef>
-          <a:fontRef idx="minor">
-            <a:schemeClr val="lt1"/>
-          </a:fontRef>
-        </p:style>
-        <p:txBody>
-          <a:bodyPr rtlCol="0" anchor="ctr"/>
-          <a:lstStyle/>
-          <a:p>
-            <a:pPr algn="ctr"/>
-          </a:p>
-        </p:txBody>
-      </p:sp>
-      <p:sp>
-        <p:nvSpPr>
-          <p:cNvPr id="3" name="TextBox 2"/>
-          <p:cNvSpPr txBox="1"/>
-          <p:nvPr/>
-        </p:nvSpPr>
-        <p:spPr>
-          <a:xfrm>
-            <a:off x="731520" y="365760"/>
-            <a:ext cx="10698480" cy="365760"/>
-          </a:xfrm>
-          <a:prstGeom prst="rect">
-            <a:avLst/>
-          </a:prstGeom>
-          <a:noFill/>
-        </p:spPr>
-        <p:txBody>
-          <a:bodyPr wrap="none">
-            <a:spAutoFit/>
-          </a:bodyPr>
-          <a:lstStyle/>
-          <a:p>
-            <a:r>
-              <a:rPr sz="1100" b="1">
-                <a:solidFill>
-                  <a:srgbClr val="38BDF8"/>
-                </a:solidFill>
-              </a:rPr>
-              <a:t>WEB APPLICATION</a:t>
-            </a:r>
-          </a:p>
-        </p:txBody>
-      </p:sp>
-      <p:sp>
-        <p:nvSpPr>
-          <p:cNvPr id="4" name="TextBox 3"/>
-          <p:cNvSpPr txBox="1"/>
-          <p:nvPr/>
-        </p:nvSpPr>
-        <p:spPr>
-          <a:xfrm>
-            <a:off x="731520" y="640080"/>
-            <a:ext cx="10698480" cy="731520"/>
-          </a:xfrm>
-          <a:prstGeom prst="rect">
-            <a:avLst/>
-          </a:prstGeom>
-          <a:noFill/>
-        </p:spPr>
-        <p:txBody>
-          <a:bodyPr wrap="none">
-            <a:spAutoFit/>
-          </a:bodyPr>
-          <a:lstStyle/>
-          <a:p>
-            <a:r>
-              <a:rPr sz="2400" b="1">
-                <a:solidFill>
-                  <a:srgbClr val="FFFFFF"/>
-                </a:solidFill>
-              </a:rPr>
-              <a:t>Interactive Web App &amp; Safety Checks</a:t>
-            </a:r>
-          </a:p>
-        </p:txBody>
-      </p:sp>
-      <p:sp>
-        <p:nvSpPr>
-          <p:cNvPr id="5" name="Rounded Rectangle 4"/>
-          <p:cNvSpPr/>
-          <p:nvPr/>
-        </p:nvSpPr>
-        <p:spPr>
-          <a:xfrm>
-            <a:off x="731520" y="1645920"/>
-            <a:ext cx="5120640" cy="2011680"/>
-          </a:xfrm>
-          <a:prstGeom prst="roundRect">
-            <a:avLst/>
-          </a:prstGeom>
-          <a:solidFill>
-            <a:srgbClr val="1E293B"/>
-          </a:solidFill>
-          <a:ln w="19050">
-            <a:solidFill>
-              <a:srgbClr val="38BDF8"/>
-            </a:solidFill>
-          </a:ln>
-        </p:spPr>
-        <p:style>
-          <a:lnRef idx="1">
-            <a:schemeClr val="accent1"/>
-          </a:lnRef>
-          <a:fillRef idx="3">
-            <a:schemeClr val="accent1"/>
-          </a:fillRef>
-          <a:effectRef idx="2">
-            <a:schemeClr val="accent1"/>
-          </a:effectRef>
-          <a:fontRef idx="minor">
-            <a:schemeClr val="lt1"/>
-          </a:fontRef>
-        </p:style>
-        <p:txBody>
-          <a:bodyPr rtlCol="0" anchor="ctr"/>
-          <a:lstStyle/>
-          <a:p>
-            <a:pPr algn="ctr"/>
-          </a:p>
-        </p:txBody>
-      </p:sp>
-      <p:sp>
-        <p:nvSpPr>
-          <p:cNvPr id="6" name="TextBox 5"/>
-          <p:cNvSpPr txBox="1"/>
-          <p:nvPr/>
-        </p:nvSpPr>
-        <p:spPr>
-          <a:xfrm>
-            <a:off x="960120" y="1828800"/>
-            <a:ext cx="4663440" cy="1645920"/>
-          </a:xfrm>
-          <a:prstGeom prst="rect">
-            <a:avLst/>
-          </a:prstGeom>
-          <a:noFill/>
-        </p:spPr>
-        <p:txBody>
-          <a:bodyPr wrap="square">
-            <a:spAutoFit/>
-          </a:bodyPr>
-          <a:lstStyle/>
-          <a:p>
-            <a:r>
-              <a:rPr sz="1600" b="1">
-                <a:solidFill>
-                  <a:srgbClr val="38BDF8"/>
-                </a:solidFill>
-              </a:rPr>
-              <a:t>Two Dedicated Tabs</a:t>
-            </a:r>
-          </a:p>
-          <a:p>
-            <a:pPr>
-              <a:spcBef>
-                <a:spcPts val="800"/>
-              </a:spcBef>
-            </a:pPr>
-            <a:r>
-              <a:rPr sz="1200" b="0">
-                <a:solidFill>
-                  <a:srgbClr val="FFFFFF"/>
-                </a:solidFill>
-              </a:rPr>
-              <a:t>• Tab 1: Universal Model for all coal types
-• Tab 2: Specialized Bituminous Model
-Users can test any coal sample or switch to the specialized model for higher precision.</a:t>
-            </a:r>
-          </a:p>
-        </p:txBody>
-      </p:sp>
-      <p:sp>
-        <p:nvSpPr>
-          <p:cNvPr id="7" name="Rounded Rectangle 6"/>
-          <p:cNvSpPr/>
-          <p:nvPr/>
-        </p:nvSpPr>
-        <p:spPr>
-          <a:xfrm>
-            <a:off x="6126480" y="1645920"/>
-            <a:ext cx="5120640" cy="2011680"/>
-          </a:xfrm>
-          <a:prstGeom prst="roundRect">
-            <a:avLst/>
-          </a:prstGeom>
-          <a:solidFill>
-            <a:srgbClr val="1E293B"/>
-          </a:solidFill>
-          <a:ln w="19050">
-            <a:solidFill>
-              <a:srgbClr val="FB923C"/>
-            </a:solidFill>
-          </a:ln>
-        </p:spPr>
-        <p:style>
-          <a:lnRef idx="1">
-            <a:schemeClr val="accent1"/>
-          </a:lnRef>
-          <a:fillRef idx="3">
-            <a:schemeClr val="accent1"/>
-          </a:fillRef>
-          <a:effectRef idx="2">
-            <a:schemeClr val="accent1"/>
-          </a:effectRef>
-          <a:fontRef idx="minor">
-            <a:schemeClr val="lt1"/>
-          </a:fontRef>
-        </p:style>
-        <p:txBody>
-          <a:bodyPr rtlCol="0" anchor="ctr"/>
-          <a:lstStyle/>
-          <a:p>
-            <a:pPr algn="ctr"/>
-          </a:p>
-        </p:txBody>
-      </p:sp>
-      <p:sp>
-        <p:nvSpPr>
-          <p:cNvPr id="8" name="TextBox 7"/>
-          <p:cNvSpPr txBox="1"/>
-          <p:nvPr/>
-        </p:nvSpPr>
-        <p:spPr>
-          <a:xfrm>
-            <a:off x="6355080" y="1828800"/>
-            <a:ext cx="4663440" cy="1645920"/>
-          </a:xfrm>
-          <a:prstGeom prst="rect">
-            <a:avLst/>
-          </a:prstGeom>
-          <a:noFill/>
-        </p:spPr>
-        <p:txBody>
-          <a:bodyPr wrap="square">
-            <a:spAutoFit/>
-          </a:bodyPr>
-          <a:lstStyle/>
-          <a:p>
-            <a:r>
-              <a:rPr sz="1600" b="1">
-                <a:solidFill>
-                  <a:srgbClr val="FB923C"/>
-                </a:solidFill>
-              </a:rPr>
-              <a:t>Safety &amp; Validation Checks</a:t>
-            </a:r>
-          </a:p>
-          <a:p>
-            <a:pPr>
-              <a:spcBef>
-                <a:spcPts val="800"/>
-              </a:spcBef>
-            </a:pPr>
-            <a:r>
-              <a:rPr sz="1200" b="0">
-                <a:solidFill>
-                  <a:srgbClr val="FFFFFF"/>
-                </a:solidFill>
-              </a:rPr>
-              <a:t>• Mass Balance Check: If Moisture + VM + Ash exceeds 100%, the app warns the user.
-• Ash Limit Check: Rejects impossible samples where Ash is greater than 55%.</a:t>
-            </a:r>
-          </a:p>
-        </p:txBody>
-      </p:sp>
-      <p:sp>
-        <p:nvSpPr>
-          <p:cNvPr id="9" name="Rounded Rectangle 8"/>
-          <p:cNvSpPr/>
-          <p:nvPr/>
-        </p:nvSpPr>
-        <p:spPr>
-          <a:xfrm>
-            <a:off x="731520" y="3931920"/>
-            <a:ext cx="5120640" cy="2011680"/>
-          </a:xfrm>
-          <a:prstGeom prst="roundRect">
-            <a:avLst/>
-          </a:prstGeom>
-          <a:solidFill>
-            <a:srgbClr val="1E293B"/>
-          </a:solidFill>
-          <a:ln w="19050">
-            <a:solidFill>
-              <a:srgbClr val="34D399"/>
-            </a:solidFill>
-          </a:ln>
-        </p:spPr>
-        <p:style>
-          <a:lnRef idx="1">
-            <a:schemeClr val="accent1"/>
-          </a:lnRef>
-          <a:fillRef idx="3">
-            <a:schemeClr val="accent1"/>
-          </a:fillRef>
-          <a:effectRef idx="2">
-            <a:schemeClr val="accent1"/>
-          </a:effectRef>
-          <a:fontRef idx="minor">
-            <a:schemeClr val="lt1"/>
-          </a:fontRef>
-        </p:style>
-        <p:txBody>
-          <a:bodyPr rtlCol="0" anchor="ctr"/>
-          <a:lstStyle/>
-          <a:p>
-            <a:pPr algn="ctr"/>
-          </a:p>
-        </p:txBody>
-      </p:sp>
-      <p:sp>
-        <p:nvSpPr>
-          <p:cNvPr id="10" name="TextBox 9"/>
-          <p:cNvSpPr txBox="1"/>
-          <p:nvPr/>
-        </p:nvSpPr>
-        <p:spPr>
-          <a:xfrm>
-            <a:off x="960120" y="4114800"/>
-            <a:ext cx="4663440" cy="1645920"/>
-          </a:xfrm>
-          <a:prstGeom prst="rect">
-            <a:avLst/>
-          </a:prstGeom>
-          <a:noFill/>
-        </p:spPr>
-        <p:txBody>
-          <a:bodyPr wrap="square">
-            <a:spAutoFit/>
-          </a:bodyPr>
-          <a:lstStyle/>
-          <a:p>
-            <a:r>
-              <a:rPr sz="1600" b="1">
-                <a:solidFill>
-                  <a:srgbClr val="34D399"/>
-                </a:solidFill>
-              </a:rPr>
-              <a:t>Instant Visual Explanations</a:t>
-            </a:r>
-          </a:p>
-          <a:p>
-            <a:pPr>
-              <a:spcBef>
-                <a:spcPts val="800"/>
-              </a:spcBef>
-            </a:pPr>
-            <a:r>
-              <a:rPr sz="1200" b="0">
-                <a:solidFill>
-                  <a:srgbClr val="FFFFFF"/>
-                </a:solidFill>
-              </a:rPr>
-              <a:t>Whenever a slider is moved, the app recalculates the prediction instantly and draws a SHAP graph showing which feature had the biggest impact.</a:t>
-            </a:r>
-          </a:p>
-        </p:txBody>
-      </p:sp>
-      <p:sp>
-        <p:nvSpPr>
-          <p:cNvPr id="11" name="Rounded Rectangle 10"/>
-          <p:cNvSpPr/>
-          <p:nvPr/>
-        </p:nvSpPr>
-        <p:spPr>
-          <a:xfrm>
-            <a:off x="6126480" y="3931920"/>
-            <a:ext cx="5120640" cy="2011680"/>
-          </a:xfrm>
-          <a:prstGeom prst="roundRect">
-            <a:avLst/>
-          </a:prstGeom>
-          <a:solidFill>
-            <a:srgbClr val="1E293B"/>
-          </a:solidFill>
-          <a:ln w="19050">
-            <a:solidFill>
-              <a:srgbClr val="38BDF8"/>
-            </a:solidFill>
-          </a:ln>
-        </p:spPr>
-        <p:style>
-          <a:lnRef idx="1">
-            <a:schemeClr val="accent1"/>
-          </a:lnRef>
-          <a:fillRef idx="3">
-            <a:schemeClr val="accent1"/>
-          </a:fillRef>
-          <a:effectRef idx="2">
-            <a:schemeClr val="accent1"/>
-          </a:effectRef>
-          <a:fontRef idx="minor">
-            <a:schemeClr val="lt1"/>
-          </a:fontRef>
-        </p:style>
-        <p:txBody>
-          <a:bodyPr rtlCol="0" anchor="ctr"/>
-          <a:lstStyle/>
-          <a:p>
-            <a:pPr algn="ctr"/>
-          </a:p>
-        </p:txBody>
-      </p:sp>
-      <p:sp>
-        <p:nvSpPr>
-          <p:cNvPr id="12" name="TextBox 11"/>
-          <p:cNvSpPr txBox="1"/>
-          <p:nvPr/>
-        </p:nvSpPr>
-        <p:spPr>
-          <a:xfrm>
-            <a:off x="6355080" y="4114800"/>
-            <a:ext cx="4663440" cy="1645920"/>
-          </a:xfrm>
-          <a:prstGeom prst="rect">
-            <a:avLst/>
-          </a:prstGeom>
-          <a:noFill/>
-        </p:spPr>
-        <p:txBody>
-          <a:bodyPr wrap="square">
-            <a:spAutoFit/>
-          </a:bodyPr>
-          <a:lstStyle/>
-          <a:p>
-            <a:r>
-              <a:rPr sz="1600" b="1">
-                <a:solidFill>
-                  <a:srgbClr val="38BDF8"/>
-                </a:solidFill>
-              </a:rPr>
-              <a:t>Live Web Deployment</a:t>
-            </a:r>
-          </a:p>
-          <a:p>
-            <a:pPr>
-              <a:spcBef>
-                <a:spcPts val="800"/>
-              </a:spcBef>
-            </a:pPr>
-            <a:r>
-              <a:rPr sz="1200" b="0">
-                <a:solidFill>
-                  <a:srgbClr val="FFFFFF"/>
-                </a:solidFill>
-              </a:rPr>
-              <a:t>The application is deployed on Streamlit Cloud and connected to our GitHub repository for easy sharing and testing from any browser.</a:t>
-            </a:r>
-          </a:p>
-        </p:txBody>
-      </p:sp>
-    </p:spTree>
-  </p:cSld>
-  <p:clrMapOvr>
-    <a:masterClrMapping/>
-  </p:clrMapOvr>
-</p:sld>
-</file>
-
-<file path=ppt/slides/slide11.xml><?xml version="1.0" encoding="utf-8"?>
-<p:sld xmlns:a="http://schemas.openxmlformats.org/drawingml/2006/main" xmlns:p="http://schemas.openxmlformats.org/presentationml/2006/main" xmlns:r="http://schemas.openxmlformats.org/officeDocument/2006/relationships">
-  <p:cSld>
-    <p:spTree>
-      <p:nvGrpSpPr>
-        <p:cNvPr id="1" name=""/>
-        <p:cNvGrpSpPr/>
-        <p:nvPr/>
-      </p:nvGrpSpPr>
-      <p:grpSpPr/>
-      <p:sp>
-        <p:nvSpPr>
-          <p:cNvPr id="2" name="Rectangle 1"/>
-          <p:cNvSpPr/>
-          <p:nvPr/>
-        </p:nvSpPr>
-        <p:spPr>
-          <a:xfrm>
-            <a:off x="0" y="0"/>
-            <a:ext cx="12191695" cy="6858000"/>
-          </a:xfrm>
-          <a:prstGeom prst="rect">
-            <a:avLst/>
-          </a:prstGeom>
-          <a:solidFill>
-            <a:srgbClr val="0F172A"/>
-          </a:solidFill>
-          <a:ln>
-            <a:noFill/>
-          </a:ln>
-        </p:spPr>
-        <p:style>
-          <a:lnRef idx="1">
-            <a:schemeClr val="accent1"/>
-          </a:lnRef>
-          <a:fillRef idx="3">
-            <a:schemeClr val="accent1"/>
-          </a:fillRef>
-          <a:effectRef idx="2">
-            <a:schemeClr val="accent1"/>
-          </a:effectRef>
-          <a:fontRef idx="minor">
-            <a:schemeClr val="lt1"/>
-          </a:fontRef>
-        </p:style>
-        <p:txBody>
-          <a:bodyPr rtlCol="0" anchor="ctr"/>
-          <a:lstStyle/>
-          <a:p>
-            <a:pPr algn="ctr"/>
-          </a:p>
-        </p:txBody>
-      </p:sp>
-      <p:sp>
-        <p:nvSpPr>
-          <p:cNvPr id="3" name="TextBox 2"/>
-          <p:cNvSpPr txBox="1"/>
-          <p:nvPr/>
-        </p:nvSpPr>
-        <p:spPr>
-          <a:xfrm>
-            <a:off x="731520" y="365760"/>
-            <a:ext cx="10698480" cy="365760"/>
-          </a:xfrm>
-          <a:prstGeom prst="rect">
-            <a:avLst/>
-          </a:prstGeom>
-          <a:noFill/>
-        </p:spPr>
-        <p:txBody>
-          <a:bodyPr wrap="none">
-            <a:spAutoFit/>
-          </a:bodyPr>
-          <a:lstStyle/>
-          <a:p>
-            <a:r>
-              <a:rPr sz="1100" b="1">
-                <a:solidFill>
-                  <a:srgbClr val="38BDF8"/>
-                </a:solidFill>
-              </a:rPr>
-              <a:t>CONCLUSION</a:t>
-            </a:r>
-          </a:p>
-        </p:txBody>
-      </p:sp>
-      <p:sp>
-        <p:nvSpPr>
-          <p:cNvPr id="4" name="TextBox 3"/>
-          <p:cNvSpPr txBox="1"/>
-          <p:nvPr/>
-        </p:nvSpPr>
-        <p:spPr>
-          <a:xfrm>
-            <a:off x="731520" y="640080"/>
-            <a:ext cx="10698480" cy="731520"/>
-          </a:xfrm>
-          <a:prstGeom prst="rect">
-            <a:avLst/>
-          </a:prstGeom>
-          <a:noFill/>
-        </p:spPr>
-        <p:txBody>
-          <a:bodyPr wrap="none">
-            <a:spAutoFit/>
-          </a:bodyPr>
-          <a:lstStyle/>
-          <a:p>
-            <a:r>
-              <a:rPr sz="2400" b="1">
-                <a:solidFill>
-                  <a:srgbClr val="FFFFFF"/>
-                </a:solidFill>
-              </a:rPr>
-              <a:t>Summary &amp; Future Improvements</a:t>
-            </a:r>
-          </a:p>
-        </p:txBody>
-      </p:sp>
-      <p:sp>
-        <p:nvSpPr>
-          <p:cNvPr id="5" name="Rounded Rectangle 4"/>
-          <p:cNvSpPr/>
-          <p:nvPr/>
-        </p:nvSpPr>
-        <p:spPr>
-          <a:xfrm>
-            <a:off x="731520" y="1645920"/>
-            <a:ext cx="5120640" cy="4389120"/>
-          </a:xfrm>
-          <a:prstGeom prst="roundRect">
-            <a:avLst/>
-          </a:prstGeom>
-          <a:solidFill>
-            <a:srgbClr val="1E293B"/>
-          </a:solidFill>
-          <a:ln w="19050">
-            <a:solidFill>
-              <a:srgbClr val="34D399"/>
-            </a:solidFill>
-          </a:ln>
-        </p:spPr>
-        <p:style>
-          <a:lnRef idx="1">
-            <a:schemeClr val="accent1"/>
-          </a:lnRef>
-          <a:fillRef idx="3">
-            <a:schemeClr val="accent1"/>
-          </a:fillRef>
-          <a:effectRef idx="2">
-            <a:schemeClr val="accent1"/>
-          </a:effectRef>
-          <a:fontRef idx="minor">
-            <a:schemeClr val="lt1"/>
-          </a:fontRef>
-        </p:style>
-        <p:txBody>
-          <a:bodyPr rtlCol="0" anchor="ctr"/>
-          <a:lstStyle/>
-          <a:p>
-            <a:pPr algn="ctr"/>
-          </a:p>
-        </p:txBody>
-      </p:sp>
-      <p:sp>
-        <p:nvSpPr>
-          <p:cNvPr id="6" name="TextBox 5"/>
-          <p:cNvSpPr txBox="1"/>
-          <p:nvPr/>
-        </p:nvSpPr>
-        <p:spPr>
-          <a:xfrm>
-            <a:off x="914400" y="1828800"/>
-            <a:ext cx="4754880" cy="4023360"/>
-          </a:xfrm>
-          <a:prstGeom prst="rect">
-            <a:avLst/>
-          </a:prstGeom>
-          <a:noFill/>
-        </p:spPr>
-        <p:txBody>
-          <a:bodyPr wrap="square">
-            <a:spAutoFit/>
-          </a:bodyPr>
-          <a:lstStyle/>
-          <a:p>
-            <a:r>
-              <a:rPr sz="1800" b="1">
-                <a:solidFill>
-                  <a:srgbClr val="34D399"/>
-                </a:solidFill>
-              </a:rPr>
-              <a:t>Key Results:</a:t>
-            </a:r>
-          </a:p>
-          <a:p>
-            <a:pPr>
-              <a:spcBef>
-                <a:spcPts val="1000"/>
-              </a:spcBef>
-            </a:pPr>
-            <a:r>
-              <a:rPr sz="1250" b="0">
-                <a:solidFill>
-                  <a:srgbClr val="FFFFFF"/>
-                </a:solidFill>
-              </a:rPr>
-              <a:t>Universal Model (All Coal):
-• Average Error (RMSE): 150.28 Kcal/kg
-• Absolute Error (MAE): 105.97 Kcal/kg
-• Error Percentage: 2.18% (target was &lt; 8%)
-• Accuracy (R²): 0.96
-Bituminous Model:
-• Average Error (RMSE): 134.18 Kcal/kg
-• Absolute Error (MAE): 96.29 Kcal/kg
-• Error Percentage: 1.91%
-• Accuracy (R²): 0.95</a:t>
-            </a:r>
-          </a:p>
-        </p:txBody>
-      </p:sp>
-      <p:sp>
-        <p:nvSpPr>
-          <p:cNvPr id="7" name="Rounded Rectangle 6"/>
-          <p:cNvSpPr/>
-          <p:nvPr/>
-        </p:nvSpPr>
-        <p:spPr>
-          <a:xfrm>
-            <a:off x="6217920" y="1645920"/>
-            <a:ext cx="5212080" cy="4389120"/>
-          </a:xfrm>
-          <a:prstGeom prst="roundRect">
-            <a:avLst/>
-          </a:prstGeom>
-          <a:solidFill>
-            <a:srgbClr val="1E293B"/>
-          </a:solidFill>
-          <a:ln w="19050">
-            <a:solidFill>
-              <a:srgbClr val="38BDF8"/>
-            </a:solidFill>
-          </a:ln>
-        </p:spPr>
-        <p:style>
-          <a:lnRef idx="1">
-            <a:schemeClr val="accent1"/>
-          </a:lnRef>
-          <a:fillRef idx="3">
-            <a:schemeClr val="accent1"/>
-          </a:fillRef>
-          <a:effectRef idx="2">
-            <a:schemeClr val="accent1"/>
-          </a:effectRef>
-          <a:fontRef idx="minor">
-            <a:schemeClr val="lt1"/>
-          </a:fontRef>
-        </p:style>
-        <p:txBody>
-          <a:bodyPr rtlCol="0" anchor="ctr"/>
-          <a:lstStyle/>
-          <a:p>
-            <a:pPr algn="ctr"/>
-          </a:p>
-        </p:txBody>
-      </p:sp>
-      <p:sp>
-        <p:nvSpPr>
-          <p:cNvPr id="8" name="TextBox 7"/>
-          <p:cNvSpPr txBox="1"/>
-          <p:nvPr/>
-        </p:nvSpPr>
-        <p:spPr>
-          <a:xfrm>
-            <a:off x="6400800" y="1828800"/>
-            <a:ext cx="4846320" cy="4023360"/>
-          </a:xfrm>
-          <a:prstGeom prst="rect">
-            <a:avLst/>
-          </a:prstGeom>
-          <a:noFill/>
-        </p:spPr>
-        <p:txBody>
-          <a:bodyPr wrap="square">
-            <a:spAutoFit/>
-          </a:bodyPr>
-          <a:lstStyle/>
-          <a:p>
-            <a:r>
-              <a:rPr sz="1800" b="1">
-                <a:solidFill>
-                  <a:srgbClr val="38BDF8"/>
-                </a:solidFill>
-              </a:rPr>
-              <a:t>What Can Be Added Next:</a:t>
-            </a:r>
-          </a:p>
-          <a:p>
-            <a:pPr>
-              <a:spcBef>
-                <a:spcPts val="1000"/>
-              </a:spcBef>
-            </a:pPr>
-            <a:r>
-              <a:rPr sz="1200" b="0">
-                <a:solidFill>
-                  <a:srgbClr val="FFFFFF"/>
-                </a:solidFill>
-              </a:rPr>
-              <a:t>1. Ultimate Analysis Mode:
-If elemental test numbers are available (Carbon, Hydrogen, Oxygen, Sulfur), adding them can bring error under 50 Kcal/kg.
-2. Prediction Ranges (Confidence Intervals):
-Give a range (e.g. 6800 ± 80 Kcal/kg) instead of a single number to show certainty.
-3. Bulk Upload:
-Add a button in the web app to upload a full CSV with thousands of samples at once.
-4. Formula Comparison:
-Compare model accuracy directly with classical Dulong and Goutal empirical formulas.</a:t>
             </a:r>
           </a:p>
         </p:txBody>
@@ -4195,7 +3362,7 @@
                   <a:srgbClr val="38BDF8"/>
                 </a:solidFill>
               </a:rPr>
-              <a:t>BACKGROUND</a:t>
+              <a:t>DATASET</a:t>
             </a:r>
           </a:p>
         </p:txBody>
@@ -4228,7 +3395,7 @@
                   <a:srgbClr val="FFFFFF"/>
                 </a:solidFill>
               </a:rPr>
-              <a:t>Problem &amp; Motivation</a:t>
+              <a:t>Data Preparation &amp; Cleaning</a:t>
             </a:r>
           </a:p>
         </p:txBody>
@@ -4242,7 +3409,7 @@
         <p:spPr>
           <a:xfrm>
             <a:off x="731520" y="1645920"/>
-            <a:ext cx="3383280" cy="4389120"/>
+            <a:ext cx="5120640" cy="2011680"/>
           </a:xfrm>
           <a:prstGeom prst="roundRect">
             <a:avLst/>
@@ -4252,7 +3419,7 @@
           </a:solidFill>
           <a:ln w="19050">
             <a:solidFill>
-              <a:srgbClr val="FB923C"/>
+              <a:srgbClr val="38BDF8"/>
             </a:solidFill>
           </a:ln>
         </p:spPr>
@@ -4286,8 +3453,8 @@
         </p:nvSpPr>
         <p:spPr>
           <a:xfrm>
-            <a:off x="960120" y="1874520"/>
-            <a:ext cx="2926080" cy="3931920"/>
+            <a:off x="960120" y="1828800"/>
+            <a:ext cx="4663440" cy="1645920"/>
           </a:xfrm>
           <a:prstGeom prst="rect">
             <a:avLst/>
@@ -4301,28 +3468,29 @@
           <a:lstStyle/>
           <a:p>
             <a:r>
-              <a:rPr sz="1800" b="1">
-                <a:solidFill>
-                  <a:srgbClr val="FB923C"/>
-                </a:solidFill>
-              </a:rPr>
-              <a:t>The Current Problem</a:t>
+              <a:rPr sz="1600" b="1">
+                <a:solidFill>
+                  <a:srgbClr val="38BDF8"/>
+                </a:solidFill>
+              </a:rPr>
+              <a:t>1. Unit Conversion</a:t>
             </a:r>
           </a:p>
           <a:p>
             <a:pPr>
               <a:spcBef>
-                <a:spcPts val="1400"/>
+                <a:spcPts val="800"/>
               </a:spcBef>
             </a:pPr>
             <a:r>
-              <a:rPr sz="1300" b="0">
+              <a:rPr sz="1250" b="0">
                 <a:solidFill>
                   <a:srgbClr val="FFFFFF"/>
                 </a:solidFill>
               </a:rPr>
-              <a:t>Measuring Gross Calorific Value (GCV) experimentally in a bomb calorimeter is slow and requires expensive equipment.
-Lab results often take 1 to 2 days, delaying decisions in power plants and coal trading.</a:t>
+              <a:t>Raw laboratory data came with heating values in Btu/lb.
+Converted to standard metric units:
+GCV (Kcal/kg) = Btu / 1.8</a:t>
             </a:r>
           </a:p>
         </p:txBody>
@@ -4335,8 +3503,8 @@
         </p:nvSpPr>
         <p:spPr>
           <a:xfrm>
-            <a:off x="4297680" y="1645920"/>
-            <a:ext cx="3383280" cy="4389120"/>
+            <a:off x="6126480" y="1645920"/>
+            <a:ext cx="5120640" cy="2011680"/>
           </a:xfrm>
           <a:prstGeom prst="roundRect">
             <a:avLst/>
@@ -4346,7 +3514,7 @@
           </a:solidFill>
           <a:ln w="19050">
             <a:solidFill>
-              <a:srgbClr val="38BDF8"/>
+              <a:srgbClr val="34D399"/>
             </a:solidFill>
           </a:ln>
         </p:spPr>
@@ -4380,8 +3548,8 @@
         </p:nvSpPr>
         <p:spPr>
           <a:xfrm>
-            <a:off x="4526280" y="1874520"/>
-            <a:ext cx="2926080" cy="3931920"/>
+            <a:off x="6355080" y="1828800"/>
+            <a:ext cx="4663440" cy="1645920"/>
           </a:xfrm>
           <a:prstGeom prst="rect">
             <a:avLst/>
@@ -4395,28 +3563,28 @@
           <a:lstStyle/>
           <a:p>
             <a:r>
-              <a:rPr sz="1800" b="1">
-                <a:solidFill>
-                  <a:srgbClr val="38BDF8"/>
-                </a:solidFill>
-              </a:rPr>
-              <a:t>The Solution</a:t>
+              <a:rPr sz="1600" b="1">
+                <a:solidFill>
+                  <a:srgbClr val="34D399"/>
+                </a:solidFill>
+              </a:rPr>
+              <a:t>2. Handling Missing Values</a:t>
             </a:r>
           </a:p>
           <a:p>
             <a:pPr>
               <a:spcBef>
-                <a:spcPts val="1400"/>
+                <a:spcPts val="800"/>
               </a:spcBef>
             </a:pPr>
             <a:r>
-              <a:rPr sz="1300" b="0">
+              <a:rPr sz="1250" b="0">
                 <a:solidFill>
                   <a:srgbClr val="FFFFFF"/>
                 </a:solidFill>
               </a:rPr>
-              <a:t>Proximate analysis (Moisture, Volatile Matter, and Ash) is quick, cheap, and routine.
-We train Machine Learning models to calculate GCV accurately from these basic numbers in seconds.</a:t>
+              <a:t>Some samples had missing moisture or ash values.
+Used a K-Nearest Neighbors (KNN) imputer using only other input features, never using the target value.</a:t>
             </a:r>
           </a:p>
         </p:txBody>
@@ -4429,8 +3597,8 @@
         </p:nvSpPr>
         <p:spPr>
           <a:xfrm>
-            <a:off x="7863840" y="1645920"/>
-            <a:ext cx="3383280" cy="4389120"/>
+            <a:off x="731520" y="3931920"/>
+            <a:ext cx="5120640" cy="2011680"/>
           </a:xfrm>
           <a:prstGeom prst="roundRect">
             <a:avLst/>
@@ -4440,7 +3608,7 @@
           </a:solidFill>
           <a:ln w="19050">
             <a:solidFill>
-              <a:srgbClr val="34D399"/>
+              <a:srgbClr val="FB923C"/>
             </a:solidFill>
           </a:ln>
         </p:spPr>
@@ -4474,8 +3642,8 @@
         </p:nvSpPr>
         <p:spPr>
           <a:xfrm>
-            <a:off x="8092440" y="1874520"/>
-            <a:ext cx="2926080" cy="3931920"/>
+            <a:off x="960120" y="4114800"/>
+            <a:ext cx="4663440" cy="1645920"/>
           </a:xfrm>
           <a:prstGeom prst="rect">
             <a:avLst/>
@@ -4489,31 +3657,125 @@
           <a:lstStyle/>
           <a:p>
             <a:r>
-              <a:rPr sz="1800" b="1">
-                <a:solidFill>
-                  <a:srgbClr val="34D399"/>
-                </a:solidFill>
-              </a:rPr>
-              <a:t>Accuracy Target</a:t>
+              <a:rPr sz="1600" b="1">
+                <a:solidFill>
+                  <a:srgbClr val="FB923C"/>
+                </a:solidFill>
+              </a:rPr>
+              <a:t>3. Removing Bad Data</a:t>
             </a:r>
           </a:p>
           <a:p>
             <a:pPr>
               <a:spcBef>
-                <a:spcPts val="1400"/>
+                <a:spcPts val="800"/>
               </a:spcBef>
             </a:pPr>
             <a:r>
-              <a:rPr sz="1300" b="0">
+              <a:rPr sz="1250" b="0">
                 <a:solidFill>
                   <a:srgbClr val="FFFFFF"/>
                 </a:solidFill>
               </a:rPr>
-              <a:t>Industry Target: RMSE under 200 Kcal/kg (Error under 8%).
-Our Results:
-• Overall model: 150 Kcal/kg (2.18% error)
-• Bituminous model: 134 Kcal/kg (1.91% error)
-Both easily beat the target.</a:t>
+              <a:t>Removed obvious measurement errors and impossible samples:
+• Energy below 2000 or above 9000 Kcal/kg
+• Ash above 55% (unusable for fuel)
+• Negative moisture or volatile matter</a:t>
+            </a:r>
+          </a:p>
+        </p:txBody>
+      </p:sp>
+      <p:sp>
+        <p:nvSpPr>
+          <p:cNvPr id="11" name="Rounded Rectangle 10"/>
+          <p:cNvSpPr/>
+          <p:nvPr/>
+        </p:nvSpPr>
+        <p:spPr>
+          <a:xfrm>
+            <a:off x="6126480" y="3931920"/>
+            <a:ext cx="5120640" cy="2011680"/>
+          </a:xfrm>
+          <a:prstGeom prst="roundRect">
+            <a:avLst/>
+          </a:prstGeom>
+          <a:solidFill>
+            <a:srgbClr val="1E293B"/>
+          </a:solidFill>
+          <a:ln w="19050">
+            <a:solidFill>
+              <a:srgbClr val="38BDF8"/>
+            </a:solidFill>
+          </a:ln>
+        </p:spPr>
+        <p:style>
+          <a:lnRef idx="1">
+            <a:schemeClr val="accent1"/>
+          </a:lnRef>
+          <a:fillRef idx="3">
+            <a:schemeClr val="accent1"/>
+          </a:fillRef>
+          <a:effectRef idx="2">
+            <a:schemeClr val="accent1"/>
+          </a:effectRef>
+          <a:fontRef idx="minor">
+            <a:schemeClr val="lt1"/>
+          </a:fontRef>
+        </p:style>
+        <p:txBody>
+          <a:bodyPr rtlCol="0" anchor="ctr"/>
+          <a:lstStyle/>
+          <a:p>
+            <a:pPr algn="ctr"/>
+          </a:p>
+        </p:txBody>
+      </p:sp>
+      <p:sp>
+        <p:nvSpPr>
+          <p:cNvPr id="12" name="TextBox 11"/>
+          <p:cNvSpPr txBox="1"/>
+          <p:nvPr/>
+        </p:nvSpPr>
+        <p:spPr>
+          <a:xfrm>
+            <a:off x="6355080" y="4114800"/>
+            <a:ext cx="4663440" cy="1645920"/>
+          </a:xfrm>
+          <a:prstGeom prst="rect">
+            <a:avLst/>
+          </a:prstGeom>
+          <a:noFill/>
+        </p:spPr>
+        <p:txBody>
+          <a:bodyPr wrap="square">
+            <a:spAutoFit/>
+          </a:bodyPr>
+          <a:lstStyle/>
+          <a:p>
+            <a:r>
+              <a:rPr sz="1600" b="1">
+                <a:solidFill>
+                  <a:srgbClr val="38BDF8"/>
+                </a:solidFill>
+              </a:rPr>
+              <a:t>4. Mass Balance Check</a:t>
+            </a:r>
+          </a:p>
+          <a:p>
+            <a:pPr>
+              <a:spcBef>
+                <a:spcPts val="800"/>
+              </a:spcBef>
+            </a:pPr>
+            <a:r>
+              <a:rPr sz="1250" b="0">
+                <a:solidFill>
+                  <a:srgbClr val="FFFFFF"/>
+                </a:solidFill>
+              </a:rPr>
+              <a:t>Moisture + Volatiles + Ash + Carbon must total 100%:
+Fixed Carbon = 100 - (Moisture + VM + Ash)
+Removed any samples where this total was broken.</a:t>
             </a:r>
           </a:p>
         </p:txBody>
@@ -4607,7 +3869,7 @@
                   <a:srgbClr val="38BDF8"/>
                 </a:solidFill>
               </a:rPr>
-              <a:t>DATASET</a:t>
+              <a:t>FEATURE CALCULATION</a:t>
             </a:r>
           </a:p>
         </p:txBody>
@@ -4640,21 +3902,115 @@
                   <a:srgbClr val="FFFFFF"/>
                 </a:solidFill>
               </a:rPr>
-              <a:t>Data Preparation &amp; Cleaning</a:t>
-            </a:r>
-          </a:p>
-        </p:txBody>
-      </p:sp>
-      <p:sp>
-        <p:nvSpPr>
-          <p:cNvPr id="5" name="Rounded Rectangle 4"/>
+              <a:t>Feature Calculation: Why Add Fuel Ratio?</a:t>
+            </a:r>
+          </a:p>
+        </p:txBody>
+      </p:sp>
+      <p:sp>
+        <p:nvSpPr>
+          <p:cNvPr id="5" name="TextBox 4"/>
+          <p:cNvSpPr txBox="1"/>
+          <p:nvPr/>
+        </p:nvSpPr>
+        <p:spPr>
+          <a:xfrm>
+            <a:off x="731520" y="1645920"/>
+            <a:ext cx="5486400" cy="4389120"/>
+          </a:xfrm>
+          <a:prstGeom prst="rect">
+            <a:avLst/>
+          </a:prstGeom>
+          <a:noFill/>
+        </p:spPr>
+        <p:txBody>
+          <a:bodyPr wrap="square">
+            <a:spAutoFit/>
+          </a:bodyPr>
+          <a:lstStyle/>
+          <a:p>
+            <a:r>
+              <a:rPr sz="1800" b="1">
+                <a:solidFill>
+                  <a:srgbClr val="FB923C"/>
+                </a:solidFill>
+              </a:rPr>
+              <a:t>Why ML Models Need Help With Division:</a:t>
+            </a:r>
+          </a:p>
+          <a:p>
+            <a:pPr>
+              <a:spcBef>
+                <a:spcPts val="1000"/>
+              </a:spcBef>
+            </a:pPr>
+            <a:r>
+              <a:rPr sz="1300" b="0">
+                <a:solidFill>
+                  <a:srgbClr val="FFFFFF"/>
+                </a:solidFill>
+              </a:rPr>
+              <a:t>• Decision trees (XGBoost, Random Forest) split data using simple 'if greater than' rules. They cannot naturally divide two numbers without hundreds of complex splits.</a:t>
+            </a:r>
+          </a:p>
+          <a:p>
+            <a:pPr>
+              <a:spcBef>
+                <a:spcPts val="1000"/>
+              </a:spcBef>
+            </a:pPr>
+            <a:r>
+              <a:rPr sz="1300" b="0">
+                <a:solidFill>
+                  <a:srgbClr val="FFFFFF"/>
+                </a:solidFill>
+              </a:rPr>
+              <a:t>• In coal chemistry, Fuel Ratio is a standard formula:
+Fuel Ratio = Fixed Carbon / Volatile Matter</a:t>
+            </a:r>
+          </a:p>
+          <a:p>
+            <a:pPr>
+              <a:spcBef>
+                <a:spcPts val="1000"/>
+              </a:spcBef>
+            </a:pPr>
+            <a:r>
+              <a:rPr sz="1300" b="0">
+                <a:solidFill>
+                  <a:srgbClr val="FFFFFF"/>
+                </a:solidFill>
+              </a:rPr>
+              <a:t>• Fuel Ratio tells you what kind of coal you have (Lignite vs Bituminous vs Anthracite).</a:t>
+            </a:r>
+          </a:p>
+          <a:p>
+            <a:pPr>
+              <a:spcBef>
+                <a:spcPts val="1000"/>
+              </a:spcBef>
+            </a:pPr>
+            <a:r>
+              <a:rPr sz="1300" b="0">
+                <a:solidFill>
+                  <a:srgbClr val="FFFFFF"/>
+                </a:solidFill>
+              </a:rPr>
+              <a:t>• By doing the division for the model beforehand, the trees understand coal rank immediately without needing extra depth.</a:t>
+            </a:r>
+          </a:p>
+        </p:txBody>
+      </p:sp>
+      <p:sp>
+        <p:nvSpPr>
+          <p:cNvPr id="6" name="Rounded Rectangle 5"/>
           <p:cNvSpPr/>
           <p:nvPr/>
         </p:nvSpPr>
         <p:spPr>
           <a:xfrm>
-            <a:off x="731520" y="1645920"/>
-            <a:ext cx="5120640" cy="2011680"/>
+            <a:off x="6583680" y="1645920"/>
+            <a:ext cx="4846320" cy="4389120"/>
           </a:xfrm>
           <a:prstGeom prst="roundRect">
             <a:avLst/>
@@ -4664,7 +4020,7 @@
           </a:solidFill>
           <a:ln w="19050">
             <a:solidFill>
-              <a:srgbClr val="38BDF8"/>
+              <a:srgbClr val="34D399"/>
             </a:solidFill>
           </a:ln>
         </p:spPr>
@@ -4692,14 +4048,14 @@
       </p:sp>
       <p:sp>
         <p:nvSpPr>
-          <p:cNvPr id="6" name="TextBox 5"/>
+          <p:cNvPr id="7" name="TextBox 6"/>
           <p:cNvSpPr txBox="1"/>
           <p:nvPr/>
         </p:nvSpPr>
         <p:spPr>
           <a:xfrm>
-            <a:off x="960120" y="1828800"/>
-            <a:ext cx="4663440" cy="1645920"/>
+            <a:off x="6858000" y="1920240"/>
+            <a:ext cx="4297680" cy="3840480"/>
           </a:xfrm>
           <a:prstGeom prst="rect">
             <a:avLst/>
@@ -4713,314 +4069,47 @@
           <a:lstStyle/>
           <a:p>
             <a:r>
-              <a:rPr sz="1600" b="1">
-                <a:solidFill>
-                  <a:srgbClr val="38BDF8"/>
-                </a:solidFill>
-              </a:rPr>
-              <a:t>1. Unit Conversion</a:t>
+              <a:rPr sz="1700" b="1">
+                <a:solidFill>
+                  <a:srgbClr val="34D399"/>
+                </a:solidFill>
+              </a:rPr>
+              <a:t>Formulas Added to the Data:</a:t>
             </a:r>
           </a:p>
           <a:p>
             <a:pPr>
               <a:spcBef>
-                <a:spcPts val="800"/>
+                <a:spcPts val="1200"/>
               </a:spcBef>
             </a:pPr>
             <a:r>
-              <a:rPr sz="1250" b="0">
+              <a:rPr sz="1500" b="1">
                 <a:solidFill>
                   <a:srgbClr val="FFFFFF"/>
                 </a:solidFill>
               </a:rPr>
-              <a:t>Raw laboratory data came with heating values in Btu/lb.
-Converted to standard metric units:
-GCV (Kcal/kg) = Btu / 1.8</a:t>
-            </a:r>
-          </a:p>
-        </p:txBody>
-      </p:sp>
-      <p:sp>
-        <p:nvSpPr>
-          <p:cNvPr id="7" name="Rounded Rectangle 6"/>
-          <p:cNvSpPr/>
-          <p:nvPr/>
-        </p:nvSpPr>
-        <p:spPr>
-          <a:xfrm>
-            <a:off x="6126480" y="1645920"/>
-            <a:ext cx="5120640" cy="2011680"/>
-          </a:xfrm>
-          <a:prstGeom prst="roundRect">
-            <a:avLst/>
-          </a:prstGeom>
-          <a:solidFill>
-            <a:srgbClr val="1E293B"/>
-          </a:solidFill>
-          <a:ln w="19050">
-            <a:solidFill>
-              <a:srgbClr val="34D399"/>
-            </a:solidFill>
-          </a:ln>
-        </p:spPr>
-        <p:style>
-          <a:lnRef idx="1">
-            <a:schemeClr val="accent1"/>
-          </a:lnRef>
-          <a:fillRef idx="3">
-            <a:schemeClr val="accent1"/>
-          </a:fillRef>
-          <a:effectRef idx="2">
-            <a:schemeClr val="accent1"/>
-          </a:effectRef>
-          <a:fontRef idx="minor">
-            <a:schemeClr val="lt1"/>
-          </a:fontRef>
-        </p:style>
-        <p:txBody>
-          <a:bodyPr rtlCol="0" anchor="ctr"/>
-          <a:lstStyle/>
-          <a:p>
-            <a:pPr algn="ctr"/>
-          </a:p>
-        </p:txBody>
-      </p:sp>
-      <p:sp>
-        <p:nvSpPr>
-          <p:cNvPr id="8" name="TextBox 7"/>
-          <p:cNvSpPr txBox="1"/>
-          <p:nvPr/>
-        </p:nvSpPr>
-        <p:spPr>
-          <a:xfrm>
-            <a:off x="6355080" y="1828800"/>
-            <a:ext cx="4663440" cy="1645920"/>
-          </a:xfrm>
-          <a:prstGeom prst="rect">
-            <a:avLst/>
-          </a:prstGeom>
-          <a:noFill/>
-        </p:spPr>
-        <p:txBody>
-          <a:bodyPr wrap="square">
-            <a:spAutoFit/>
-          </a:bodyPr>
-          <a:lstStyle/>
-          <a:p>
-            <a:r>
-              <a:rPr sz="1600" b="1">
-                <a:solidFill>
-                  <a:srgbClr val="34D399"/>
-                </a:solidFill>
-              </a:rPr>
-              <a:t>2. Handling Missing Values</a:t>
+              <a:t>1. Fixed Carbon = 100 - (Moisture + VM + Ash)
+2. Fuel Ratio = Fixed Carbon / VM</a:t>
             </a:r>
           </a:p>
           <a:p>
             <a:pPr>
               <a:spcBef>
-                <a:spcPts val="800"/>
+                <a:spcPts val="1200"/>
               </a:spcBef>
             </a:pPr>
             <a:r>
-              <a:rPr sz="1250" b="0">
+              <a:rPr sz="1300" b="0">
                 <a:solidFill>
                   <a:srgbClr val="FFFFFF"/>
                 </a:solidFill>
               </a:rPr>
-              <a:t>Some samples had missing moisture or ash values.
-Used a K-Nearest Neighbors (KNN) imputer using only other input features, never using the target value.</a:t>
-            </a:r>
-          </a:p>
-        </p:txBody>
-      </p:sp>
-      <p:sp>
-        <p:nvSpPr>
-          <p:cNvPr id="9" name="Rounded Rectangle 8"/>
-          <p:cNvSpPr/>
-          <p:nvPr/>
-        </p:nvSpPr>
-        <p:spPr>
-          <a:xfrm>
-            <a:off x="731520" y="3931920"/>
-            <a:ext cx="5120640" cy="2011680"/>
-          </a:xfrm>
-          <a:prstGeom prst="roundRect">
-            <a:avLst/>
-          </a:prstGeom>
-          <a:solidFill>
-            <a:srgbClr val="1E293B"/>
-          </a:solidFill>
-          <a:ln w="19050">
-            <a:solidFill>
-              <a:srgbClr val="FB923C"/>
-            </a:solidFill>
-          </a:ln>
-        </p:spPr>
-        <p:style>
-          <a:lnRef idx="1">
-            <a:schemeClr val="accent1"/>
-          </a:lnRef>
-          <a:fillRef idx="3">
-            <a:schemeClr val="accent1"/>
-          </a:fillRef>
-          <a:effectRef idx="2">
-            <a:schemeClr val="accent1"/>
-          </a:effectRef>
-          <a:fontRef idx="minor">
-            <a:schemeClr val="lt1"/>
-          </a:fontRef>
-        </p:style>
-        <p:txBody>
-          <a:bodyPr rtlCol="0" anchor="ctr"/>
-          <a:lstStyle/>
-          <a:p>
-            <a:pPr algn="ctr"/>
-          </a:p>
-        </p:txBody>
-      </p:sp>
-      <p:sp>
-        <p:nvSpPr>
-          <p:cNvPr id="10" name="TextBox 9"/>
-          <p:cNvSpPr txBox="1"/>
-          <p:nvPr/>
-        </p:nvSpPr>
-        <p:spPr>
-          <a:xfrm>
-            <a:off x="960120" y="4114800"/>
-            <a:ext cx="4663440" cy="1645920"/>
-          </a:xfrm>
-          <a:prstGeom prst="rect">
-            <a:avLst/>
-          </a:prstGeom>
-          <a:noFill/>
-        </p:spPr>
-        <p:txBody>
-          <a:bodyPr wrap="square">
-            <a:spAutoFit/>
-          </a:bodyPr>
-          <a:lstStyle/>
-          <a:p>
-            <a:r>
-              <a:rPr sz="1600" b="1">
-                <a:solidFill>
-                  <a:srgbClr val="FB923C"/>
-                </a:solidFill>
-              </a:rPr>
-              <a:t>3. Removing Bad Data</a:t>
-            </a:r>
-          </a:p>
-          <a:p>
-            <a:pPr>
-              <a:spcBef>
-                <a:spcPts val="800"/>
-              </a:spcBef>
-            </a:pPr>
-            <a:r>
-              <a:rPr sz="1250" b="0">
-                <a:solidFill>
-                  <a:srgbClr val="FFFFFF"/>
-                </a:solidFill>
-              </a:rPr>
-              <a:t>Removed obvious measurement errors and impossible samples:
-• Energy below 2000 or above 9000 Kcal/kg
-• Ash above 55% (unusable for fuel)
-• Negative moisture or volatile matter</a:t>
-            </a:r>
-          </a:p>
-        </p:txBody>
-      </p:sp>
-      <p:sp>
-        <p:nvSpPr>
-          <p:cNvPr id="11" name="Rounded Rectangle 10"/>
-          <p:cNvSpPr/>
-          <p:nvPr/>
-        </p:nvSpPr>
-        <p:spPr>
-          <a:xfrm>
-            <a:off x="6126480" y="3931920"/>
-            <a:ext cx="5120640" cy="2011680"/>
-          </a:xfrm>
-          <a:prstGeom prst="roundRect">
-            <a:avLst/>
-          </a:prstGeom>
-          <a:solidFill>
-            <a:srgbClr val="1E293B"/>
-          </a:solidFill>
-          <a:ln w="19050">
-            <a:solidFill>
-              <a:srgbClr val="38BDF8"/>
-            </a:solidFill>
-          </a:ln>
-        </p:spPr>
-        <p:style>
-          <a:lnRef idx="1">
-            <a:schemeClr val="accent1"/>
-          </a:lnRef>
-          <a:fillRef idx="3">
-            <a:schemeClr val="accent1"/>
-          </a:fillRef>
-          <a:effectRef idx="2">
-            <a:schemeClr val="accent1"/>
-          </a:effectRef>
-          <a:fontRef idx="minor">
-            <a:schemeClr val="lt1"/>
-          </a:fontRef>
-        </p:style>
-        <p:txBody>
-          <a:bodyPr rtlCol="0" anchor="ctr"/>
-          <a:lstStyle/>
-          <a:p>
-            <a:pPr algn="ctr"/>
-          </a:p>
-        </p:txBody>
-      </p:sp>
-      <p:sp>
-        <p:nvSpPr>
-          <p:cNvPr id="12" name="TextBox 11"/>
-          <p:cNvSpPr txBox="1"/>
-          <p:nvPr/>
-        </p:nvSpPr>
-        <p:spPr>
-          <a:xfrm>
-            <a:off x="6355080" y="4114800"/>
-            <a:ext cx="4663440" cy="1645920"/>
-          </a:xfrm>
-          <a:prstGeom prst="rect">
-            <a:avLst/>
-          </a:prstGeom>
-          <a:noFill/>
-        </p:spPr>
-        <p:txBody>
-          <a:bodyPr wrap="square">
-            <a:spAutoFit/>
-          </a:bodyPr>
-          <a:lstStyle/>
-          <a:p>
-            <a:r>
-              <a:rPr sz="1600" b="1">
-                <a:solidFill>
-                  <a:srgbClr val="38BDF8"/>
-                </a:solidFill>
-              </a:rPr>
-              <a:t>4. Mass Balance Check</a:t>
-            </a:r>
-          </a:p>
-          <a:p>
-            <a:pPr>
-              <a:spcBef>
-                <a:spcPts val="800"/>
-              </a:spcBef>
-            </a:pPr>
-            <a:r>
-              <a:rPr sz="1250" b="0">
-                <a:solidFill>
-                  <a:srgbClr val="FFFFFF"/>
-                </a:solidFill>
-              </a:rPr>
-              <a:t>Moisture + Volatiles + Ash + Carbon must total 100%:
-Fixed Carbon = 100 - (Moisture + VM + Ash)
-Removed any samples where this total was broken.</a:t>
+              <a:t>
+Why this helped:
+• Keeps models simpler and faster
+• Lets shallow trees reach lower errors
+• Directly reflects real coal combustion chemistry</a:t>
             </a:r>
           </a:p>
         </p:txBody>
@@ -5034,340 +4123,6 @@
 </file>
 
 <file path=ppt/slides/slide4.xml><?xml version="1.0" encoding="utf-8"?>
-<p:sld xmlns:a="http://schemas.openxmlformats.org/drawingml/2006/main" xmlns:p="http://schemas.openxmlformats.org/presentationml/2006/main" xmlns:r="http://schemas.openxmlformats.org/officeDocument/2006/relationships">
-  <p:cSld>
-    <p:spTree>
-      <p:nvGrpSpPr>
-        <p:cNvPr id="1" name=""/>
-        <p:cNvGrpSpPr/>
-        <p:nvPr/>
-      </p:nvGrpSpPr>
-      <p:grpSpPr/>
-      <p:sp>
-        <p:nvSpPr>
-          <p:cNvPr id="2" name="Rectangle 1"/>
-          <p:cNvSpPr/>
-          <p:nvPr/>
-        </p:nvSpPr>
-        <p:spPr>
-          <a:xfrm>
-            <a:off x="0" y="0"/>
-            <a:ext cx="12191695" cy="6858000"/>
-          </a:xfrm>
-          <a:prstGeom prst="rect">
-            <a:avLst/>
-          </a:prstGeom>
-          <a:solidFill>
-            <a:srgbClr val="0F172A"/>
-          </a:solidFill>
-          <a:ln>
-            <a:noFill/>
-          </a:ln>
-        </p:spPr>
-        <p:style>
-          <a:lnRef idx="1">
-            <a:schemeClr val="accent1"/>
-          </a:lnRef>
-          <a:fillRef idx="3">
-            <a:schemeClr val="accent1"/>
-          </a:fillRef>
-          <a:effectRef idx="2">
-            <a:schemeClr val="accent1"/>
-          </a:effectRef>
-          <a:fontRef idx="minor">
-            <a:schemeClr val="lt1"/>
-          </a:fontRef>
-        </p:style>
-        <p:txBody>
-          <a:bodyPr rtlCol="0" anchor="ctr"/>
-          <a:lstStyle/>
-          <a:p>
-            <a:pPr algn="ctr"/>
-          </a:p>
-        </p:txBody>
-      </p:sp>
-      <p:sp>
-        <p:nvSpPr>
-          <p:cNvPr id="3" name="TextBox 2"/>
-          <p:cNvSpPr txBox="1"/>
-          <p:nvPr/>
-        </p:nvSpPr>
-        <p:spPr>
-          <a:xfrm>
-            <a:off x="731520" y="365760"/>
-            <a:ext cx="10698480" cy="365760"/>
-          </a:xfrm>
-          <a:prstGeom prst="rect">
-            <a:avLst/>
-          </a:prstGeom>
-          <a:noFill/>
-        </p:spPr>
-        <p:txBody>
-          <a:bodyPr wrap="none">
-            <a:spAutoFit/>
-          </a:bodyPr>
-          <a:lstStyle/>
-          <a:p>
-            <a:r>
-              <a:rPr sz="1100" b="1">
-                <a:solidFill>
-                  <a:srgbClr val="38BDF8"/>
-                </a:solidFill>
-              </a:rPr>
-              <a:t>FEATURE CALCULATION</a:t>
-            </a:r>
-          </a:p>
-        </p:txBody>
-      </p:sp>
-      <p:sp>
-        <p:nvSpPr>
-          <p:cNvPr id="4" name="TextBox 3"/>
-          <p:cNvSpPr txBox="1"/>
-          <p:nvPr/>
-        </p:nvSpPr>
-        <p:spPr>
-          <a:xfrm>
-            <a:off x="731520" y="640080"/>
-            <a:ext cx="10698480" cy="731520"/>
-          </a:xfrm>
-          <a:prstGeom prst="rect">
-            <a:avLst/>
-          </a:prstGeom>
-          <a:noFill/>
-        </p:spPr>
-        <p:txBody>
-          <a:bodyPr wrap="none">
-            <a:spAutoFit/>
-          </a:bodyPr>
-          <a:lstStyle/>
-          <a:p>
-            <a:r>
-              <a:rPr sz="2400" b="1">
-                <a:solidFill>
-                  <a:srgbClr val="FFFFFF"/>
-                </a:solidFill>
-              </a:rPr>
-              <a:t>Feature Calculation: Why Add Fuel Ratio?</a:t>
-            </a:r>
-          </a:p>
-        </p:txBody>
-      </p:sp>
-      <p:sp>
-        <p:nvSpPr>
-          <p:cNvPr id="5" name="TextBox 4"/>
-          <p:cNvSpPr txBox="1"/>
-          <p:nvPr/>
-        </p:nvSpPr>
-        <p:spPr>
-          <a:xfrm>
-            <a:off x="731520" y="1645920"/>
-            <a:ext cx="5486400" cy="4389120"/>
-          </a:xfrm>
-          <a:prstGeom prst="rect">
-            <a:avLst/>
-          </a:prstGeom>
-          <a:noFill/>
-        </p:spPr>
-        <p:txBody>
-          <a:bodyPr wrap="square">
-            <a:spAutoFit/>
-          </a:bodyPr>
-          <a:lstStyle/>
-          <a:p>
-            <a:r>
-              <a:rPr sz="1800" b="1">
-                <a:solidFill>
-                  <a:srgbClr val="FB923C"/>
-                </a:solidFill>
-              </a:rPr>
-              <a:t>Why ML Models Need Help With Division:</a:t>
-            </a:r>
-          </a:p>
-          <a:p>
-            <a:pPr>
-              <a:spcBef>
-                <a:spcPts val="1000"/>
-              </a:spcBef>
-            </a:pPr>
-            <a:r>
-              <a:rPr sz="1300" b="0">
-                <a:solidFill>
-                  <a:srgbClr val="FFFFFF"/>
-                </a:solidFill>
-              </a:rPr>
-              <a:t>• Decision trees (XGBoost, Random Forest) split data using simple 'if greater than' rules. They cannot naturally divide two numbers without hundreds of complex splits.</a:t>
-            </a:r>
-          </a:p>
-          <a:p>
-            <a:pPr>
-              <a:spcBef>
-                <a:spcPts val="1000"/>
-              </a:spcBef>
-            </a:pPr>
-            <a:r>
-              <a:rPr sz="1300" b="0">
-                <a:solidFill>
-                  <a:srgbClr val="FFFFFF"/>
-                </a:solidFill>
-              </a:rPr>
-              <a:t>• In coal chemistry, Fuel Ratio is a standard formula:
-Fuel Ratio = Fixed Carbon / Volatile Matter</a:t>
-            </a:r>
-          </a:p>
-          <a:p>
-            <a:pPr>
-              <a:spcBef>
-                <a:spcPts val="1000"/>
-              </a:spcBef>
-            </a:pPr>
-            <a:r>
-              <a:rPr sz="1300" b="0">
-                <a:solidFill>
-                  <a:srgbClr val="FFFFFF"/>
-                </a:solidFill>
-              </a:rPr>
-              <a:t>• Fuel Ratio tells you what kind of coal you have (Lignite vs Bituminous vs Anthracite).</a:t>
-            </a:r>
-          </a:p>
-          <a:p>
-            <a:pPr>
-              <a:spcBef>
-                <a:spcPts val="1000"/>
-              </a:spcBef>
-            </a:pPr>
-            <a:r>
-              <a:rPr sz="1300" b="0">
-                <a:solidFill>
-                  <a:srgbClr val="FFFFFF"/>
-                </a:solidFill>
-              </a:rPr>
-              <a:t>• By doing the division for the model beforehand, the trees understand coal rank immediately without needing extra depth.</a:t>
-            </a:r>
-          </a:p>
-        </p:txBody>
-      </p:sp>
-      <p:sp>
-        <p:nvSpPr>
-          <p:cNvPr id="6" name="Rounded Rectangle 5"/>
-          <p:cNvSpPr/>
-          <p:nvPr/>
-        </p:nvSpPr>
-        <p:spPr>
-          <a:xfrm>
-            <a:off x="6583680" y="1645920"/>
-            <a:ext cx="4846320" cy="4389120"/>
-          </a:xfrm>
-          <a:prstGeom prst="roundRect">
-            <a:avLst/>
-          </a:prstGeom>
-          <a:solidFill>
-            <a:srgbClr val="1E293B"/>
-          </a:solidFill>
-          <a:ln w="19050">
-            <a:solidFill>
-              <a:srgbClr val="34D399"/>
-            </a:solidFill>
-          </a:ln>
-        </p:spPr>
-        <p:style>
-          <a:lnRef idx="1">
-            <a:schemeClr val="accent1"/>
-          </a:lnRef>
-          <a:fillRef idx="3">
-            <a:schemeClr val="accent1"/>
-          </a:fillRef>
-          <a:effectRef idx="2">
-            <a:schemeClr val="accent1"/>
-          </a:effectRef>
-          <a:fontRef idx="minor">
-            <a:schemeClr val="lt1"/>
-          </a:fontRef>
-        </p:style>
-        <p:txBody>
-          <a:bodyPr rtlCol="0" anchor="ctr"/>
-          <a:lstStyle/>
-          <a:p>
-            <a:pPr algn="ctr"/>
-          </a:p>
-        </p:txBody>
-      </p:sp>
-      <p:sp>
-        <p:nvSpPr>
-          <p:cNvPr id="7" name="TextBox 6"/>
-          <p:cNvSpPr txBox="1"/>
-          <p:nvPr/>
-        </p:nvSpPr>
-        <p:spPr>
-          <a:xfrm>
-            <a:off x="6858000" y="1920240"/>
-            <a:ext cx="4297680" cy="3840480"/>
-          </a:xfrm>
-          <a:prstGeom prst="rect">
-            <a:avLst/>
-          </a:prstGeom>
-          <a:noFill/>
-        </p:spPr>
-        <p:txBody>
-          <a:bodyPr wrap="square">
-            <a:spAutoFit/>
-          </a:bodyPr>
-          <a:lstStyle/>
-          <a:p>
-            <a:r>
-              <a:rPr sz="1700" b="1">
-                <a:solidFill>
-                  <a:srgbClr val="34D399"/>
-                </a:solidFill>
-              </a:rPr>
-              <a:t>Formulas Added to the Data:</a:t>
-            </a:r>
-          </a:p>
-          <a:p>
-            <a:pPr>
-              <a:spcBef>
-                <a:spcPts val="1200"/>
-              </a:spcBef>
-            </a:pPr>
-            <a:r>
-              <a:rPr sz="1500" b="1">
-                <a:solidFill>
-                  <a:srgbClr val="FFFFFF"/>
-                </a:solidFill>
-              </a:rPr>
-              <a:t>1. Fixed Carbon = 100 - (Moisture + VM + Ash)
-2. Fuel Ratio = Fixed Carbon / VM</a:t>
-            </a:r>
-          </a:p>
-          <a:p>
-            <a:pPr>
-              <a:spcBef>
-                <a:spcPts val="1200"/>
-              </a:spcBef>
-            </a:pPr>
-            <a:r>
-              <a:rPr sz="1300" b="0">
-                <a:solidFill>
-                  <a:srgbClr val="FFFFFF"/>
-                </a:solidFill>
-              </a:rPr>
-              <a:t>
-Why this helped:
-• Keeps models simpler and faster
-• Lets shallow trees reach lower errors
-• Directly reflects real coal combustion chemistry</a:t>
-            </a:r>
-          </a:p>
-        </p:txBody>
-      </p:sp>
-    </p:spTree>
-  </p:cSld>
-  <p:clrMapOvr>
-    <a:masterClrMapping/>
-  </p:clrMapOvr>
-</p:sld>
-</file>
-
-<file path=ppt/slides/slide5.xml><?xml version="1.0" encoding="utf-8"?>
 <p:sld xmlns:a="http://schemas.openxmlformats.org/drawingml/2006/main" xmlns:p="http://schemas.openxmlformats.org/presentationml/2006/main" xmlns:r="http://schemas.openxmlformats.org/officeDocument/2006/relationships">
   <p:cSld>
     <p:spTree>
@@ -6062,7 +4817,7 @@
 </p:sld>
 </file>
 
-<file path=ppt/slides/slide6.xml><?xml version="1.0" encoding="utf-8"?>
+<file path=ppt/slides/slide5.xml><?xml version="1.0" encoding="utf-8"?>
 <p:sld xmlns:a="http://schemas.openxmlformats.org/drawingml/2006/main" xmlns:p="http://schemas.openxmlformats.org/presentationml/2006/main" xmlns:r="http://schemas.openxmlformats.org/officeDocument/2006/relationships">
   <p:cSld>
     <p:spTree>
@@ -6205,6 +4960,454 @@
           </a:prstGeom>
         </p:spPr>
       </p:pic>
+    </p:spTree>
+  </p:cSld>
+  <p:clrMapOvr>
+    <a:masterClrMapping/>
+  </p:clrMapOvr>
+</p:sld>
+</file>
+
+<file path=ppt/slides/slide6.xml><?xml version="1.0" encoding="utf-8"?>
+<p:sld xmlns:a="http://schemas.openxmlformats.org/drawingml/2006/main" xmlns:p="http://schemas.openxmlformats.org/presentationml/2006/main" xmlns:r="http://schemas.openxmlformats.org/officeDocument/2006/relationships">
+  <p:cSld>
+    <p:spTree>
+      <p:nvGrpSpPr>
+        <p:cNvPr id="1" name=""/>
+        <p:cNvGrpSpPr/>
+        <p:nvPr/>
+      </p:nvGrpSpPr>
+      <p:grpSpPr/>
+      <p:sp>
+        <p:nvSpPr>
+          <p:cNvPr id="2" name="Rectangle 1"/>
+          <p:cNvSpPr/>
+          <p:nvPr/>
+        </p:nvSpPr>
+        <p:spPr>
+          <a:xfrm>
+            <a:off x="0" y="0"/>
+            <a:ext cx="12191695" cy="6858000"/>
+          </a:xfrm>
+          <a:prstGeom prst="rect">
+            <a:avLst/>
+          </a:prstGeom>
+          <a:solidFill>
+            <a:srgbClr val="0F172A"/>
+          </a:solidFill>
+          <a:ln>
+            <a:noFill/>
+          </a:ln>
+        </p:spPr>
+        <p:style>
+          <a:lnRef idx="1">
+            <a:schemeClr val="accent1"/>
+          </a:lnRef>
+          <a:fillRef idx="3">
+            <a:schemeClr val="accent1"/>
+          </a:fillRef>
+          <a:effectRef idx="2">
+            <a:schemeClr val="accent1"/>
+          </a:effectRef>
+          <a:fontRef idx="minor">
+            <a:schemeClr val="lt1"/>
+          </a:fontRef>
+        </p:style>
+        <p:txBody>
+          <a:bodyPr rtlCol="0" anchor="ctr"/>
+          <a:lstStyle/>
+          <a:p>
+            <a:pPr algn="ctr"/>
+          </a:p>
+        </p:txBody>
+      </p:sp>
+      <p:sp>
+        <p:nvSpPr>
+          <p:cNvPr id="3" name="TextBox 2"/>
+          <p:cNvSpPr txBox="1"/>
+          <p:nvPr/>
+        </p:nvSpPr>
+        <p:spPr>
+          <a:xfrm>
+            <a:off x="731520" y="365760"/>
+            <a:ext cx="10698480" cy="365760"/>
+          </a:xfrm>
+          <a:prstGeom prst="rect">
+            <a:avLst/>
+          </a:prstGeom>
+          <a:noFill/>
+        </p:spPr>
+        <p:txBody>
+          <a:bodyPr wrap="none">
+            <a:spAutoFit/>
+          </a:bodyPr>
+          <a:lstStyle/>
+          <a:p>
+            <a:r>
+              <a:rPr sz="1100" b="1">
+                <a:solidFill>
+                  <a:srgbClr val="38BDF8"/>
+                </a:solidFill>
+              </a:rPr>
+              <a:t>MODEL TUNING</a:t>
+            </a:r>
+          </a:p>
+        </p:txBody>
+      </p:sp>
+      <p:sp>
+        <p:nvSpPr>
+          <p:cNvPr id="4" name="TextBox 3"/>
+          <p:cNvSpPr txBox="1"/>
+          <p:nvPr/>
+        </p:nvSpPr>
+        <p:spPr>
+          <a:xfrm>
+            <a:off x="731520" y="640080"/>
+            <a:ext cx="10698480" cy="731520"/>
+          </a:xfrm>
+          <a:prstGeom prst="rect">
+            <a:avLst/>
+          </a:prstGeom>
+          <a:noFill/>
+        </p:spPr>
+        <p:txBody>
+          <a:bodyPr wrap="none">
+            <a:spAutoFit/>
+          </a:bodyPr>
+          <a:lstStyle/>
+          <a:p>
+            <a:r>
+              <a:rPr sz="2400" b="1">
+                <a:solidFill>
+                  <a:srgbClr val="FFFFFF"/>
+                </a:solidFill>
+              </a:rPr>
+              <a:t>Tuning the Models (Finding the Best Parameters)</a:t>
+            </a:r>
+          </a:p>
+        </p:txBody>
+      </p:sp>
+      <p:sp>
+        <p:nvSpPr>
+          <p:cNvPr id="5" name="TextBox 4"/>
+          <p:cNvSpPr txBox="1"/>
+          <p:nvPr/>
+        </p:nvSpPr>
+        <p:spPr>
+          <a:xfrm>
+            <a:off x="731520" y="1645920"/>
+            <a:ext cx="5303520" cy="4572000"/>
+          </a:xfrm>
+          <a:prstGeom prst="rect">
+            <a:avLst/>
+          </a:prstGeom>
+          <a:noFill/>
+        </p:spPr>
+        <p:txBody>
+          <a:bodyPr wrap="square">
+            <a:spAutoFit/>
+          </a:bodyPr>
+          <a:lstStyle/>
+          <a:p>
+            <a:r>
+              <a:rPr sz="1800" b="1">
+                <a:solidFill>
+                  <a:srgbClr val="38BDF8"/>
+                </a:solidFill>
+              </a:rPr>
+              <a:t>How We Tuned the Parameters:</a:t>
+            </a:r>
+          </a:p>
+          <a:p>
+            <a:pPr>
+              <a:spcBef>
+                <a:spcPts val="1000"/>
+              </a:spcBef>
+            </a:pPr>
+            <a:r>
+              <a:rPr sz="1300" b="0">
+                <a:solidFill>
+                  <a:srgbClr val="FFFFFF"/>
+                </a:solidFill>
+              </a:rPr>
+              <a:t>• Instead of guessing numbers, we used an automated tuning tool called Optuna.</a:t>
+            </a:r>
+          </a:p>
+          <a:p>
+            <a:pPr>
+              <a:spcBef>
+                <a:spcPts val="1000"/>
+              </a:spcBef>
+            </a:pPr>
+            <a:r>
+              <a:rPr sz="1300" b="0">
+                <a:solidFill>
+                  <a:srgbClr val="FFFFFF"/>
+                </a:solidFill>
+              </a:rPr>
+              <a:t>• Optuna tests different combinations of tree depths, number of trees, and learning rates across 5 cross-validation folds.</a:t>
+            </a:r>
+          </a:p>
+          <a:p>
+            <a:pPr>
+              <a:spcBef>
+                <a:spcPts val="1000"/>
+              </a:spcBef>
+            </a:pPr>
+            <a:r>
+              <a:rPr sz="1300" b="0">
+                <a:solidFill>
+                  <a:srgbClr val="FFFFFF"/>
+                </a:solidFill>
+              </a:rPr>
+              <a:t>• It focuses on parameter values that consistently reduce prediction error.</a:t>
+            </a:r>
+          </a:p>
+          <a:p>
+            <a:pPr>
+              <a:spcBef>
+                <a:spcPts val="1000"/>
+              </a:spcBef>
+            </a:pPr>
+            <a:r>
+              <a:rPr sz="1300" b="0">
+                <a:solidFill>
+                  <a:srgbClr val="FFFFFF"/>
+                </a:solidFill>
+              </a:rPr>
+              <a:t>• For XGBoost, it selected a tree depth of 4 (shallow trees). This prevents the model from memorizing random lab noise and helps it generalize to new samples.</a:t>
+            </a:r>
+          </a:p>
+        </p:txBody>
+      </p:sp>
+      <p:sp>
+        <p:nvSpPr>
+          <p:cNvPr id="6" name="Rounded Rectangle 5"/>
+          <p:cNvSpPr/>
+          <p:nvPr/>
+        </p:nvSpPr>
+        <p:spPr>
+          <a:xfrm>
+            <a:off x="6309360" y="1645920"/>
+            <a:ext cx="5120640" cy="4572000"/>
+          </a:xfrm>
+          <a:prstGeom prst="roundRect">
+            <a:avLst/>
+          </a:prstGeom>
+          <a:solidFill>
+            <a:srgbClr val="1E293B"/>
+          </a:solidFill>
+          <a:ln w="19050">
+            <a:solidFill>
+              <a:srgbClr val="34D399"/>
+            </a:solidFill>
+          </a:ln>
+        </p:spPr>
+        <p:style>
+          <a:lnRef idx="1">
+            <a:schemeClr val="accent1"/>
+          </a:lnRef>
+          <a:fillRef idx="3">
+            <a:schemeClr val="accent1"/>
+          </a:fillRef>
+          <a:effectRef idx="2">
+            <a:schemeClr val="accent1"/>
+          </a:effectRef>
+          <a:fontRef idx="minor">
+            <a:schemeClr val="lt1"/>
+          </a:fontRef>
+        </p:style>
+        <p:txBody>
+          <a:bodyPr rtlCol="0" anchor="ctr"/>
+          <a:lstStyle/>
+          <a:p>
+            <a:pPr algn="ctr"/>
+          </a:p>
+        </p:txBody>
+      </p:sp>
+      <p:sp>
+        <p:nvSpPr>
+          <p:cNvPr id="7" name="TextBox 6"/>
+          <p:cNvSpPr txBox="1"/>
+          <p:nvPr/>
+        </p:nvSpPr>
+        <p:spPr>
+          <a:xfrm>
+            <a:off x="6492240" y="1783080"/>
+            <a:ext cx="4754880" cy="4297680"/>
+          </a:xfrm>
+          <a:prstGeom prst="rect">
+            <a:avLst/>
+          </a:prstGeom>
+          <a:noFill/>
+        </p:spPr>
+        <p:txBody>
+          <a:bodyPr wrap="square">
+            <a:spAutoFit/>
+          </a:bodyPr>
+          <a:lstStyle/>
+          <a:p>
+            <a:r>
+              <a:rPr sz="1600" b="1">
+                <a:solidFill>
+                  <a:srgbClr val="34D399"/>
+                </a:solidFill>
+              </a:rPr>
+              <a:t>Selected Settings:</a:t>
+            </a:r>
+          </a:p>
+          <a:p>
+            <a:pPr>
+              <a:spcBef>
+                <a:spcPts val="800"/>
+              </a:spcBef>
+            </a:pPr>
+            <a:r>
+              <a:rPr sz="1100" b="1">
+                <a:solidFill>
+                  <a:srgbClr val="38BDF8"/>
+                </a:solidFill>
+              </a:rPr>
+              <a:t>XGBoost:</a:t>
+            </a:r>
+          </a:p>
+          <a:p>
+            <a:pPr>
+              <a:spcBef>
+                <a:spcPts val="200"/>
+              </a:spcBef>
+            </a:pPr>
+            <a:r>
+              <a:rPr sz="1100" b="0">
+                <a:solidFill>
+                  <a:srgbClr val="FFFFFF"/>
+                </a:solidFill>
+              </a:rPr>
+              <a:t>• 300 trees | Max depth: 4 (prevents overfitting)</a:t>
+            </a:r>
+          </a:p>
+          <a:p>
+            <a:pPr>
+              <a:spcBef>
+                <a:spcPts val="200"/>
+              </a:spcBef>
+            </a:pPr>
+            <a:r>
+              <a:rPr sz="1100" b="0">
+                <a:solidFill>
+                  <a:srgbClr val="FFFFFF"/>
+                </a:solidFill>
+              </a:rPr>
+              <a:t>• Learning rate: 0.025</a:t>
+            </a:r>
+          </a:p>
+          <a:p>
+            <a:pPr>
+              <a:spcBef>
+                <a:spcPts val="800"/>
+              </a:spcBef>
+            </a:pPr>
+            <a:r>
+              <a:rPr sz="1100" b="1">
+                <a:solidFill>
+                  <a:srgbClr val="38BDF8"/>
+                </a:solidFill>
+              </a:rPr>
+              <a:t>Random Forest:</a:t>
+            </a:r>
+          </a:p>
+          <a:p>
+            <a:pPr>
+              <a:spcBef>
+                <a:spcPts val="200"/>
+              </a:spcBef>
+            </a:pPr>
+            <a:r>
+              <a:rPr sz="1100" b="0">
+                <a:solidFill>
+                  <a:srgbClr val="FFFFFF"/>
+                </a:solidFill>
+              </a:rPr>
+              <a:t>• 200 trees | Max depth: 15</a:t>
+            </a:r>
+          </a:p>
+          <a:p>
+            <a:pPr>
+              <a:spcBef>
+                <a:spcPts val="200"/>
+              </a:spcBef>
+            </a:pPr>
+            <a:r>
+              <a:rPr sz="1100" b="0">
+                <a:solidFill>
+                  <a:srgbClr val="FFFFFF"/>
+                </a:solidFill>
+              </a:rPr>
+              <a:t>• Min samples per leaf: 4</a:t>
+            </a:r>
+          </a:p>
+          <a:p>
+            <a:pPr>
+              <a:spcBef>
+                <a:spcPts val="800"/>
+              </a:spcBef>
+            </a:pPr>
+            <a:r>
+              <a:rPr sz="1100" b="1">
+                <a:solidFill>
+                  <a:srgbClr val="38BDF8"/>
+                </a:solidFill>
+              </a:rPr>
+              <a:t>Support Vector Machine (SVR):</a:t>
+            </a:r>
+          </a:p>
+          <a:p>
+            <a:pPr>
+              <a:spcBef>
+                <a:spcPts val="200"/>
+              </a:spcBef>
+            </a:pPr>
+            <a:r>
+              <a:rPr sz="1100" b="0">
+                <a:solidFill>
+                  <a:srgbClr val="FFFFFF"/>
+                </a:solidFill>
+              </a:rPr>
+              <a:t>• Normalized inputs &amp; target for numerical stability</a:t>
+            </a:r>
+          </a:p>
+          <a:p>
+            <a:pPr>
+              <a:spcBef>
+                <a:spcPts val="800"/>
+              </a:spcBef>
+            </a:pPr>
+            <a:r>
+              <a:rPr sz="1100" b="1">
+                <a:solidFill>
+                  <a:srgbClr val="38BDF8"/>
+                </a:solidFill>
+              </a:rPr>
+              <a:t>Final Blending Model (Ridge):</a:t>
+            </a:r>
+          </a:p>
+          <a:p>
+            <a:pPr>
+              <a:spcBef>
+                <a:spcPts val="200"/>
+              </a:spcBef>
+            </a:pPr>
+            <a:r>
+              <a:rPr sz="1100" b="0">
+                <a:solidFill>
+                  <a:srgbClr val="FFFFFF"/>
+                </a:solidFill>
+              </a:rPr>
+              <a:t>• Automatically assigns optimal weights to each model</a:t>
+            </a:r>
+          </a:p>
+        </p:txBody>
+      </p:sp>
     </p:spTree>
   </p:cSld>
   <p:clrMapOvr>
@@ -6294,7 +5497,7 @@
                   <a:srgbClr val="38BDF8"/>
                 </a:solidFill>
               </a:rPr>
-              <a:t>MODEL TUNING</a:t>
+              <a:t>COAL RANK</a:t>
             </a:r>
           </a:p>
         </p:txBody>
@@ -6327,7 +5530,7 @@
                   <a:srgbClr val="FFFFFF"/>
                 </a:solidFill>
               </a:rPr>
-              <a:t>Tuning the Models (Finding the Best Parameters)</a:t>
+              <a:t>Specialized Model for Bituminous Coal</a:t>
             </a:r>
           </a:p>
         </p:txBody>
@@ -6357,10 +5560,10 @@
             <a:r>
               <a:rPr sz="1800" b="1">
                 <a:solidFill>
-                  <a:srgbClr val="38BDF8"/>
-                </a:solidFill>
-              </a:rPr>
-              <a:t>How We Tuned the Parameters:</a:t>
+                  <a:srgbClr val="34D399"/>
+                </a:solidFill>
+              </a:rPr>
+              <a:t>Why Train a Separate Model?</a:t>
             </a:r>
           </a:p>
           <a:p>
@@ -6375,7 +5578,7 @@
                   <a:srgbClr val="FFFFFF"/>
                 </a:solidFill>
               </a:rPr>
-              <a:t>• Instead of guessing numbers, we used an automated tuning tool called Optuna.</a:t>
+              <a:t>• Different types of coal burn differently. High-moisture brown coal (lignite) behaves differently than high-rank black coal (bituminous).</a:t>
             </a:r>
           </a:p>
           <a:p>
@@ -6390,7 +5593,7 @@
                   <a:srgbClr val="FFFFFF"/>
                 </a:solidFill>
               </a:rPr>
-              <a:t>• Optuna tests different combinations of tree depths, number of trees, and learning rates across 5 cross-validation folds.</a:t>
+              <a:t>• We filtered 4,494 samples of Bituminous coal using official ASTM D388 laboratory standards.</a:t>
             </a:r>
           </a:p>
           <a:p>
@@ -6405,7 +5608,7 @@
                   <a:srgbClr val="FFFFFF"/>
                 </a:solidFill>
               </a:rPr>
-              <a:t>• It focuses on parameter values that consistently reduce prediction error.</a:t>
+              <a:t>• Training a specialized model on just this group produced significantly higher accuracy:</a:t>
             </a:r>
           </a:p>
           <a:p>
@@ -6420,115 +5623,37 @@
                   <a:srgbClr val="FFFFFF"/>
                 </a:solidFill>
               </a:rPr>
-              <a:t>• For XGBoost, it selected a tree depth of 4 (shallow trees). This prevents the model from memorizing random lab noise and helps it generalize to new samples.</a:t>
-            </a:r>
-          </a:p>
-        </p:txBody>
-      </p:sp>
-      <p:sp>
-        <p:nvSpPr>
-          <p:cNvPr id="6" name="Rounded Rectangle 5"/>
-          <p:cNvSpPr/>
+              <a:t>• • Error dropped from 150 to 134 Kcal/kg
+• Average absolute error dropped below 100 Kcal/kg (96 Kcal/kg)
+• Error rate reached 1.91%</a:t>
+            </a:r>
+          </a:p>
+        </p:txBody>
+      </p:sp>
+      <p:pic>
+        <p:nvPicPr>
+          <p:cNvPr id="6" name="Picture 5" descr="actual_vs_predicted_bituminous.png"/>
+          <p:cNvPicPr>
+            <a:picLocks noChangeAspect="1"/>
+          </p:cNvPicPr>
           <p:nvPr/>
-        </p:nvSpPr>
-        <p:spPr>
-          <a:xfrm>
-            <a:off x="6309360" y="1645920"/>
-            <a:ext cx="5120640" cy="4389120"/>
-          </a:xfrm>
-          <a:prstGeom prst="roundRect">
-            <a:avLst/>
-          </a:prstGeom>
-          <a:solidFill>
-            <a:srgbClr val="1E293B"/>
-          </a:solidFill>
-          <a:ln w="19050">
-            <a:solidFill>
-              <a:srgbClr val="34D399"/>
-            </a:solidFill>
-          </a:ln>
-        </p:spPr>
-        <p:style>
-          <a:lnRef idx="1">
-            <a:schemeClr val="accent1"/>
-          </a:lnRef>
-          <a:fillRef idx="3">
-            <a:schemeClr val="accent1"/>
-          </a:fillRef>
-          <a:effectRef idx="2">
-            <a:schemeClr val="accent1"/>
-          </a:effectRef>
-          <a:fontRef idx="minor">
-            <a:schemeClr val="lt1"/>
-          </a:fontRef>
-        </p:style>
-        <p:txBody>
-          <a:bodyPr rtlCol="0" anchor="ctr"/>
-          <a:lstStyle/>
-          <a:p>
-            <a:pPr algn="ctr"/>
-          </a:p>
-        </p:txBody>
-      </p:sp>
-      <p:sp>
-        <p:nvSpPr>
-          <p:cNvPr id="7" name="TextBox 6"/>
-          <p:cNvSpPr txBox="1"/>
-          <p:nvPr/>
-        </p:nvSpPr>
-        <p:spPr>
-          <a:xfrm>
-            <a:off x="6492240" y="1828800"/>
-            <a:ext cx="4754880" cy="4023360"/>
+        </p:nvPicPr>
+        <p:blipFill>
+          <a:blip r:embed="rId2"/>
+          <a:stretch>
+            <a:fillRect/>
+          </a:stretch>
+        </p:blipFill>
+        <p:spPr>
+          <a:xfrm>
+            <a:off x="6400800" y="1645920"/>
+            <a:ext cx="5029200" cy="3771900"/>
           </a:xfrm>
           <a:prstGeom prst="rect">
             <a:avLst/>
           </a:prstGeom>
-          <a:noFill/>
-        </p:spPr>
-        <p:txBody>
-          <a:bodyPr wrap="square">
-            <a:spAutoFit/>
-          </a:bodyPr>
-          <a:lstStyle/>
-          <a:p>
-            <a:r>
-              <a:rPr sz="1600" b="1">
-                <a:solidFill>
-                  <a:srgbClr val="34D399"/>
-                </a:solidFill>
-              </a:rPr>
-              <a:t>Selected Settings:</a:t>
-            </a:r>
-          </a:p>
-          <a:p>
-            <a:pPr>
-              <a:spcBef>
-                <a:spcPts val="1000"/>
-              </a:spcBef>
-            </a:pPr>
-            <a:r>
-              <a:rPr sz="1150" b="0">
-                <a:solidFill>
-                  <a:srgbClr val="FFFFFF"/>
-                </a:solidFill>
-              </a:rPr>
-              <a:t>XGBoost:
-• Number of trees: 300
-• Maximum depth: 4 (shallow trees prevent overfitting)
-• Learning rate: 0.025
-Random Forest:
-• Number of trees: 200
-• Maximum depth: 15
-• Min samples per leaf: 4
-Support Vector Machine:
-• Uses normalized data so large GCV numbers don't break it
-Final Blending Model:
-• Ridge Regression assigning weights to each model</a:t>
-            </a:r>
-          </a:p>
-        </p:txBody>
-      </p:sp>
+        </p:spPr>
+      </p:pic>
     </p:spTree>
   </p:cSld>
   <p:clrMapOvr>
@@ -6618,7 +5743,7 @@
                   <a:srgbClr val="38BDF8"/>
                 </a:solidFill>
               </a:rPr>
-              <a:t>COAL RANK</a:t>
+              <a:t>EXPLAINABILITY</a:t>
             </a:r>
           </a:p>
         </p:txBody>
@@ -6651,7 +5776,7 @@
                   <a:srgbClr val="FFFFFF"/>
                 </a:solidFill>
               </a:rPr>
-              <a:t>Specialized Model for Bituminous Coal</a:t>
+              <a:t>Explaining Predictions (No Black Box)</a:t>
             </a:r>
           </a:p>
         </p:txBody>
@@ -6681,79 +5806,80 @@
             <a:r>
               <a:rPr sz="1800" b="1">
                 <a:solidFill>
-                  <a:srgbClr val="34D399"/>
-                </a:solidFill>
-              </a:rPr>
-              <a:t>Why Train a Separate Model?</a:t>
+                  <a:srgbClr val="38BDF8"/>
+                </a:solidFill>
+              </a:rPr>
+              <a:t>Why Does the Model Guess What It Does?</a:t>
             </a:r>
           </a:p>
           <a:p>
             <a:pPr>
               <a:spcBef>
-                <a:spcPts val="1000"/>
+                <a:spcPts val="800"/>
               </a:spcBef>
             </a:pPr>
             <a:r>
-              <a:rPr sz="1300" b="0">
+              <a:rPr sz="1250" b="0">
                 <a:solidFill>
                   <a:srgbClr val="FFFFFF"/>
                 </a:solidFill>
               </a:rPr>
-              <a:t>• Different types of coal burn differently. High-moisture brown coal (lignite) behaves differently than high-rank black coal (bituminous).</a:t>
+              <a:t>• In industry, engineers need to understand why a model makes a prediction rather than just trusting a black-box number.</a:t>
             </a:r>
           </a:p>
           <a:p>
             <a:pPr>
               <a:spcBef>
-                <a:spcPts val="1000"/>
+                <a:spcPts val="800"/>
               </a:spcBef>
             </a:pPr>
             <a:r>
-              <a:rPr sz="1300" b="0">
+              <a:rPr sz="1250" b="0">
                 <a:solidFill>
                   <a:srgbClr val="FFFFFF"/>
                 </a:solidFill>
               </a:rPr>
-              <a:t>• We filtered 4,494 samples of Bituminous coal using official ASTM D388 laboratory standards.</a:t>
+              <a:t>• We integrated SHAP, a method that breaks down how much each chemical feature contributed to the final score.</a:t>
             </a:r>
           </a:p>
           <a:p>
             <a:pPr>
               <a:spcBef>
-                <a:spcPts val="1000"/>
+                <a:spcPts val="800"/>
               </a:spcBef>
             </a:pPr>
             <a:r>
-              <a:rPr sz="1300" b="0">
+              <a:rPr sz="1250" b="0">
                 <a:solidFill>
                   <a:srgbClr val="FFFFFF"/>
                 </a:solidFill>
               </a:rPr>
-              <a:t>• Training a specialized model on just this group produced significantly higher accuracy:</a:t>
+              <a:t>• The model's reasoning matches real chemistry:
+• Moisture pulls energy down (it takes heat to boil water)
+• Ash pulls energy down (rock/dirt does not burn)
+• Carbon and Fuel Ratio push energy up (actual fuel)</a:t>
             </a:r>
           </a:p>
           <a:p>
             <a:pPr>
               <a:spcBef>
-                <a:spcPts val="1000"/>
+                <a:spcPts val="800"/>
               </a:spcBef>
             </a:pPr>
             <a:r>
-              <a:rPr sz="1300" b="0">
+              <a:rPr sz="1250" b="0">
                 <a:solidFill>
                   <a:srgbClr val="FFFFFF"/>
                 </a:solidFill>
               </a:rPr>
-              <a:t>• • Error dropped from 150 to 134 Kcal/kg
-• Average absolute error dropped below 100 Kcal/kg (96 Kcal/kg)
-• Error rate reached 1.91%</a:t>
+              <a:t>• The graph on the right shows a sample prediction and how each feature pushed the value up (red) or down (blue).</a:t>
             </a:r>
           </a:p>
         </p:txBody>
       </p:sp>
       <p:pic>
         <p:nvPicPr>
-          <p:cNvPr id="6" name="Picture 5" descr="actual_vs_predicted_bituminous.png"/>
+          <p:cNvPr id="6" name="Picture 5" descr="shap_waterfall.png"/>
           <p:cNvPicPr>
             <a:picLocks noChangeAspect="1"/>
           </p:cNvPicPr>
@@ -6768,7 +5894,7 @@
         <p:spPr>
           <a:xfrm>
             <a:off x="6400800" y="1645920"/>
-            <a:ext cx="5029200" cy="3771900"/>
+            <a:ext cx="5029200" cy="2514600"/>
           </a:xfrm>
           <a:prstGeom prst="rect">
             <a:avLst/>
@@ -6864,7 +5990,7 @@
                   <a:srgbClr val="38BDF8"/>
                 </a:solidFill>
               </a:rPr>
-              <a:t>EXPLAINABILITY</a:t>
+              <a:t>CONCLUSION</a:t>
             </a:r>
           </a:p>
         </p:txBody>
@@ -6897,21 +6023,66 @@
                   <a:srgbClr val="FFFFFF"/>
                 </a:solidFill>
               </a:rPr>
-              <a:t>Explaining Predictions (No Black Box)</a:t>
-            </a:r>
-          </a:p>
-        </p:txBody>
-      </p:sp>
-      <p:sp>
-        <p:nvSpPr>
-          <p:cNvPr id="5" name="TextBox 4"/>
+              <a:t>Summary of Key Results</a:t>
+            </a:r>
+          </a:p>
+        </p:txBody>
+      </p:sp>
+      <p:sp>
+        <p:nvSpPr>
+          <p:cNvPr id="5" name="Rounded Rectangle 4"/>
+          <p:cNvSpPr/>
+          <p:nvPr/>
+        </p:nvSpPr>
+        <p:spPr>
+          <a:xfrm>
+            <a:off x="2011680" y="1645920"/>
+            <a:ext cx="8165592" cy="4389120"/>
+          </a:xfrm>
+          <a:prstGeom prst="roundRect">
+            <a:avLst/>
+          </a:prstGeom>
+          <a:solidFill>
+            <a:srgbClr val="1E293B"/>
+          </a:solidFill>
+          <a:ln w="25400">
+            <a:solidFill>
+              <a:srgbClr val="34D399"/>
+            </a:solidFill>
+          </a:ln>
+        </p:spPr>
+        <p:style>
+          <a:lnRef idx="1">
+            <a:schemeClr val="accent1"/>
+          </a:lnRef>
+          <a:fillRef idx="3">
+            <a:schemeClr val="accent1"/>
+          </a:fillRef>
+          <a:effectRef idx="2">
+            <a:schemeClr val="accent1"/>
+          </a:effectRef>
+          <a:fontRef idx="minor">
+            <a:schemeClr val="lt1"/>
+          </a:fontRef>
+        </p:style>
+        <p:txBody>
+          <a:bodyPr rtlCol="0" anchor="ctr"/>
+          <a:lstStyle/>
+          <a:p>
+            <a:pPr algn="ctr"/>
+          </a:p>
+        </p:txBody>
+      </p:sp>
+      <p:sp>
+        <p:nvSpPr>
+          <p:cNvPr id="6" name="TextBox 5"/>
           <p:cNvSpPr txBox="1"/>
           <p:nvPr/>
         </p:nvSpPr>
         <p:spPr>
           <a:xfrm>
-            <a:off x="731520" y="1645920"/>
-            <a:ext cx="5303520" cy="4389120"/>
+            <a:off x="2286000" y="1828800"/>
+            <a:ext cx="7616952" cy="4023360"/>
           </a:xfrm>
           <a:prstGeom prst="rect">
             <a:avLst/>
@@ -6925,103 +6096,166 @@
           <a:lstStyle/>
           <a:p>
             <a:r>
-              <a:rPr sz="1800" b="1">
-                <a:solidFill>
-                  <a:srgbClr val="38BDF8"/>
-                </a:solidFill>
-              </a:rPr>
-              <a:t>Why Does the Model Guess What It Does?</a:t>
+              <a:rPr sz="2000" b="1">
+                <a:solidFill>
+                  <a:srgbClr val="34D399"/>
+                </a:solidFill>
+              </a:rPr>
+              <a:t>Final Performance Across 5-Fold Cross Validation:</a:t>
             </a:r>
           </a:p>
           <a:p>
             <a:pPr>
               <a:spcBef>
-                <a:spcPts val="800"/>
+                <a:spcPts val="1400"/>
               </a:spcBef>
             </a:pPr>
             <a:r>
-              <a:rPr sz="1250" b="0">
-                <a:solidFill>
-                  <a:srgbClr val="FFFFFF"/>
-                </a:solidFill>
-              </a:rPr>
-              <a:t>• In industry, engineers need to understand why a model makes a prediction rather than just trusting a black-box number.</a:t>
+              <a:rPr sz="1350" b="1">
+                <a:solidFill>
+                  <a:srgbClr val="38BDF8"/>
+                </a:solidFill>
+              </a:rPr>
+              <a:t>Universal Model (All Coal Ranks):</a:t>
             </a:r>
           </a:p>
           <a:p>
             <a:pPr>
               <a:spcBef>
-                <a:spcPts val="800"/>
+                <a:spcPts val="400"/>
               </a:spcBef>
             </a:pPr>
             <a:r>
-              <a:rPr sz="1250" b="0">
+              <a:rPr sz="1350" b="0">
                 <a:solidFill>
                   <a:srgbClr val="FFFFFF"/>
                 </a:solidFill>
               </a:rPr>
-              <a:t>• We integrated SHAP, a method that breaks down how much each chemical feature contributed to the final score.</a:t>
+              <a:t>• Average Error (RMSE): 150.28 Kcal/kg  (Target was &lt;= 200 Kcal/kg)</a:t>
             </a:r>
           </a:p>
           <a:p>
             <a:pPr>
               <a:spcBef>
-                <a:spcPts val="800"/>
+                <a:spcPts val="400"/>
               </a:spcBef>
             </a:pPr>
             <a:r>
-              <a:rPr sz="1250" b="0">
+              <a:rPr sz="1350" b="0">
                 <a:solidFill>
                   <a:srgbClr val="FFFFFF"/>
                 </a:solidFill>
               </a:rPr>
-              <a:t>• The model's reasoning matches real chemistry:
-• Moisture pulls energy down (it takes heat to boil water)
-• Ash pulls energy down (rock/dirt does not burn)
-• Carbon and Fuel Ratio push energy up (actual fuel)</a:t>
+              <a:t>• Absolute Error (MAE): 105.97 Kcal/kg</a:t>
             </a:r>
           </a:p>
           <a:p>
             <a:pPr>
               <a:spcBef>
-                <a:spcPts val="800"/>
+                <a:spcPts val="400"/>
               </a:spcBef>
             </a:pPr>
             <a:r>
-              <a:rPr sz="1250" b="0">
+              <a:rPr sz="1350" b="0">
                 <a:solidFill>
                   <a:srgbClr val="FFFFFF"/>
                 </a:solidFill>
               </a:rPr>
-              <a:t>• The graph on the right shows a sample prediction and how each feature pushed the value up (red) or down (blue).</a:t>
-            </a:r>
-          </a:p>
-        </p:txBody>
-      </p:sp>
-      <p:pic>
-        <p:nvPicPr>
-          <p:cNvPr id="6" name="Picture 5" descr="shap_waterfall.png"/>
-          <p:cNvPicPr>
-            <a:picLocks noChangeAspect="1"/>
-          </p:cNvPicPr>
-          <p:nvPr/>
-        </p:nvPicPr>
-        <p:blipFill>
-          <a:blip r:embed="rId2"/>
-          <a:stretch>
-            <a:fillRect/>
-          </a:stretch>
-        </p:blipFill>
-        <p:spPr>
-          <a:xfrm>
-            <a:off x="6400800" y="1645920"/>
-            <a:ext cx="5029200" cy="2514600"/>
-          </a:xfrm>
-          <a:prstGeom prst="rect">
-            <a:avLst/>
-          </a:prstGeom>
-        </p:spPr>
-      </p:pic>
+              <a:t>• Error Percentage: 2.18%  (Industry target was &lt; 8.0%)</a:t>
+            </a:r>
+          </a:p>
+          <a:p>
+            <a:pPr>
+              <a:spcBef>
+                <a:spcPts val="400"/>
+              </a:spcBef>
+            </a:pPr>
+            <a:r>
+              <a:rPr sz="1350" b="0">
+                <a:solidFill>
+                  <a:srgbClr val="FFFFFF"/>
+                </a:solidFill>
+              </a:rPr>
+              <a:t>• Accuracy Score (R²): 0.96</a:t>
+            </a:r>
+          </a:p>
+          <a:p>
+            <a:pPr>
+              <a:spcBef>
+                <a:spcPts val="1600"/>
+              </a:spcBef>
+            </a:pPr>
+            <a:r>
+              <a:rPr sz="1350" b="1">
+                <a:solidFill>
+                  <a:srgbClr val="34D399"/>
+                </a:solidFill>
+              </a:rPr>
+              <a:t>Specialized Bituminous Coal Model:</a:t>
+            </a:r>
+          </a:p>
+          <a:p>
+            <a:pPr>
+              <a:spcBef>
+                <a:spcPts val="400"/>
+              </a:spcBef>
+            </a:pPr>
+            <a:r>
+              <a:rPr sz="1350" b="0">
+                <a:solidFill>
+                  <a:srgbClr val="FFFFFF"/>
+                </a:solidFill>
+              </a:rPr>
+              <a:t>• Average Error (RMSE): 134.18 Kcal/kg  (-16.10 Kcal/kg improvement)</a:t>
+            </a:r>
+          </a:p>
+          <a:p>
+            <a:pPr>
+              <a:spcBef>
+                <a:spcPts val="400"/>
+              </a:spcBef>
+            </a:pPr>
+            <a:r>
+              <a:rPr sz="1350" b="0">
+                <a:solidFill>
+                  <a:srgbClr val="FFFFFF"/>
+                </a:solidFill>
+              </a:rPr>
+              <a:t>• Absolute Error (MAE): 96.29 Kcal/kg  (Sub-100 error margin)</a:t>
+            </a:r>
+          </a:p>
+          <a:p>
+            <a:pPr>
+              <a:spcBef>
+                <a:spcPts val="400"/>
+              </a:spcBef>
+            </a:pPr>
+            <a:r>
+              <a:rPr sz="1350" b="0">
+                <a:solidFill>
+                  <a:srgbClr val="FFFFFF"/>
+                </a:solidFill>
+              </a:rPr>
+              <a:t>• Error Percentage: 1.91%  (Sub-2% error rate)</a:t>
+            </a:r>
+          </a:p>
+          <a:p>
+            <a:pPr>
+              <a:spcBef>
+                <a:spcPts val="400"/>
+              </a:spcBef>
+            </a:pPr>
+            <a:r>
+              <a:rPr sz="1350" b="0">
+                <a:solidFill>
+                  <a:srgbClr val="FFFFFF"/>
+                </a:solidFill>
+              </a:rPr>
+              <a:t>• Accuracy Score (R²): 0.95</a:t>
+            </a:r>
+          </a:p>
+        </p:txBody>
+      </p:sp>
     </p:spTree>
   </p:cSld>
   <p:clrMapOvr>

</xml_diff>

<commit_message>
Explicitly label CV Score on summary slide and benchmarking table
</commit_message>
<xml_diff>
--- a/Coal_GCV_Prediction_Presentation.pptx
+++ b/Coal_GCV_Prediction_Presentation.pptx
@@ -3258,7 +3258,7 @@
                   <a:srgbClr val="FFFFFF"/>
                 </a:solidFill>
               </a:rPr>
-              <a:t>• Tested on real geological coal data with sub-2% error rate
+              <a:t>• Tested on real geological coal data with sub-2% CV error score
 </a:t>
             </a:r>
             <a:r>
@@ -4251,7 +4251,7 @@
         </p:nvGraphicFramePr>
         <p:xfrm>
           <a:off x="731520" y="1645920"/>
-          <a:ext cx="5943600" cy="4114800"/>
+          <a:ext cx="6035040" cy="4114800"/>
         </p:xfrm>
         <a:graphic>
           <a:graphicData uri="http://schemas.openxmlformats.org/drawingml/2006/table">
@@ -4260,10 +4260,11 @@
                 <a:tableStyleId>{5C22544A-7EE6-4342-B048-85BDC9FD1C3A}</a:tableStyleId>
               </a:tblPr>
               <a:tblGrid>
-                <a:gridCol w="2377440"/>
-                <a:gridCol w="1188720"/>
-                <a:gridCol w="1188720"/>
-                <a:gridCol w="1188720"/>
+                <a:gridCol w="2011680"/>
+                <a:gridCol w="1097280"/>
+                <a:gridCol w="1005840"/>
+                <a:gridCol w="1005840"/>
+                <a:gridCol w="914400"/>
               </a:tblGrid>
               <a:tr h="685800">
                 <a:tc>
@@ -4298,7 +4299,7 @@
                             <a:srgbClr val="FFFFFF"/>
                           </a:solidFill>
                         </a:rPr>
-                        <a:t>Average Error (RMSE)</a:t>
+                        <a:t>RMSE</a:t>
                       </a:r>
                     </a:p>
                   </a:txBody>
@@ -4319,7 +4320,7 @@
                             <a:srgbClr val="FFFFFF"/>
                           </a:solidFill>
                         </a:rPr>
-                        <a:t>Absolute Error (MAE)</a:t>
+                        <a:t>MAE</a:t>
                       </a:r>
                     </a:p>
                   </a:txBody>
@@ -4340,7 +4341,28 @@
                             <a:srgbClr val="FFFFFF"/>
                           </a:solidFill>
                         </a:rPr>
-                        <a:t>Accuracy (R²)</a:t>
+                        <a:t>CV Score</a:t>
+                      </a:r>
+                    </a:p>
+                  </a:txBody>
+                  <a:tcPr>
+                    <a:solidFill>
+                      <a:srgbClr val="1E3A8A"/>
+                    </a:solidFill>
+                  </a:tcPr>
+                </a:tc>
+                <a:tc>
+                  <a:txBody>
+                    <a:bodyPr/>
+                    <a:lstStyle/>
+                    <a:p>
+                      <a:r>
+                        <a:rPr sz="1100" b="1">
+                          <a:solidFill>
+                            <a:srgbClr val="FFFFFF"/>
+                          </a:solidFill>
+                        </a:rPr>
+                        <a:t>R² Score</a:t>
                       </a:r>
                     </a:p>
                   </a:txBody>
@@ -4363,7 +4385,7 @@
                             <a:srgbClr val="FFFFFF"/>
                           </a:solidFill>
                         </a:rPr>
-                        <a:t>Support Vector Machine (SVR)</a:t>
+                        <a:t>Support Vector (SVR)</a:t>
                       </a:r>
                     </a:p>
                   </a:txBody>
@@ -4384,7 +4406,7 @@
                             <a:srgbClr val="FFFFFF"/>
                           </a:solidFill>
                         </a:rPr>
-                        <a:t>612.45 Kcal/kg</a:t>
+                        <a:t>612.45</a:t>
                       </a:r>
                     </a:p>
                   </a:txBody>
@@ -4406,6 +4428,27 @@
                           </a:solidFill>
                         </a:rPr>
                         <a:t>487.12</a:t>
+                      </a:r>
+                    </a:p>
+                  </a:txBody>
+                  <a:tcPr>
+                    <a:solidFill>
+                      <a:srgbClr val="1E293B"/>
+                    </a:solidFill>
+                  </a:tcPr>
+                </a:tc>
+                <a:tc>
+                  <a:txBody>
+                    <a:bodyPr/>
+                    <a:lstStyle/>
+                    <a:p>
+                      <a:r>
+                        <a:rPr sz="1100" b="0">
+                          <a:solidFill>
+                            <a:srgbClr val="FFFFFF"/>
+                          </a:solidFill>
+                        </a:rPr>
+                        <a:t>8.89%</a:t>
                       </a:r>
                     </a:p>
                   </a:txBody>
@@ -4470,7 +4513,7 @@
                             <a:srgbClr val="FFFFFF"/>
                           </a:solidFill>
                         </a:rPr>
-                        <a:t>217.30 Kcal/kg</a:t>
+                        <a:t>217.30</a:t>
                       </a:r>
                     </a:p>
                   </a:txBody>
@@ -4492,6 +4535,27 @@
                           </a:solidFill>
                         </a:rPr>
                         <a:t>148.80</a:t>
+                      </a:r>
+                    </a:p>
+                  </a:txBody>
+                  <a:tcPr>
+                    <a:solidFill>
+                      <a:srgbClr val="1E293B"/>
+                    </a:solidFill>
+                  </a:tcPr>
+                </a:tc>
+                <a:tc>
+                  <a:txBody>
+                    <a:bodyPr/>
+                    <a:lstStyle/>
+                    <a:p>
+                      <a:r>
+                        <a:rPr sz="1100" b="0">
+                          <a:solidFill>
+                            <a:srgbClr val="FFFFFF"/>
+                          </a:solidFill>
+                        </a:rPr>
+                        <a:t>3.15%</a:t>
                       </a:r>
                     </a:p>
                   </a:txBody>
@@ -4556,7 +4620,7 @@
                             <a:srgbClr val="FFFFFF"/>
                           </a:solidFill>
                         </a:rPr>
-                        <a:t>154.84 Kcal/kg</a:t>
+                        <a:t>154.84</a:t>
                       </a:r>
                     </a:p>
                   </a:txBody>
@@ -4578,6 +4642,27 @@
                           </a:solidFill>
                         </a:rPr>
                         <a:t>109.12</a:t>
+                      </a:r>
+                    </a:p>
+                  </a:txBody>
+                  <a:tcPr>
+                    <a:solidFill>
+                      <a:srgbClr val="1E293B"/>
+                    </a:solidFill>
+                  </a:tcPr>
+                </a:tc>
+                <a:tc>
+                  <a:txBody>
+                    <a:bodyPr/>
+                    <a:lstStyle/>
+                    <a:p>
+                      <a:r>
+                        <a:rPr sz="1100" b="0">
+                          <a:solidFill>
+                            <a:srgbClr val="FFFFFF"/>
+                          </a:solidFill>
+                        </a:rPr>
+                        <a:t>2.25%</a:t>
                       </a:r>
                     </a:p>
                   </a:txBody>
@@ -4642,7 +4727,7 @@
                             <a:srgbClr val="FFFFFF"/>
                           </a:solidFill>
                         </a:rPr>
-                        <a:t>152.14 Kcal/kg</a:t>
+                        <a:t>152.14</a:t>
                       </a:r>
                     </a:p>
                   </a:txBody>
@@ -4664,6 +4749,27 @@
                           </a:solidFill>
                         </a:rPr>
                         <a:t>107.45</a:t>
+                      </a:r>
+                    </a:p>
+                  </a:txBody>
+                  <a:tcPr>
+                    <a:solidFill>
+                      <a:srgbClr val="1E293B"/>
+                    </a:solidFill>
+                  </a:tcPr>
+                </a:tc>
+                <a:tc>
+                  <a:txBody>
+                    <a:bodyPr/>
+                    <a:lstStyle/>
+                    <a:p>
+                      <a:r>
+                        <a:rPr sz="1100" b="0">
+                          <a:solidFill>
+                            <a:srgbClr val="FFFFFF"/>
+                          </a:solidFill>
+                        </a:rPr>
+                        <a:t>2.21%</a:t>
                       </a:r>
                     </a:p>
                   </a:txBody>
@@ -4707,7 +4813,7 @@
                             <a:srgbClr val="FFFFFF"/>
                           </a:solidFill>
                         </a:rPr>
-                        <a:t>Combined Ensemble (Ours)</a:t>
+                        <a:t>Combined Ensemble</a:t>
                       </a:r>
                     </a:p>
                   </a:txBody>
@@ -4728,7 +4834,7 @@
                             <a:srgbClr val="FFFFFF"/>
                           </a:solidFill>
                         </a:rPr>
-                        <a:t>150.28 Kcal/kg</a:t>
+                        <a:t>150.28</a:t>
                       </a:r>
                     </a:p>
                   </a:txBody>
@@ -4750,6 +4856,27 @@
                           </a:solidFill>
                         </a:rPr>
                         <a:t>105.97</a:t>
+                      </a:r>
+                    </a:p>
+                  </a:txBody>
+                  <a:tcPr>
+                    <a:solidFill>
+                      <a:srgbClr val="064E3B"/>
+                    </a:solidFill>
+                  </a:tcPr>
+                </a:tc>
+                <a:tc>
+                  <a:txBody>
+                    <a:bodyPr/>
+                    <a:lstStyle/>
+                    <a:p>
+                      <a:r>
+                        <a:rPr sz="1100" b="1">
+                          <a:solidFill>
+                            <a:srgbClr val="FFFFFF"/>
+                          </a:solidFill>
+                        </a:rPr>
+                        <a:t>2.18%</a:t>
                       </a:r>
                     </a:p>
                   </a:txBody>
@@ -5625,7 +5752,7 @@
               </a:rPr>
               <a:t>• • Error dropped from 150 to 134 Kcal/kg
 • Average absolute error dropped below 100 Kcal/kg (96 Kcal/kg)
-• Error rate reached 1.91%</a:t>
+• CV Score reached an exceptional 1.91%</a:t>
             </a:r>
           </a:p>
         </p:txBody>
@@ -6156,12 +6283,12 @@
               </a:spcBef>
             </a:pPr>
             <a:r>
-              <a:rPr sz="1350" b="0">
-                <a:solidFill>
-                  <a:srgbClr val="FFFFFF"/>
-                </a:solidFill>
-              </a:rPr>
-              <a:t>• Error Percentage: 2.18%  (Industry target was &lt; 8.0%)</a:t>
+              <a:rPr sz="1350" b="1">
+                <a:solidFill>
+                  <a:srgbClr val="FB923C"/>
+                </a:solidFill>
+              </a:rPr>
+              <a:t>• CV Score (Coefficient of Variation): 2.18%  (Target was &lt; 8.0%)</a:t>
             </a:r>
           </a:p>
           <a:p>
@@ -6231,12 +6358,12 @@
               </a:spcBef>
             </a:pPr>
             <a:r>
-              <a:rPr sz="1350" b="0">
-                <a:solidFill>
-                  <a:srgbClr val="FFFFFF"/>
-                </a:solidFill>
-              </a:rPr>
-              <a:t>• Error Percentage: 1.91%  (Sub-2% error rate)</a:t>
+              <a:rPr sz="1350" b="1">
+                <a:solidFill>
+                  <a:srgbClr val="34D399"/>
+                </a:solidFill>
+              </a:rPr>
+              <a:t>• CV Score (Coefficient of Variation): 1.91%  (Sub-2% precision)</a:t>
             </a:r>
           </a:p>
           <a:p>

</xml_diff>